<commit_message>
updated session 01 slides
</commit_message>
<xml_diff>
--- a/Programming01/Session01/slides.pptx
+++ b/Programming01/Session01/slides.pptx
@@ -5,7 +5,7 @@
     <p:sldMasterId id="2147483648" r:id="rId1"/>
   </p:sldMasterIdLst>
   <p:notesMasterIdLst>
-    <p:notesMasterId r:id="rId19"/>
+    <p:notesMasterId r:id="rId12"/>
   </p:notesMasterIdLst>
   <p:sldIdLst>
     <p:sldId id="256" r:id="rId2"/>
@@ -18,13 +18,6 @@
     <p:sldId id="263" r:id="rId9"/>
     <p:sldId id="264" r:id="rId10"/>
     <p:sldId id="265" r:id="rId11"/>
-    <p:sldId id="266" r:id="rId12"/>
-    <p:sldId id="267" r:id="rId13"/>
-    <p:sldId id="268" r:id="rId14"/>
-    <p:sldId id="269" r:id="rId15"/>
-    <p:sldId id="270" r:id="rId16"/>
-    <p:sldId id="271" r:id="rId17"/>
-    <p:sldId id="272" r:id="rId18"/>
   </p:sldIdLst>
   <p:sldSz cx="9144000" cy="5143500" type="screen16x9"/>
   <p:notesSz cx="6858000" cy="9144000"/>
@@ -540,169 +533,17 @@
             </a:pPr>
             <a:r>
               <a:rPr/>
-              <a:t>Open on the concrete task, not on the tool. Let the room answer the question first (someone will say “open them one by one”, someone else will say “Excel”). Then show the two panels. The point is not that typing is faster (though it is). The point is the last line: after the clicking, nobody (including you) can say what was done. After the command, the answer and the method are the same object. Do not defend the terminal on aesthetics. Defend it on evidence.</a:t>
-            </a:r>
-          </a:p>
-        </p:txBody>
-      </p:sp>
-      <p:sp>
-        <p:nvSpPr>
-          <p:cNvPr id="4" name="Slide Number Placeholder 3"/>
-          <p:cNvSpPr>
-            <a:spLocks noGrp="1"/>
-          </p:cNvSpPr>
-          <p:nvPr>
-            <p:ph type="sldNum" sz="quarter" idx="10"/>
-          </p:nvPr>
-        </p:nvSpPr>
-        <p:spPr/>
-        <p:txBody>
-          <a:bodyPr/>
-          <a:lstStyle/>
-          <a:p>
-            <a:fld id="{18BDFEC3-8487-43E8-A154-7C12CBC1FFF2}" type="slidenum">
-              <a:rPr lang="en-US"/>
-              <a:t>3</a:t>
-            </a:fld>
-            <a:endParaRPr lang="en-US"/>
-          </a:p>
-        </p:txBody>
-      </p:sp>
-    </p:spTree>
-  </p:cSld>
-</p:notes>
-</file>
-
-<file path=ppt/notesSlides/notesSlide10.xml><?xml version="1.0" encoding="utf-8"?>
-<p:notes xmlns:a="http://schemas.openxmlformats.org/drawingml/2006/main" xmlns:r="http://schemas.openxmlformats.org/officeDocument/2006/relationships" xmlns:p="http://schemas.openxmlformats.org/presentationml/2006/main">
-  <p:cSld>
-    <p:spTree>
-      <p:nvGrpSpPr>
-        <p:cNvPr id="1" name=""/>
-        <p:cNvGrpSpPr/>
-        <p:nvPr/>
-      </p:nvGrpSpPr>
-      <p:grpSpPr>
-        <a:xfrm>
-          <a:off x="0" y="0"/>
-          <a:ext cx="0" cy="0"/>
-          <a:chOff x="0" y="0"/>
-          <a:chExt cx="0" cy="0"/>
-        </a:xfrm>
-      </p:grpSpPr>
-      <p:sp>
-        <p:nvSpPr>
-          <p:cNvPr id="2" name="Slide Image Placeholder 1"/>
-          <p:cNvSpPr>
-            <a:spLocks noGrp="1" noRot="1" noChangeAspect="1"/>
-          </p:cNvSpPr>
-          <p:nvPr>
-            <p:ph type="sldImg"/>
-          </p:nvPr>
-        </p:nvSpPr>
-        <p:spPr/>
-      </p:sp>
-      <p:sp>
-        <p:nvSpPr>
-          <p:cNvPr id="3" name="Notes Placeholder 2"/>
-          <p:cNvSpPr>
-            <a:spLocks noGrp="1"/>
-          </p:cNvSpPr>
-          <p:nvPr>
-            <p:ph type="body" idx="1"/>
-          </p:nvPr>
-        </p:nvSpPr>
-        <p:spPr/>
-        <p:txBody>
-          <a:bodyPr/>
-          <a:lstStyle/>
-          <a:p>
-            <a:pPr lvl="0" indent="0" marL="0">
-              <a:buNone/>
-            </a:pPr>
-            <a:r>
-              <a:rPr/>
-              <a:t>The demystifying slide. </a:t>
+              <a:t>Rows of machines, and not one keyboard, mouse or monitor in the room. This is the NASA Columbia supercomputer, but it is also every hospital server room, every cloud instance, and every compute cluster you will send a job to. Nobody walks in and clicks. You reach these machines over the network (</a:t>
             </a:r>
             <a:r>
               <a:rPr>
                 <a:latin typeface="Courier"/>
               </a:rPr>
-              <a:t>python3</a:t>
+              <a:t>ssh</a:t>
             </a:r>
             <a:r>
               <a:rPr/>
-              <a:t> is a file on disk that the shell finds and starts, exactly like </a:t>
-            </a:r>
-            <a:r>
-              <a:rPr>
-                <a:latin typeface="Courier"/>
-              </a:rPr>
-              <a:t>ls</a:t>
-            </a:r>
-            <a:r>
-              <a:rPr/>
-              <a:t>, and </a:t>
-            </a:r>
-            <a:r>
-              <a:rPr>
-                <a:latin typeface="Courier"/>
-              </a:rPr>
-              <a:t>which python3</a:t>
-            </a:r>
-            <a:r>
-              <a:rPr/>
-              <a:t> proves it. It reads a </a:t>
-            </a:r>
-            <a:r>
-              <a:rPr>
-                <a:latin typeface="Courier"/>
-              </a:rPr>
-              <a:t>.py</a:t>
-            </a:r>
-            <a:r>
-              <a:rPr/>
-              <a:t> file, or a </a:t>
-            </a:r>
-            <a:r>
-              <a:rPr>
-                <a:latin typeface="Courier"/>
-              </a:rPr>
-              <a:t>-c</a:t>
-            </a:r>
-            <a:r>
-              <a:rPr/>
-              <a:t> string, or waits for you to type (the REPL). Two directions to point out. The shell supplies the loop and the file list; Python supplies the computation. And Python can call back out with </a:t>
-            </a:r>
-            <a:r>
-              <a:rPr>
-                <a:latin typeface="Courier"/>
-              </a:rPr>
-              <a:t>subprocess</a:t>
-            </a:r>
-            <a:r>
-              <a:rPr/>
-              <a:t>, though if you find yourself doing that a lot, the job was probably a shell job. Mention the exit code: </a:t>
-            </a:r>
-            <a:r>
-              <a:rPr>
-                <a:latin typeface="Courier"/>
-              </a:rPr>
-              <a:t>python3 script.py &amp;&amp; echo ok</a:t>
-            </a:r>
-            <a:r>
-              <a:rPr/>
-              <a:t> only prints </a:t>
-            </a:r>
-            <a:r>
-              <a:rPr>
-                <a:latin typeface="Courier"/>
-              </a:rPr>
-              <a:t>ok</a:t>
-            </a:r>
-            <a:r>
-              <a:rPr/>
-              <a:t> if the script did not crash. That is how steps get chained.</a:t>
+              <a:t>), and what answers you is a text prompt. The graphical interface is the exception, available on your laptop and almost nowhere else. So the question is not whether the command line is pleasant. It is the only interface these machines have, and that is where the data and the computing power live. Ask the room: where do you think the imaging archive of a hospital actually sits?</a:t>
             </a:r>
           </a:p>
         </p:txBody>
@@ -724,415 +565,7 @@
           <a:p>
             <a:fld id="{18BDFEC3-8487-43E8-A154-7C12CBC1FFF2}" type="slidenum">
               <a:rPr lang="en-US"/>
-              <a:t>14</a:t>
-            </a:fld>
-            <a:endParaRPr lang="en-US"/>
-          </a:p>
-        </p:txBody>
-      </p:sp>
-    </p:spTree>
-  </p:cSld>
-</p:notes>
-</file>
-
-<file path=ppt/notesSlides/notesSlide11.xml><?xml version="1.0" encoding="utf-8"?>
-<p:notes xmlns:a="http://schemas.openxmlformats.org/drawingml/2006/main" xmlns:r="http://schemas.openxmlformats.org/officeDocument/2006/relationships" xmlns:p="http://schemas.openxmlformats.org/presentationml/2006/main">
-  <p:cSld>
-    <p:spTree>
-      <p:nvGrpSpPr>
-        <p:cNvPr id="1" name=""/>
-        <p:cNvGrpSpPr/>
-        <p:nvPr/>
-      </p:nvGrpSpPr>
-      <p:grpSpPr>
-        <a:xfrm>
-          <a:off x="0" y="0"/>
-          <a:ext cx="0" cy="0"/>
-          <a:chOff x="0" y="0"/>
-          <a:chExt cx="0" cy="0"/>
-        </a:xfrm>
-      </p:grpSpPr>
-      <p:sp>
-        <p:nvSpPr>
-          <p:cNvPr id="2" name="Slide Image Placeholder 1"/>
-          <p:cNvSpPr>
-            <a:spLocks noGrp="1" noRot="1" noChangeAspect="1"/>
-          </p:cNvSpPr>
-          <p:nvPr>
-            <p:ph type="sldImg"/>
-          </p:nvPr>
-        </p:nvSpPr>
-        <p:spPr/>
-      </p:sp>
-      <p:sp>
-        <p:nvSpPr>
-          <p:cNvPr id="3" name="Notes Placeholder 2"/>
-          <p:cNvSpPr>
-            <a:spLocks noGrp="1"/>
-          </p:cNvSpPr>
-          <p:nvPr>
-            <p:ph type="body" idx="1"/>
-          </p:nvPr>
-        </p:nvSpPr>
-        <p:spPr/>
-        <p:txBody>
-          <a:bodyPr/>
-          <a:lstStyle/>
-          <a:p>
-            <a:pPr lvl="0" indent="0" marL="0">
-              <a:buNone/>
-            </a:pPr>
-            <a:r>
-              <a:rPr/>
-              <a:t>The single most common source of “it works on my machine” in this field. A virtual environment is not magic: it is a folder (</a:t>
-            </a:r>
-            <a:r>
-              <a:rPr>
-                <a:latin typeface="Courier"/>
-              </a:rPr>
-              <a:t>.venv/</a:t>
-            </a:r>
-            <a:r>
-              <a:rPr/>
-              <a:t>) containing its own </a:t>
-            </a:r>
-            <a:r>
-              <a:rPr>
-                <a:latin typeface="Courier"/>
-              </a:rPr>
-              <a:t>python</a:t>
-            </a:r>
-            <a:r>
-              <a:rPr/>
-              <a:t> and its own </a:t>
-            </a:r>
-            <a:r>
-              <a:rPr>
-                <a:latin typeface="Courier"/>
-              </a:rPr>
-              <a:t>site-packages</a:t>
-            </a:r>
-            <a:r>
-              <a:rPr/>
-              <a:t>. “Activating” it just puts that folder first on </a:t>
-            </a:r>
-            <a:r>
-              <a:rPr>
-                <a:latin typeface="Courier"/>
-              </a:rPr>
-              <a:t>PATH</a:t>
-            </a:r>
-            <a:r>
-              <a:rPr/>
-              <a:t>, which is why </a:t>
-            </a:r>
-            <a:r>
-              <a:rPr>
-                <a:latin typeface="Courier"/>
-              </a:rPr>
-              <a:t>which python3</a:t>
-            </a:r>
-            <a:r>
-              <a:rPr/>
-              <a:t> is the diagnostic command when something is wrong. Say plainly: never install into the system Python. On a managed hospital workstation you often cannot anyway, and the error will read </a:t>
-            </a:r>
-            <a:r>
-              <a:rPr>
-                <a:latin typeface="Courier"/>
-              </a:rPr>
-              <a:t>externally-managed-environment</a:t>
-            </a:r>
-            <a:r>
-              <a:rPr/>
-              <a:t>.</a:t>
-            </a:r>
-          </a:p>
-        </p:txBody>
-      </p:sp>
-      <p:sp>
-        <p:nvSpPr>
-          <p:cNvPr id="4" name="Slide Number Placeholder 3"/>
-          <p:cNvSpPr>
-            <a:spLocks noGrp="1"/>
-          </p:cNvSpPr>
-          <p:nvPr>
-            <p:ph type="sldNum" sz="quarter" idx="10"/>
-          </p:nvPr>
-        </p:nvSpPr>
-        <p:spPr/>
-        <p:txBody>
-          <a:bodyPr/>
-          <a:lstStyle/>
-          <a:p>
-            <a:fld id="{18BDFEC3-8487-43E8-A154-7C12CBC1FFF2}" type="slidenum">
-              <a:rPr lang="en-US"/>
-              <a:t>15</a:t>
-            </a:fld>
-            <a:endParaRPr lang="en-US"/>
-          </a:p>
-        </p:txBody>
-      </p:sp>
-    </p:spTree>
-  </p:cSld>
-</p:notes>
-</file>
-
-<file path=ppt/notesSlides/notesSlide12.xml><?xml version="1.0" encoding="utf-8"?>
-<p:notes xmlns:a="http://schemas.openxmlformats.org/drawingml/2006/main" xmlns:r="http://schemas.openxmlformats.org/officeDocument/2006/relationships" xmlns:p="http://schemas.openxmlformats.org/presentationml/2006/main">
-  <p:cSld>
-    <p:spTree>
-      <p:nvGrpSpPr>
-        <p:cNvPr id="1" name=""/>
-        <p:cNvGrpSpPr/>
-        <p:nvPr/>
-      </p:nvGrpSpPr>
-      <p:grpSpPr>
-        <a:xfrm>
-          <a:off x="0" y="0"/>
-          <a:ext cx="0" cy="0"/>
-          <a:chOff x="0" y="0"/>
-          <a:chExt cx="0" cy="0"/>
-        </a:xfrm>
-      </p:grpSpPr>
-      <p:sp>
-        <p:nvSpPr>
-          <p:cNvPr id="2" name="Slide Image Placeholder 1"/>
-          <p:cNvSpPr>
-            <a:spLocks noGrp="1" noRot="1" noChangeAspect="1"/>
-          </p:cNvSpPr>
-          <p:nvPr>
-            <p:ph type="sldImg"/>
-          </p:nvPr>
-        </p:nvSpPr>
-        <p:spPr/>
-      </p:sp>
-      <p:sp>
-        <p:nvSpPr>
-          <p:cNvPr id="3" name="Notes Placeholder 2"/>
-          <p:cNvSpPr>
-            <a:spLocks noGrp="1"/>
-          </p:cNvSpPr>
-          <p:nvPr>
-            <p:ph type="body" idx="1"/>
-          </p:nvPr>
-        </p:nvSpPr>
-        <p:spPr/>
-        <p:txBody>
-          <a:bodyPr/>
-          <a:lstStyle/>
-          <a:p>
-            <a:pPr lvl="0" indent="0" marL="0">
-              <a:buNone/>
-            </a:pPr>
-            <a:r>
-              <a:rPr/>
-              <a:t>Type this live in an empty folder. Show </a:t>
-            </a:r>
-            <a:r>
-              <a:rPr>
-                <a:latin typeface="Courier"/>
-              </a:rPr>
-              <a:t>which python3</a:t>
-            </a:r>
-            <a:r>
-              <a:rPr/>
-              <a:t> before and after activating: that before/after is what makes the concept click. Insist that </a:t>
-            </a:r>
-            <a:r>
-              <a:rPr>
-                <a:latin typeface="Courier"/>
-              </a:rPr>
-              <a:t>.venv/</a:t>
-            </a:r>
-            <a:r>
-              <a:rPr/>
-              <a:t> is disposable and must never be committed, because it is derived, it is large, and it is specific to one machine. What you commit is the </a:t>
-            </a:r>
-            <a:r>
-              <a:rPr i="1"/>
-              <a:t>list</a:t>
-            </a:r>
-            <a:r>
-              <a:rPr/>
-              <a:t> of packages.</a:t>
-            </a:r>
-          </a:p>
-        </p:txBody>
-      </p:sp>
-      <p:sp>
-        <p:nvSpPr>
-          <p:cNvPr id="4" name="Slide Number Placeholder 3"/>
-          <p:cNvSpPr>
-            <a:spLocks noGrp="1"/>
-          </p:cNvSpPr>
-          <p:nvPr>
-            <p:ph type="sldNum" sz="quarter" idx="10"/>
-          </p:nvPr>
-        </p:nvSpPr>
-        <p:spPr/>
-        <p:txBody>
-          <a:bodyPr/>
-          <a:lstStyle/>
-          <a:p>
-            <a:fld id="{18BDFEC3-8487-43E8-A154-7C12CBC1FFF2}" type="slidenum">
-              <a:rPr lang="en-US"/>
-              <a:t>16</a:t>
-            </a:fld>
-            <a:endParaRPr lang="en-US"/>
-          </a:p>
-        </p:txBody>
-      </p:sp>
-    </p:spTree>
-  </p:cSld>
-</p:notes>
-</file>
-
-<file path=ppt/notesSlides/notesSlide13.xml><?xml version="1.0" encoding="utf-8"?>
-<p:notes xmlns:a="http://schemas.openxmlformats.org/drawingml/2006/main" xmlns:r="http://schemas.openxmlformats.org/officeDocument/2006/relationships" xmlns:p="http://schemas.openxmlformats.org/presentationml/2006/main">
-  <p:cSld>
-    <p:spTree>
-      <p:nvGrpSpPr>
-        <p:cNvPr id="1" name=""/>
-        <p:cNvGrpSpPr/>
-        <p:nvPr/>
-      </p:nvGrpSpPr>
-      <p:grpSpPr>
-        <a:xfrm>
-          <a:off x="0" y="0"/>
-          <a:ext cx="0" cy="0"/>
-          <a:chOff x="0" y="0"/>
-          <a:chExt cx="0" cy="0"/>
-        </a:xfrm>
-      </p:grpSpPr>
-      <p:sp>
-        <p:nvSpPr>
-          <p:cNvPr id="2" name="Slide Image Placeholder 1"/>
-          <p:cNvSpPr>
-            <a:spLocks noGrp="1" noRot="1" noChangeAspect="1"/>
-          </p:cNvSpPr>
-          <p:nvPr>
-            <p:ph type="sldImg"/>
-          </p:nvPr>
-        </p:nvSpPr>
-        <p:spPr/>
-      </p:sp>
-      <p:sp>
-        <p:nvSpPr>
-          <p:cNvPr id="3" name="Notes Placeholder 2"/>
-          <p:cNvSpPr>
-            <a:spLocks noGrp="1"/>
-          </p:cNvSpPr>
-          <p:nvPr>
-            <p:ph type="body" idx="1"/>
-          </p:nvPr>
-        </p:nvSpPr>
-        <p:spPr/>
-        <p:txBody>
-          <a:bodyPr/>
-          <a:lstStyle/>
-          <a:p>
-            <a:pPr lvl="0" indent="0" marL="0">
-              <a:buNone/>
-            </a:pPr>
-            <a:r>
-              <a:rPr>
-                <a:latin typeface="Courier"/>
-              </a:rPr>
-              <a:t>uvx ruff check .</a:t>
-            </a:r>
-            <a:r>
-              <a:rPr/>
-              <a:t> is the zero commitment demo (it downloads, runs, and leaves nothing behind). Run it on the notebook folder live. The interesting catch in a health project is usually a variable assigned and never used: nine times out of ten that line was </a:t>
-            </a:r>
-            <a:r>
-              <a:rPr i="1"/>
-              <a:t>meant</a:t>
-            </a:r>
-            <a:r>
-              <a:rPr/>
-              <a:t> to update the dataframe. </a:t>
-            </a:r>
-            <a:r>
-              <a:rPr>
-                <a:latin typeface="Courier"/>
-              </a:rPr>
-              <a:t>ruff format</a:t>
-            </a:r>
-            <a:r>
-              <a:rPr/>
-              <a:t> replaces </a:t>
-            </a:r>
-            <a:r>
-              <a:rPr>
-                <a:latin typeface="Courier"/>
-              </a:rPr>
-              <a:t>black</a:t>
-            </a:r>
-            <a:r>
-              <a:rPr/>
-              <a:t>; </a:t>
-            </a:r>
-            <a:r>
-              <a:rPr>
-                <a:latin typeface="Courier"/>
-              </a:rPr>
-              <a:t>ruff check</a:t>
-            </a:r>
-            <a:r>
-              <a:rPr/>
-              <a:t> replaces </a:t>
-            </a:r>
-            <a:r>
-              <a:rPr>
-                <a:latin typeface="Courier"/>
-              </a:rPr>
-              <a:t>flake8</a:t>
-            </a:r>
-            <a:r>
-              <a:rPr/>
-              <a:t> and most of </a:t>
-            </a:r>
-            <a:r>
-              <a:rPr>
-                <a:latin typeface="Courier"/>
-              </a:rPr>
-              <a:t>pylint</a:t>
-            </a:r>
-            <a:r>
-              <a:rPr/>
-              <a:t>. One tool, one config, in </a:t>
-            </a:r>
-            <a:r>
-              <a:rPr>
-                <a:latin typeface="Courier"/>
-              </a:rPr>
-              <a:t>pyproject.toml</a:t>
-            </a:r>
-            <a:r>
-              <a:rPr/>
-              <a:t>.</a:t>
-            </a:r>
-          </a:p>
-        </p:txBody>
-      </p:sp>
-      <p:sp>
-        <p:nvSpPr>
-          <p:cNvPr id="4" name="Slide Number Placeholder 3"/>
-          <p:cNvSpPr>
-            <a:spLocks noGrp="1"/>
-          </p:cNvSpPr>
-          <p:nvPr>
-            <p:ph type="sldNum" sz="quarter" idx="10"/>
-          </p:nvPr>
-        </p:nvSpPr>
-        <p:spPr/>
-        <p:txBody>
-          <a:bodyPr/>
-          <a:lstStyle/>
-          <a:p>
-            <a:fld id="{18BDFEC3-8487-43E8-A154-7C12CBC1FFF2}" type="slidenum">
-              <a:rPr lang="en-US"/>
-              <a:t>17</a:t>
+              <a:t>3</a:t>
             </a:fld>
             <a:endParaRPr lang="en-US"/>
           </a:p>
@@ -1192,25 +625,15 @@
             </a:pPr>
             <a:r>
               <a:rPr/>
-              <a:t>This is the slide that answers “why is a health data course starting with bash?”. Make it institutional, not ideological: this is simply the interface the field uses. The </a:t>
-            </a:r>
-            <a:r>
-              <a:rPr>
-                <a:latin typeface="Courier"/>
-              </a:rPr>
-              <a:t>ssh</a:t>
+              <a:t>Four words students use as synonyms for a fortnight. Fixing this early saves a lot of confusion later: “the terminal crashed” and “the shell is bash” and “ls is a program” are three different statements. Emphasise the closing line. Everything that follows (variables, loops, conditionals, functions) is available </a:t>
+            </a:r>
+            <a:r>
+              <a:rPr i="1"/>
+              <a:t>because</a:t>
             </a:r>
             <a:r>
               <a:rPr/>
-              <a:t> point usually lands hardest, because for regulated data, remote text access is often the </a:t>
-            </a:r>
-            <a:r>
-              <a:rPr i="1"/>
-              <a:t>only</a:t>
-            </a:r>
-            <a:r>
-              <a:rPr/>
-              <a:t> access.</a:t>
+              <a:t> the shell is a language. The prompt is a REPL.</a:t>
             </a:r>
           </a:p>
         </p:txBody>
@@ -1292,15 +715,27 @@
             </a:pPr>
             <a:r>
               <a:rPr/>
-              <a:t>Four words students use as synonyms for a fortnight. Fixing this early saves a lot of confusion later: “the terminal crashed” and “the shell is bash” and “ls is a program” are three different statements. Emphasise the closing line. Everything that follows (variables, loops, conditionals, functions) is available </a:t>
-            </a:r>
-            <a:r>
-              <a:rPr i="1"/>
-              <a:t>because</a:t>
+              <a:t>This is the grammar slide; every command in the notebook obeys it. Two traps to name now, because both will bite in the exercises: (1) a space separates arguments, so a filename with a space is two arguments unless it is quoted. Health data exports are full of </a:t>
+            </a:r>
+            <a:r>
+              <a:rPr>
+                <a:latin typeface="Courier"/>
+              </a:rPr>
+              <a:t>Patient Records 2024.csv</a:t>
             </a:r>
             <a:r>
               <a:rPr/>
-              <a:t> the shell is a language. The prompt is a REPL.</a:t>
+              <a:t>. (2) flags are case sensitive and not universal: </a:t>
+            </a:r>
+            <a:r>
+              <a:rPr>
+                <a:latin typeface="Courier"/>
+              </a:rPr>
+              <a:t>-h</a:t>
+            </a:r>
+            <a:r>
+              <a:rPr/>
+              <a:t> is “help” in some tools and “human readable” in others. There is no committee.</a:t>
             </a:r>
           </a:p>
         </p:txBody>
@@ -1382,27 +817,17 @@
             </a:pPr>
             <a:r>
               <a:rPr/>
-              <a:t>This is the grammar slide; every command in the notebook obeys it. Two traps to name now, because both will bite in the exercises: (1) a space separates arguments, so a filename with a space is two arguments unless it is quoted. Health data exports are full of </a:t>
+              <a:t>Two ideas: there is a single root (no </a:t>
             </a:r>
             <a:r>
               <a:rPr>
                 <a:latin typeface="Courier"/>
               </a:rPr>
-              <a:t>Patient Records 2024.csv</a:t>
+              <a:t>C:</a:t>
             </a:r>
             <a:r>
               <a:rPr/>
-              <a:t>. (2) flags are case sensitive and not universal: </a:t>
-            </a:r>
-            <a:r>
-              <a:rPr>
-                <a:latin typeface="Courier"/>
-              </a:rPr>
-              <a:t>-h</a:t>
-            </a:r>
-            <a:r>
-              <a:rPr/>
-              <a:t> is “help” in some tools and “human readable” in others. There is no committee.</a:t>
+              <a:t> drive), and any file has two names (absolute and relative) that point to the same thing. Rule of thumb for their future scripts: absolute paths for data that lives somewhere fixed, relative paths for anything inside the project, so the project can be moved, shared, or run on the cluster untouched.</a:t>
             </a:r>
           </a:p>
         </p:txBody>
@@ -1424,7 +849,7 @@
           <a:p>
             <a:fld id="{18BDFEC3-8487-43E8-A154-7C12CBC1FFF2}" type="slidenum">
               <a:rPr lang="en-US"/>
-              <a:t>6</a:t>
+              <a:t>7</a:t>
             </a:fld>
             <a:endParaRPr lang="en-US"/>
           </a:p>
@@ -1484,17 +909,67 @@
             </a:pPr>
             <a:r>
               <a:rPr/>
-              <a:t>Two ideas: there is a single root (no </a:t>
+              <a:t>Type these live, slowly, in a scratch folder. Let them see the prompt change with </a:t>
             </a:r>
             <a:r>
               <a:rPr>
                 <a:latin typeface="Courier"/>
               </a:rPr>
-              <a:t>C:</a:t>
+              <a:t>cd</a:t>
             </a:r>
             <a:r>
               <a:rPr/>
-              <a:t> drive), and any file has two names (absolute and relative) that point to the same thing. Rule of thumb for their future scripts: absolute paths for data that lives somewhere fixed, relative paths for anything inside the project, so the project can be moved, shared, or run on the cluster untouched.</a:t>
+              <a:t>. Give the </a:t>
+            </a:r>
+            <a:r>
+              <a:rPr>
+                <a:latin typeface="Courier"/>
+              </a:rPr>
+              <a:t>rm</a:t>
+            </a:r>
+            <a:r>
+              <a:rPr/>
+              <a:t> warning its own beat. Then give them the habit that actually protects them: run the dangerous thing as </a:t>
+            </a:r>
+            <a:r>
+              <a:rPr>
+                <a:latin typeface="Courier"/>
+              </a:rPr>
+              <a:t>ls</a:t>
+            </a:r>
+            <a:r>
+              <a:rPr/>
+              <a:t> first (</a:t>
+            </a:r>
+            <a:r>
+              <a:rPr>
+                <a:latin typeface="Courier"/>
+              </a:rPr>
+              <a:t>ls *.tmp</a:t>
+            </a:r>
+            <a:r>
+              <a:rPr/>
+              <a:t>), look at what matched, then swap </a:t>
+            </a:r>
+            <a:r>
+              <a:rPr>
+                <a:latin typeface="Courier"/>
+              </a:rPr>
+              <a:t>ls</a:t>
+            </a:r>
+            <a:r>
+              <a:rPr/>
+              <a:t> for </a:t>
+            </a:r>
+            <a:r>
+              <a:rPr>
+                <a:latin typeface="Courier"/>
+              </a:rPr>
+              <a:t>rm</a:t>
+            </a:r>
+            <a:r>
+              <a:rPr/>
+              <a:t>. Never trust a glob you have not printed.</a:t>
             </a:r>
           </a:p>
         </p:txBody>
@@ -1576,67 +1051,27 @@
             </a:pPr>
             <a:r>
               <a:rPr/>
-              <a:t>Type these live, slowly, in a scratch folder. Let them see the prompt change with </a:t>
+              <a:t>This is the intellectual core of the whole session, and the reason the tools are all small. Each program does one job and speaks the same currency: lines of text. The pipe is what makes them compose. Build the example one stage at a time on screen, showing the intermediate output after each </a:t>
             </a:r>
             <a:r>
               <a:rPr>
                 <a:latin typeface="Courier"/>
               </a:rPr>
-              <a:t>cd</a:t>
+              <a:t>|</a:t>
             </a:r>
             <a:r>
               <a:rPr/>
-              <a:t>. Give the </a:t>
+              <a:t>. Students remember the shape once they have watched it narrow. Mention that this is exactly </a:t>
             </a:r>
             <a:r>
               <a:rPr>
                 <a:latin typeface="Courier"/>
               </a:rPr>
-              <a:t>rm</a:t>
+              <a:t>pandas</a:t>
             </a:r>
             <a:r>
               <a:rPr/>
-              <a:t> warning its own beat. Then give them the habit that actually protects them: run the dangerous thing as </a:t>
-            </a:r>
-            <a:r>
-              <a:rPr>
-                <a:latin typeface="Courier"/>
-              </a:rPr>
-              <a:t>ls</a:t>
-            </a:r>
-            <a:r>
-              <a:rPr/>
-              <a:t> first (</a:t>
-            </a:r>
-            <a:r>
-              <a:rPr>
-                <a:latin typeface="Courier"/>
-              </a:rPr>
-              <a:t>ls *.tmp</a:t>
-            </a:r>
-            <a:r>
-              <a:rPr/>
-              <a:t>), look at what matched, then swap </a:t>
-            </a:r>
-            <a:r>
-              <a:rPr>
-                <a:latin typeface="Courier"/>
-              </a:rPr>
-              <a:t>ls</a:t>
-            </a:r>
-            <a:r>
-              <a:rPr/>
-              <a:t> for </a:t>
-            </a:r>
-            <a:r>
-              <a:rPr>
-                <a:latin typeface="Courier"/>
-              </a:rPr>
-              <a:t>rm</a:t>
-            </a:r>
-            <a:r>
-              <a:rPr/>
-              <a:t>. Never trust a glob you have not printed.</a:t>
+              <a:t> chaining, ten years older and on files it never has to load into memory.</a:t>
             </a:r>
           </a:p>
         </p:txBody>
@@ -1718,108 +1153,6 @@
             </a:pPr>
             <a:r>
               <a:rPr/>
-              <a:t>This is the intellectual core of the whole session, and the reason the tools are all small. Each program does one job and speaks the same currency: lines of text. The pipe is what makes them compose. Build the example one stage at a time on screen, showing the intermediate output after each </a:t>
-            </a:r>
-            <a:r>
-              <a:rPr>
-                <a:latin typeface="Courier"/>
-              </a:rPr>
-              <a:t>|</a:t>
-            </a:r>
-            <a:r>
-              <a:rPr/>
-              <a:t>. Students remember the shape once they have watched it narrow. Mention that this is exactly </a:t>
-            </a:r>
-            <a:r>
-              <a:rPr>
-                <a:latin typeface="Courier"/>
-              </a:rPr>
-              <a:t>pandas</a:t>
-            </a:r>
-            <a:r>
-              <a:rPr/>
-              <a:t> chaining, ten years older and on files it never has to load into memory.</a:t>
-            </a:r>
-          </a:p>
-        </p:txBody>
-      </p:sp>
-      <p:sp>
-        <p:nvSpPr>
-          <p:cNvPr id="4" name="Slide Number Placeholder 3"/>
-          <p:cNvSpPr>
-            <a:spLocks noGrp="1"/>
-          </p:cNvSpPr>
-          <p:nvPr>
-            <p:ph type="sldNum" sz="quarter" idx="10"/>
-          </p:nvPr>
-        </p:nvSpPr>
-        <p:spPr/>
-        <p:txBody>
-          <a:bodyPr/>
-          <a:lstStyle/>
-          <a:p>
-            <a:fld id="{18BDFEC3-8487-43E8-A154-7C12CBC1FFF2}" type="slidenum">
-              <a:rPr lang="en-US"/>
-              <a:t>10</a:t>
-            </a:fld>
-            <a:endParaRPr lang="en-US"/>
-          </a:p>
-        </p:txBody>
-      </p:sp>
-    </p:spTree>
-  </p:cSld>
-</p:notes>
-</file>
-
-<file path=ppt/notesSlides/notesSlide8.xml><?xml version="1.0" encoding="utf-8"?>
-<p:notes xmlns:a="http://schemas.openxmlformats.org/drawingml/2006/main" xmlns:r="http://schemas.openxmlformats.org/officeDocument/2006/relationships" xmlns:p="http://schemas.openxmlformats.org/presentationml/2006/main">
-  <p:cSld>
-    <p:spTree>
-      <p:nvGrpSpPr>
-        <p:cNvPr id="1" name=""/>
-        <p:cNvGrpSpPr/>
-        <p:nvPr/>
-      </p:nvGrpSpPr>
-      <p:grpSpPr>
-        <a:xfrm>
-          <a:off x="0" y="0"/>
-          <a:ext cx="0" cy="0"/>
-          <a:chOff x="0" y="0"/>
-          <a:chExt cx="0" cy="0"/>
-        </a:xfrm>
-      </p:grpSpPr>
-      <p:sp>
-        <p:nvSpPr>
-          <p:cNvPr id="2" name="Slide Image Placeholder 1"/>
-          <p:cNvSpPr>
-            <a:spLocks noGrp="1" noRot="1" noChangeAspect="1"/>
-          </p:cNvSpPr>
-          <p:nvPr>
-            <p:ph type="sldImg"/>
-          </p:nvPr>
-        </p:nvSpPr>
-        <p:spPr/>
-      </p:sp>
-      <p:sp>
-        <p:nvSpPr>
-          <p:cNvPr id="3" name="Notes Placeholder 2"/>
-          <p:cNvSpPr>
-            <a:spLocks noGrp="1"/>
-          </p:cNvSpPr>
-          <p:nvPr>
-            <p:ph type="body" idx="1"/>
-          </p:nvPr>
-        </p:nvSpPr>
-        <p:spPr/>
-        <p:txBody>
-          <a:bodyPr/>
-          <a:lstStyle/>
-          <a:p>
-            <a:pPr lvl="0" indent="0" marL="0">
-              <a:buNone/>
-            </a:pPr>
-            <a:r>
-              <a:rPr/>
               <a:t>Do not try to teach these exhaustively (the notebook does that). Here just establish that the toolbox is small, and that each one is a verb you can look up. </a:t>
             </a:r>
             <a:r>
@@ -1862,125 +1195,7 @@
           <a:p>
             <a:fld id="{18BDFEC3-8487-43E8-A154-7C12CBC1FFF2}" type="slidenum">
               <a:rPr lang="en-US"/>
-              <a:t>11</a:t>
-            </a:fld>
-            <a:endParaRPr lang="en-US"/>
-          </a:p>
-        </p:txBody>
-      </p:sp>
-    </p:spTree>
-  </p:cSld>
-</p:notes>
-</file>
-
-<file path=ppt/notesSlides/notesSlide9.xml><?xml version="1.0" encoding="utf-8"?>
-<p:notes xmlns:a="http://schemas.openxmlformats.org/drawingml/2006/main" xmlns:r="http://schemas.openxmlformats.org/officeDocument/2006/relationships" xmlns:p="http://schemas.openxmlformats.org/presentationml/2006/main">
-  <p:cSld>
-    <p:spTree>
-      <p:nvGrpSpPr>
-        <p:cNvPr id="1" name=""/>
-        <p:cNvGrpSpPr/>
-        <p:nvPr/>
-      </p:nvGrpSpPr>
-      <p:grpSpPr>
-        <a:xfrm>
-          <a:off x="0" y="0"/>
-          <a:ext cx="0" cy="0"/>
-          <a:chOff x="0" y="0"/>
-          <a:chExt cx="0" cy="0"/>
-        </a:xfrm>
-      </p:grpSpPr>
-      <p:sp>
-        <p:nvSpPr>
-          <p:cNvPr id="2" name="Slide Image Placeholder 1"/>
-          <p:cNvSpPr>
-            <a:spLocks noGrp="1" noRot="1" noChangeAspect="1"/>
-          </p:cNvSpPr>
-          <p:nvPr>
-            <p:ph type="sldImg"/>
-          </p:nvPr>
-        </p:nvSpPr>
-        <p:spPr/>
-      </p:sp>
-      <p:sp>
-        <p:nvSpPr>
-          <p:cNvPr id="3" name="Notes Placeholder 2"/>
-          <p:cNvSpPr>
-            <a:spLocks noGrp="1"/>
-          </p:cNvSpPr>
-          <p:nvPr>
-            <p:ph type="body" idx="1"/>
-          </p:nvPr>
-        </p:nvSpPr>
-        <p:spPr/>
-        <p:txBody>
-          <a:bodyPr/>
-          <a:lstStyle/>
-          <a:p>
-            <a:pPr lvl="0" indent="0" marL="0">
-              <a:buNone/>
-            </a:pPr>
-            <a:r>
-              <a:rPr/>
-              <a:t>Students arrive expecting a fight (“should I learn bash or Python?”), and the answer is that they do different jobs. bash manipulates </a:t>
-            </a:r>
-            <a:r>
-              <a:rPr i="1"/>
-              <a:t>files and programs</a:t>
-            </a:r>
-            <a:r>
-              <a:rPr/>
-              <a:t>; Python manipulates </a:t>
-            </a:r>
-            <a:r>
-              <a:rPr i="1"/>
-              <a:t>values</a:t>
-            </a:r>
-            <a:r>
-              <a:rPr/>
-              <a:t>. Adding two numbers in bash is awkward on purpose; renaming 4 000 files in Python is fifteen lines of </a:t>
-            </a:r>
-            <a:r>
-              <a:rPr>
-                <a:latin typeface="Courier"/>
-              </a:rPr>
-              <a:t>os.walk</a:t>
-            </a:r>
-            <a:r>
-              <a:rPr/>
-              <a:t> that </a:t>
-            </a:r>
-            <a:r>
-              <a:rPr>
-                <a:latin typeface="Courier"/>
-              </a:rPr>
-              <a:t>mv</a:t>
-            </a:r>
-            <a:r>
-              <a:rPr/>
-              <a:t> did in one. The working rule: if the sentence contains “for each file”, start in the shell. If it contains “for each patient”, you are already inside Python.</a:t>
-            </a:r>
-          </a:p>
-        </p:txBody>
-      </p:sp>
-      <p:sp>
-        <p:nvSpPr>
-          <p:cNvPr id="4" name="Slide Number Placeholder 3"/>
-          <p:cNvSpPr>
-            <a:spLocks noGrp="1"/>
-          </p:cNvSpPr>
-          <p:nvPr>
-            <p:ph type="sldNum" sz="quarter" idx="10"/>
-          </p:nvPr>
-        </p:nvSpPr>
-        <p:spPr/>
-        <p:txBody>
-          <a:bodyPr/>
-          <a:lstStyle/>
-          <a:p>
-            <a:fld id="{18BDFEC3-8487-43E8-A154-7C12CBC1FFF2}" type="slidenum">
-              <a:rPr lang="en-US"/>
-              <a:t>13</a:t>
+              <a:t>10</a:t>
             </a:fld>
             <a:endParaRPr lang="en-US"/>
           </a:p>
@@ -4990,7 +4205,7 @@
             <a:br/>
             <a:r>
               <a:rPr/>
-              <a:t>The Command Line: Talking to a Computer in Words</a:t>
+              <a:t>The Command Line</a:t>
             </a:r>
           </a:p>
         </p:txBody>
@@ -5066,85 +4281,6 @@
 </file>
 
 <file path=ppt/slides/slide10.xml><?xml version="1.0" encoding="utf-8"?>
-<p:sld xmlns:a="http://schemas.openxmlformats.org/drawingml/2006/main" xmlns:r="http://schemas.openxmlformats.org/officeDocument/2006/relationships" xmlns:p="http://schemas.openxmlformats.org/presentationml/2006/main">
-  <p:cSld>
-    <p:spTree>
-      <p:nvGrpSpPr>
-        <p:cNvPr id="1" name=""/>
-        <p:cNvGrpSpPr/>
-        <p:nvPr/>
-      </p:nvGrpSpPr>
-      <p:grpSpPr>
-        <a:xfrm>
-          <a:off x="0" y="0"/>
-          <a:ext cx="0" cy="0"/>
-          <a:chOff x="0" y="0"/>
-          <a:chExt cx="0" cy="0"/>
-        </a:xfrm>
-      </p:grpSpPr>
-      <p:sp>
-        <p:nvSpPr>
-          <p:cNvPr id="2" name="Title 1"/>
-          <p:cNvSpPr>
-            <a:spLocks noGrp="1"/>
-          </p:cNvSpPr>
-          <p:nvPr>
-            <p:ph type="title"/>
-          </p:nvPr>
-        </p:nvSpPr>
-        <p:spPr/>
-        <p:txBody>
-          <a:bodyPr>
-            <a:normAutofit/>
-          </a:bodyPr>
-          <a:lstStyle/>
-          <a:p>
-            <a:pPr lvl="0" indent="0" marL="0">
-              <a:buNone/>
-            </a:pPr>
-            <a:r>
-              <a:rPr/>
-              <a:t>Text in, text out</a:t>
-            </a:r>
-          </a:p>
-        </p:txBody>
-      </p:sp>
-      <p:pic>
-        <p:nvPicPr>
-          <p:cNvPr descr="img/pipeline.png" id="0" name="Picture 1"/>
-          <p:cNvPicPr>
-            <a:picLocks noGrp="1" noChangeAspect="1"/>
-          </p:cNvPicPr>
-          <p:nvPr/>
-        </p:nvPicPr>
-        <p:blipFill>
-          <a:blip r:embed="rId3"/>
-          <a:stretch>
-            <a:fillRect/>
-          </a:stretch>
-        </p:blipFill>
-        <p:spPr bwMode="auto">
-          <a:xfrm>
-            <a:off x="457200" y="1193800"/>
-            <a:ext cx="8229600" cy="3390900"/>
-          </a:xfrm>
-          <a:prstGeom prst="rect">
-            <a:avLst/>
-          </a:prstGeom>
-          <a:noFill/>
-          <a:ln w="9525">
-            <a:noFill/>
-            <a:headEnd/>
-            <a:tailEnd/>
-          </a:ln>
-        </p:spPr>
-      </p:pic>
-    </p:spTree>
-  </p:cSld>
-</p:sld>
-</file>
-
-<file path=ppt/slides/slide11.xml><?xml version="1.0" encoding="utf-8"?>
 <p:sld xmlns:a="http://schemas.openxmlformats.org/drawingml/2006/main" xmlns:r="http://schemas.openxmlformats.org/officeDocument/2006/relationships" xmlns:p="http://schemas.openxmlformats.org/presentationml/2006/main">
   <p:cSld>
     <p:spTree>
@@ -5517,701 +4653,6 @@
 </p:sld>
 </file>
 
-<file path=ppt/slides/slide12.xml><?xml version="1.0" encoding="utf-8"?>
-<p:sld xmlns:a="http://schemas.openxmlformats.org/drawingml/2006/main" xmlns:r="http://schemas.openxmlformats.org/officeDocument/2006/relationships" xmlns:p="http://schemas.openxmlformats.org/presentationml/2006/main">
-  <p:cSld>
-    <p:spTree>
-      <p:nvGrpSpPr>
-        <p:cNvPr id="1" name=""/>
-        <p:cNvGrpSpPr/>
-        <p:nvPr/>
-      </p:nvGrpSpPr>
-      <p:grpSpPr>
-        <a:xfrm>
-          <a:off x="0" y="0"/>
-          <a:ext cx="0" cy="0"/>
-          <a:chOff x="0" y="0"/>
-          <a:chExt cx="0" cy="0"/>
-        </a:xfrm>
-      </p:grpSpPr>
-      <p:sp>
-        <p:nvSpPr>
-          <p:cNvPr id="2" name="Title 1"/>
-          <p:cNvSpPr>
-            <a:spLocks noGrp="1"/>
-          </p:cNvSpPr>
-          <p:nvPr>
-            <p:ph type="title"/>
-          </p:nvPr>
-        </p:nvSpPr>
-        <p:spPr>
-          <a:xfrm>
-            <a:off x="722313" y="3305176"/>
-            <a:ext cx="7772400" cy="1021556"/>
-          </a:xfrm>
-        </p:spPr>
-        <p:txBody>
-          <a:bodyPr>
-            <a:normAutofit/>
-          </a:bodyPr>
-          <a:lstStyle/>
-          <a:p>
-            <a:pPr lvl="0" indent="0" marL="0">
-              <a:buNone/>
-            </a:pPr>
-            <a:r>
-              <a:rPr/>
-              <a:t>3. From the shell to Python</a:t>
-            </a:r>
-          </a:p>
-        </p:txBody>
-      </p:sp>
-    </p:spTree>
-  </p:cSld>
-</p:sld>
-</file>
-
-<file path=ppt/slides/slide13.xml><?xml version="1.0" encoding="utf-8"?>
-<p:sld xmlns:a="http://schemas.openxmlformats.org/drawingml/2006/main" xmlns:r="http://schemas.openxmlformats.org/officeDocument/2006/relationships" xmlns:p="http://schemas.openxmlformats.org/presentationml/2006/main">
-  <p:cSld>
-    <p:spTree>
-      <p:nvGrpSpPr>
-        <p:cNvPr id="1" name=""/>
-        <p:cNvGrpSpPr/>
-        <p:nvPr/>
-      </p:nvGrpSpPr>
-      <p:grpSpPr>
-        <a:xfrm>
-          <a:off x="0" y="0"/>
-          <a:ext cx="0" cy="0"/>
-          <a:chOff x="0" y="0"/>
-          <a:chExt cx="0" cy="0"/>
-        </a:xfrm>
-      </p:grpSpPr>
-      <p:sp>
-        <p:nvSpPr>
-          <p:cNvPr id="2" name="Title 1"/>
-          <p:cNvSpPr>
-            <a:spLocks noGrp="1"/>
-          </p:cNvSpPr>
-          <p:nvPr>
-            <p:ph type="title"/>
-          </p:nvPr>
-        </p:nvSpPr>
-        <p:spPr/>
-        <p:txBody>
-          <a:bodyPr>
-            <a:normAutofit/>
-          </a:bodyPr>
-          <a:lstStyle/>
-          <a:p>
-            <a:pPr lvl="0" indent="0" marL="0">
-              <a:buNone/>
-            </a:pPr>
-            <a:r>
-              <a:rPr/>
-              <a:t>Two languages, one boundary</a:t>
-            </a:r>
-          </a:p>
-        </p:txBody>
-      </p:sp>
-      <p:pic>
-        <p:nvPicPr>
-          <p:cNvPr descr="img/python_vs_bash.png" id="0" name="Picture 1"/>
-          <p:cNvPicPr>
-            <a:picLocks noGrp="1" noChangeAspect="1"/>
-          </p:cNvPicPr>
-          <p:nvPr/>
-        </p:nvPicPr>
-        <p:blipFill>
-          <a:blip r:embed="rId3"/>
-          <a:stretch>
-            <a:fillRect/>
-          </a:stretch>
-        </p:blipFill>
-        <p:spPr bwMode="auto">
-          <a:xfrm>
-            <a:off x="457200" y="1193800"/>
-            <a:ext cx="8229600" cy="3390900"/>
-          </a:xfrm>
-          <a:prstGeom prst="rect">
-            <a:avLst/>
-          </a:prstGeom>
-          <a:noFill/>
-          <a:ln w="9525">
-            <a:noFill/>
-            <a:headEnd/>
-            <a:tailEnd/>
-          </a:ln>
-        </p:spPr>
-      </p:pic>
-    </p:spTree>
-  </p:cSld>
-</p:sld>
-</file>
-
-<file path=ppt/slides/slide14.xml><?xml version="1.0" encoding="utf-8"?>
-<p:sld xmlns:a="http://schemas.openxmlformats.org/drawingml/2006/main" xmlns:r="http://schemas.openxmlformats.org/officeDocument/2006/relationships" xmlns:p="http://schemas.openxmlformats.org/presentationml/2006/main">
-  <p:cSld>
-    <p:spTree>
-      <p:nvGrpSpPr>
-        <p:cNvPr id="1" name=""/>
-        <p:cNvGrpSpPr/>
-        <p:nvPr/>
-      </p:nvGrpSpPr>
-      <p:grpSpPr>
-        <a:xfrm>
-          <a:off x="0" y="0"/>
-          <a:ext cx="0" cy="0"/>
-          <a:chOff x="0" y="0"/>
-          <a:chExt cx="0" cy="0"/>
-        </a:xfrm>
-      </p:grpSpPr>
-      <p:sp>
-        <p:nvSpPr>
-          <p:cNvPr id="2" name="Title 1"/>
-          <p:cNvSpPr>
-            <a:spLocks noGrp="1"/>
-          </p:cNvSpPr>
-          <p:nvPr>
-            <p:ph type="title"/>
-          </p:nvPr>
-        </p:nvSpPr>
-        <p:spPr/>
-        <p:txBody>
-          <a:bodyPr>
-            <a:normAutofit/>
-          </a:bodyPr>
-          <a:lstStyle/>
-          <a:p>
-            <a:pPr lvl="0" indent="0" marL="0">
-              <a:buNone/>
-            </a:pPr>
-            <a:r>
-              <a:rPr/>
-              <a:t>Python is just another program</a:t>
-            </a:r>
-          </a:p>
-        </p:txBody>
-      </p:sp>
-      <p:pic>
-        <p:nvPicPr>
-          <p:cNvPr descr="img/interop.png" id="0" name="Picture 1"/>
-          <p:cNvPicPr>
-            <a:picLocks noGrp="1" noChangeAspect="1"/>
-          </p:cNvPicPr>
-          <p:nvPr/>
-        </p:nvPicPr>
-        <p:blipFill>
-          <a:blip r:embed="rId3"/>
-          <a:stretch>
-            <a:fillRect/>
-          </a:stretch>
-        </p:blipFill>
-        <p:spPr bwMode="auto">
-          <a:xfrm>
-            <a:off x="457200" y="1193800"/>
-            <a:ext cx="8229600" cy="3390900"/>
-          </a:xfrm>
-          <a:prstGeom prst="rect">
-            <a:avLst/>
-          </a:prstGeom>
-          <a:noFill/>
-          <a:ln w="9525">
-            <a:noFill/>
-            <a:headEnd/>
-            <a:tailEnd/>
-          </a:ln>
-        </p:spPr>
-      </p:pic>
-    </p:spTree>
-  </p:cSld>
-</p:sld>
-</file>
-
-<file path=ppt/slides/slide15.xml><?xml version="1.0" encoding="utf-8"?>
-<p:sld xmlns:a="http://schemas.openxmlformats.org/drawingml/2006/main" xmlns:r="http://schemas.openxmlformats.org/officeDocument/2006/relationships" xmlns:p="http://schemas.openxmlformats.org/presentationml/2006/main">
-  <p:cSld>
-    <p:spTree>
-      <p:nvGrpSpPr>
-        <p:cNvPr id="1" name=""/>
-        <p:cNvGrpSpPr/>
-        <p:nvPr/>
-      </p:nvGrpSpPr>
-      <p:grpSpPr>
-        <a:xfrm>
-          <a:off x="0" y="0"/>
-          <a:ext cx="0" cy="0"/>
-          <a:chOff x="0" y="0"/>
-          <a:chExt cx="0" cy="0"/>
-        </a:xfrm>
-      </p:grpSpPr>
-      <p:sp>
-        <p:nvSpPr>
-          <p:cNvPr id="2" name="Title 1"/>
-          <p:cNvSpPr>
-            <a:spLocks noGrp="1"/>
-          </p:cNvSpPr>
-          <p:nvPr>
-            <p:ph type="title"/>
-          </p:nvPr>
-        </p:nvSpPr>
-        <p:spPr/>
-        <p:txBody>
-          <a:bodyPr>
-            <a:normAutofit/>
-          </a:bodyPr>
-          <a:lstStyle/>
-          <a:p>
-            <a:pPr lvl="0" indent="0" marL="0">
-              <a:buNone/>
-            </a:pPr>
-            <a:r>
-              <a:rPr/>
-              <a:t>What is an environment?</a:t>
-            </a:r>
-          </a:p>
-        </p:txBody>
-      </p:sp>
-      <p:pic>
-        <p:nvPicPr>
-          <p:cNvPr descr="img/environments.png" id="0" name="Picture 1"/>
-          <p:cNvPicPr>
-            <a:picLocks noGrp="1" noChangeAspect="1"/>
-          </p:cNvPicPr>
-          <p:nvPr/>
-        </p:nvPicPr>
-        <p:blipFill>
-          <a:blip r:embed="rId3"/>
-          <a:stretch>
-            <a:fillRect/>
-          </a:stretch>
-        </p:blipFill>
-        <p:spPr bwMode="auto">
-          <a:xfrm>
-            <a:off x="457200" y="1193800"/>
-            <a:ext cx="8229600" cy="3390900"/>
-          </a:xfrm>
-          <a:prstGeom prst="rect">
-            <a:avLst/>
-          </a:prstGeom>
-          <a:noFill/>
-          <a:ln w="9525">
-            <a:noFill/>
-            <a:headEnd/>
-            <a:tailEnd/>
-          </a:ln>
-        </p:spPr>
-      </p:pic>
-    </p:spTree>
-  </p:cSld>
-</p:sld>
-</file>
-
-<file path=ppt/slides/slide16.xml><?xml version="1.0" encoding="utf-8"?>
-<p:sld xmlns:a="http://schemas.openxmlformats.org/drawingml/2006/main" xmlns:r="http://schemas.openxmlformats.org/officeDocument/2006/relationships" xmlns:p="http://schemas.openxmlformats.org/presentationml/2006/main">
-  <p:cSld>
-    <p:spTree>
-      <p:nvGrpSpPr>
-        <p:cNvPr id="1" name=""/>
-        <p:cNvGrpSpPr/>
-        <p:nvPr/>
-      </p:nvGrpSpPr>
-      <p:grpSpPr>
-        <a:xfrm>
-          <a:off x="0" y="0"/>
-          <a:ext cx="0" cy="0"/>
-          <a:chOff x="0" y="0"/>
-          <a:chExt cx="0" cy="0"/>
-        </a:xfrm>
-      </p:grpSpPr>
-      <p:sp>
-        <p:nvSpPr>
-          <p:cNvPr id="2" name="Title 1"/>
-          <p:cNvSpPr>
-            <a:spLocks noGrp="1"/>
-          </p:cNvSpPr>
-          <p:nvPr>
-            <p:ph type="title"/>
-          </p:nvPr>
-        </p:nvSpPr>
-        <p:spPr/>
-        <p:txBody>
-          <a:bodyPr>
-            <a:normAutofit/>
-          </a:bodyPr>
-          <a:lstStyle/>
-          <a:p>
-            <a:pPr lvl="0" indent="0" marL="0">
-              <a:buNone/>
-            </a:pPr>
-            <a:r>
-              <a:rPr/>
-              <a:t>Creating and using one</a:t>
-            </a:r>
-          </a:p>
-        </p:txBody>
-      </p:sp>
-      <p:sp>
-        <p:nvSpPr>
-          <p:cNvPr id="3" name="Content Placeholder 2"/>
-          <p:cNvSpPr>
-            <a:spLocks noGrp="1"/>
-          </p:cNvSpPr>
-          <p:nvPr>
-            <p:ph idx="1"/>
-          </p:nvPr>
-        </p:nvSpPr>
-        <p:spPr/>
-        <p:txBody>
-          <a:bodyPr>
-            <a:normAutofit/>
-          </a:bodyPr>
-          <a:lstStyle/>
-          <a:p>
-            <a:pPr lvl="0" indent="0">
-              <a:buNone/>
-            </a:pPr>
-            <a:r>
-              <a:rPr>
-                <a:latin typeface="Courier"/>
-              </a:rPr>
-              <a:t>uv venv                        </a:t>
-            </a:r>
-            <a:r>
-              <a:rPr i="1">
-                <a:solidFill>
-                  <a:srgbClr val="60A0B0"/>
-                </a:solidFill>
-                <a:latin typeface="Courier"/>
-              </a:rPr>
-              <a:t># create .venv/ here</a:t>
-            </a:r>
-            <a:br/>
-            <a:r>
-              <a:rPr>
-                <a:solidFill>
-                  <a:srgbClr val="008000"/>
-                </a:solidFill>
-                <a:latin typeface="Courier"/>
-              </a:rPr>
-              <a:t>source</a:t>
-            </a:r>
-            <a:r>
-              <a:rPr>
-                <a:latin typeface="Courier"/>
-              </a:rPr>
-              <a:t> .venv/bin/activate      </a:t>
-            </a:r>
-            <a:r>
-              <a:rPr i="1">
-                <a:solidFill>
-                  <a:srgbClr val="60A0B0"/>
-                </a:solidFill>
-                <a:latin typeface="Courier"/>
-              </a:rPr>
-              <a:t># put it first on PATH  (deactivate to leave)</a:t>
-            </a:r>
-            <a:br/>
-            <a:r>
-              <a:rPr>
-                <a:solidFill>
-                  <a:srgbClr val="06287E"/>
-                </a:solidFill>
-                <a:latin typeface="Courier"/>
-              </a:rPr>
-              <a:t>which</a:t>
-            </a:r>
-            <a:r>
-              <a:rPr>
-                <a:latin typeface="Courier"/>
-              </a:rPr>
-              <a:t> python3                  </a:t>
-            </a:r>
-            <a:r>
-              <a:rPr i="1">
-                <a:solidFill>
-                  <a:srgbClr val="60A0B0"/>
-                </a:solidFill>
-                <a:latin typeface="Courier"/>
-              </a:rPr>
-              <a:t># .../project/.venv/bin/python3   ← the check</a:t>
-            </a:r>
-            <a:br/>
-            <a:br/>
-            <a:r>
-              <a:rPr>
-                <a:latin typeface="Courier"/>
-              </a:rPr>
-              <a:t>uv pip install pandas          </a:t>
-            </a:r>
-            <a:r>
-              <a:rPr i="1">
-                <a:solidFill>
-                  <a:srgbClr val="60A0B0"/>
-                </a:solidFill>
-                <a:latin typeface="Courier"/>
-              </a:rPr>
-              <a:t># installs into .venv, not into the system</a:t>
-            </a:r>
-            <a:br/>
-            <a:r>
-              <a:rPr>
-                <a:latin typeface="Courier"/>
-              </a:rPr>
-              <a:t>uv pip freeze </a:t>
-            </a:r>
-            <a:r>
-              <a:rPr>
-                <a:solidFill>
-                  <a:srgbClr val="666666"/>
-                </a:solidFill>
-                <a:latin typeface="Courier"/>
-              </a:rPr>
-              <a:t>&gt;</a:t>
-            </a:r>
-            <a:r>
-              <a:rPr>
-                <a:latin typeface="Courier"/>
-              </a:rPr>
-              <a:t> requirements.txt    </a:t>
-            </a:r>
-            <a:r>
-              <a:rPr i="1">
-                <a:solidFill>
-                  <a:srgbClr val="60A0B0"/>
-                </a:solidFill>
-                <a:latin typeface="Courier"/>
-              </a:rPr>
-              <a:t># exactly what you have, for someone else</a:t>
-            </a:r>
-          </a:p>
-          <a:p>
-            <a:pPr lvl="0"/>
-            <a:r>
-              <a:rPr/>
-              <a:t>One environment </a:t>
-            </a:r>
-            <a:r>
-              <a:rPr b="1"/>
-              <a:t>per project</a:t>
-            </a:r>
-            <a:r>
-              <a:rPr/>
-              <a:t>, inside the project, in </a:t>
-            </a:r>
-            <a:r>
-              <a:rPr>
-                <a:latin typeface="Courier"/>
-              </a:rPr>
-              <a:t>.gitignore</a:t>
-            </a:r>
-          </a:p>
-        </p:txBody>
-      </p:sp>
-    </p:spTree>
-  </p:cSld>
-</p:sld>
-</file>
-
-<file path=ppt/slides/slide17.xml><?xml version="1.0" encoding="utf-8"?>
-<p:sld xmlns:a="http://schemas.openxmlformats.org/drawingml/2006/main" xmlns:r="http://schemas.openxmlformats.org/officeDocument/2006/relationships" xmlns:p="http://schemas.openxmlformats.org/presentationml/2006/main">
-  <p:cSld>
-    <p:spTree>
-      <p:nvGrpSpPr>
-        <p:cNvPr id="1" name=""/>
-        <p:cNvGrpSpPr/>
-        <p:nvPr/>
-      </p:nvGrpSpPr>
-      <p:grpSpPr>
-        <a:xfrm>
-          <a:off x="0" y="0"/>
-          <a:ext cx="0" cy="0"/>
-          <a:chOff x="0" y="0"/>
-          <a:chExt cx="0" cy="0"/>
-        </a:xfrm>
-      </p:grpSpPr>
-      <p:sp>
-        <p:nvSpPr>
-          <p:cNvPr id="2" name="Title 1"/>
-          <p:cNvSpPr>
-            <a:spLocks noGrp="1"/>
-          </p:cNvSpPr>
-          <p:nvPr>
-            <p:ph type="title"/>
-          </p:nvPr>
-        </p:nvSpPr>
-        <p:spPr/>
-        <p:txBody>
-          <a:bodyPr>
-            <a:normAutofit/>
-          </a:bodyPr>
-          <a:lstStyle/>
-          <a:p>
-            <a:pPr lvl="0" indent="0" marL="0">
-              <a:buNone/>
-            </a:pPr>
-            <a:r>
-              <a:rPr/>
-              <a:t>ruff</a:t>
-            </a:r>
-          </a:p>
-        </p:txBody>
-      </p:sp>
-      <p:sp>
-        <p:nvSpPr>
-          <p:cNvPr id="3" name="Content Placeholder 2"/>
-          <p:cNvSpPr>
-            <a:spLocks noGrp="1"/>
-          </p:cNvSpPr>
-          <p:nvPr>
-            <p:ph idx="1"/>
-          </p:nvPr>
-        </p:nvSpPr>
-        <p:spPr/>
-        <p:txBody>
-          <a:bodyPr>
-            <a:normAutofit/>
-          </a:bodyPr>
-          <a:lstStyle/>
-          <a:p>
-            <a:pPr lvl="0" indent="0" marL="0">
-              <a:buNone/>
-            </a:pPr>
-            <a:r>
-              <a:rPr>
-                <a:latin typeface="Courier"/>
-              </a:rPr>
-              <a:t>ruff</a:t>
-            </a:r>
-            <a:r>
-              <a:rPr/>
-              <a:t> is a </a:t>
-            </a:r>
-            <a:r>
-              <a:rPr b="1"/>
-              <a:t>linter</a:t>
-            </a:r>
-            <a:r>
-              <a:rPr/>
-              <a:t> (finds mistakes) and a </a:t>
-            </a:r>
-            <a:r>
-              <a:rPr b="1"/>
-              <a:t>formatter</a:t>
-            </a:r>
-            <a:r>
-              <a:rPr/>
-              <a:t> (fixes layout)</a:t>
-            </a:r>
-          </a:p>
-          <a:p>
-            <a:pPr lvl="0" indent="0">
-              <a:buNone/>
-            </a:pPr>
-            <a:r>
-              <a:rPr>
-                <a:latin typeface="Courier"/>
-              </a:rPr>
-              <a:t>uv tool install ruff     </a:t>
-            </a:r>
-            <a:r>
-              <a:rPr i="1">
-                <a:solidFill>
-                  <a:srgbClr val="60A0B0"/>
-                </a:solidFill>
-                <a:latin typeface="Courier"/>
-              </a:rPr>
-              <a:t># or: uv pip install ruff  /  python3 -m pip install ruff</a:t>
-            </a:r>
-            <a:br/>
-            <a:r>
-              <a:rPr>
-                <a:latin typeface="Courier"/>
-              </a:rPr>
-              <a:t>uvx ruff check .         </a:t>
-            </a:r>
-            <a:r>
-              <a:rPr i="1">
-                <a:solidFill>
-                  <a:srgbClr val="60A0B0"/>
-                </a:solidFill>
-                <a:latin typeface="Courier"/>
-              </a:rPr>
-              <a:t># run it once, installing nothing</a:t>
-            </a:r>
-            <a:br/>
-            <a:br/>
-            <a:r>
-              <a:rPr>
-                <a:latin typeface="Courier"/>
-              </a:rPr>
-              <a:t>ruff check .             </a:t>
-            </a:r>
-            <a:r>
-              <a:rPr i="1">
-                <a:solidFill>
-                  <a:srgbClr val="60A0B0"/>
-                </a:solidFill>
-                <a:latin typeface="Courier"/>
-              </a:rPr>
-              <a:t># unused imports, undefined names, dead code</a:t>
-            </a:r>
-            <a:br/>
-            <a:r>
-              <a:rPr>
-                <a:latin typeface="Courier"/>
-              </a:rPr>
-              <a:t>ruff check </a:t>
-            </a:r>
-            <a:r>
-              <a:rPr>
-                <a:solidFill>
-                  <a:srgbClr val="7D9029"/>
-                </a:solidFill>
-                <a:latin typeface="Courier"/>
-              </a:rPr>
-              <a:t>--fix</a:t>
-            </a:r>
-            <a:r>
-              <a:rPr>
-                <a:latin typeface="Courier"/>
-              </a:rPr>
-              <a:t> .       </a:t>
-            </a:r>
-            <a:r>
-              <a:rPr i="1">
-                <a:solidFill>
-                  <a:srgbClr val="60A0B0"/>
-                </a:solidFill>
-                <a:latin typeface="Courier"/>
-              </a:rPr>
-              <a:t># fix what can be fixed automatically</a:t>
-            </a:r>
-            <a:br/>
-            <a:r>
-              <a:rPr>
-                <a:latin typeface="Courier"/>
-              </a:rPr>
-              <a:t>ruff format .            </a:t>
-            </a:r>
-            <a:r>
-              <a:rPr i="1">
-                <a:solidFill>
-                  <a:srgbClr val="60A0B0"/>
-                </a:solidFill>
-                <a:latin typeface="Courier"/>
-              </a:rPr>
-              <a:t># one house style, no more debates about spacing</a:t>
-            </a:r>
-          </a:p>
-        </p:txBody>
-      </p:sp>
-    </p:spTree>
-  </p:cSld>
-</p:sld>
-</file>
-
 <file path=ppt/slides/slide2.xml><?xml version="1.0" encoding="utf-8"?>
 <p:sld xmlns:a="http://schemas.openxmlformats.org/drawingml/2006/main" xmlns:r="http://schemas.openxmlformats.org/officeDocument/2006/relationships" xmlns:p="http://schemas.openxmlformats.org/presentationml/2006/main">
   <p:cSld>
@@ -6293,12 +4734,7 @@
             <p:ph type="title"/>
           </p:nvPr>
         </p:nvSpPr>
-        <p:spPr>
-          <a:xfrm>
-            <a:off x="457201" y="204787"/>
-            <a:ext cx="3008313" cy="871538"/>
-          </a:xfrm>
-        </p:spPr>
+        <p:spPr/>
         <p:txBody>
           <a:bodyPr>
             <a:normAutofit/>
@@ -6310,51 +4746,14 @@
             </a:pPr>
             <a:r>
               <a:rPr/>
-              <a:t>Some (most) tasks are faster</a:t>
-            </a:r>
-          </a:p>
-        </p:txBody>
-      </p:sp>
-      <p:sp>
-        <p:nvSpPr>
-          <p:cNvPr id="4" name="Text Placeholder 3"/>
-          <p:cNvSpPr>
-            <a:spLocks noGrp="1"/>
-          </p:cNvSpPr>
-          <p:nvPr>
-            <p:ph idx="2" sz="half" type="body"/>
-          </p:nvPr>
-        </p:nvSpPr>
-        <p:spPr/>
-        <p:txBody>
-          <a:bodyPr anchor="ctr">
-            <a:normAutofit/>
-          </a:bodyPr>
-          <a:lstStyle/>
-          <a:p>
-            <a:pPr lvl="0" indent="0" marL="0" algn="ctr">
-              <a:buNone/>
-            </a:pPr>
-            <a:r>
-              <a:rPr sz="2000"/>
-              <a:t>You are handed 137 exported ECG files. How many mention </a:t>
-            </a:r>
-            <a:r>
-              <a:rPr sz="2000">
-                <a:latin typeface="Courier"/>
-              </a:rPr>
-              <a:t>ICU</a:t>
-            </a:r>
-            <a:r>
-              <a:rPr sz="2000"/>
-              <a:t>?</a:t>
+              <a:t>Most computers have no screen</a:t>
             </a:r>
           </a:p>
         </p:txBody>
       </p:sp>
       <p:pic>
         <p:nvPicPr>
-          <p:cNvPr descr="img/gui_vs_cli.png" id="0" name="Picture 1"/>
+          <p:cNvPr descr="img/datacenter.jpg" id="0" name="Picture 1"/>
           <p:cNvPicPr>
             <a:picLocks noGrp="1" noChangeAspect="1"/>
           </p:cNvPicPr>
@@ -6368,8 +4767,8 @@
         </p:blipFill>
         <p:spPr bwMode="auto">
           <a:xfrm>
-            <a:off x="3568700" y="1346200"/>
-            <a:ext cx="5105400" cy="2108200"/>
+            <a:off x="457200" y="1193800"/>
+            <a:ext cx="8229600" cy="3390900"/>
           </a:xfrm>
           <a:prstGeom prst="rect">
             <a:avLst/>
@@ -6426,113 +4825,41 @@
             </a:pPr>
             <a:r>
               <a:rPr/>
-              <a:t>Where you will actually meet it</a:t>
-            </a:r>
-          </a:p>
-        </p:txBody>
-      </p:sp>
-      <p:sp>
-        <p:nvSpPr>
-          <p:cNvPr id="3" name="Content Placeholder 2"/>
-          <p:cNvSpPr>
-            <a:spLocks noGrp="1"/>
-          </p:cNvSpPr>
-          <p:nvPr>
-            <p:ph idx="1"/>
-          </p:nvPr>
-        </p:nvSpPr>
-        <p:spPr/>
-        <p:txBody>
-          <a:bodyPr>
-            <a:normAutofit/>
-          </a:bodyPr>
-          <a:lstStyle/>
-          <a:p>
-            <a:pPr lvl="0"/>
-            <a:r>
-              <a:rPr b="1"/>
-              <a:t>Servers.</a:t>
-            </a:r>
-            <a:r>
-              <a:rPr/>
-              <a:t> Hospital data does not leave the building; you connect to a machine with </a:t>
-            </a:r>
-            <a:r>
-              <a:rPr>
-                <a:latin typeface="Courier"/>
-              </a:rPr>
-              <a:t>ssh</a:t>
-            </a:r>
-            <a:r>
-              <a:rPr/>
-              <a:t> and there is no desktop waiting for you</a:t>
-            </a:r>
-          </a:p>
-          <a:p>
-            <a:pPr lvl="0"/>
-            <a:r>
-              <a:rPr b="1"/>
-              <a:t>Pipelines.</a:t>
-            </a:r>
-            <a:r>
-              <a:rPr/>
-              <a:t> Imaging and omics tools (</a:t>
-            </a:r>
-            <a:r>
-              <a:rPr>
-                <a:latin typeface="Courier"/>
-              </a:rPr>
-              <a:t>dcm2niix</a:t>
-            </a:r>
-            <a:r>
-              <a:rPr/>
-              <a:t>, </a:t>
-            </a:r>
-            <a:r>
-              <a:rPr>
-                <a:latin typeface="Courier"/>
-              </a:rPr>
-              <a:t>fastqc</a:t>
-            </a:r>
-            <a:r>
-              <a:rPr/>
-              <a:t>, </a:t>
-            </a:r>
-            <a:r>
-              <a:rPr>
-                <a:latin typeface="Courier"/>
-              </a:rPr>
-              <a:t>samtools</a:t>
-            </a:r>
-            <a:r>
-              <a:rPr/>
-              <a:t>) ship as commands, not as apps</a:t>
-            </a:r>
-          </a:p>
-          <a:p>
-            <a:pPr lvl="0"/>
-            <a:r>
-              <a:rPr b="1"/>
-              <a:t>Reproducibility.</a:t>
-            </a:r>
-            <a:r>
-              <a:rPr/>
-              <a:t> There is no clicking error possible</a:t>
-            </a:r>
-          </a:p>
-          <a:p>
-            <a:pPr lvl="0"/>
-            <a:r>
-              <a:rPr b="1"/>
-              <a:t>Scale.</a:t>
-            </a:r>
-            <a:r>
-              <a:rPr/>
-              <a:t> The step between 1 file and 4 000 files should cost you one line</a:t>
-            </a:r>
-          </a:p>
-        </p:txBody>
-      </p:sp>
+              <a:t>Terminal, shell, program, kernel</a:t>
+            </a:r>
+          </a:p>
+        </p:txBody>
+      </p:sp>
+      <p:pic>
+        <p:nvPicPr>
+          <p:cNvPr descr="img/terminal_shell.png" id="0" name="Picture 1"/>
+          <p:cNvPicPr>
+            <a:picLocks noGrp="1" noChangeAspect="1"/>
+          </p:cNvPicPr>
+          <p:nvPr/>
+        </p:nvPicPr>
+        <p:blipFill>
+          <a:blip r:embed="rId3"/>
+          <a:stretch>
+            <a:fillRect/>
+          </a:stretch>
+        </p:blipFill>
+        <p:spPr bwMode="auto">
+          <a:xfrm>
+            <a:off x="457200" y="1193800"/>
+            <a:ext cx="8229600" cy="3390900"/>
+          </a:xfrm>
+          <a:prstGeom prst="rect">
+            <a:avLst/>
+          </a:prstGeom>
+          <a:noFill/>
+          <a:ln w="9525">
+            <a:noFill/>
+            <a:headEnd/>
+            <a:tailEnd/>
+          </a:ln>
+        </p:spPr>
+      </p:pic>
     </p:spTree>
   </p:cSld>
 </p:sld>
@@ -6577,14 +4904,14 @@
             </a:pPr>
             <a:r>
               <a:rPr/>
-              <a:t>Terminal, shell, program, kernel</a:t>
+              <a:t>The anatomy of a command</a:t>
             </a:r>
           </a:p>
         </p:txBody>
       </p:sp>
       <p:pic>
         <p:nvPicPr>
-          <p:cNvPr descr="img/terminal_shell.png" id="0" name="Picture 1"/>
+          <p:cNvPr descr="img/anatomy.png" id="0" name="Picture 1"/>
           <p:cNvPicPr>
             <a:picLocks noGrp="1" noChangeAspect="1"/>
           </p:cNvPicPr>
@@ -6644,7 +4971,12 @@
             <p:ph type="title"/>
           </p:nvPr>
         </p:nvSpPr>
-        <p:spPr/>
+        <p:spPr>
+          <a:xfrm>
+            <a:off x="722313" y="3305176"/>
+            <a:ext cx="7772400" cy="1021556"/>
+          </a:xfrm>
+        </p:spPr>
         <p:txBody>
           <a:bodyPr>
             <a:normAutofit/>
@@ -6656,101 +4988,17 @@
             </a:pPr>
             <a:r>
               <a:rPr/>
-              <a:t>The anatomy of a command</a:t>
-            </a:r>
-          </a:p>
-        </p:txBody>
-      </p:sp>
-      <p:pic>
-        <p:nvPicPr>
-          <p:cNvPr descr="img/anatomy.png" id="0" name="Picture 1"/>
-          <p:cNvPicPr>
-            <a:picLocks noGrp="1" noChangeAspect="1"/>
-          </p:cNvPicPr>
-          <p:nvPr/>
-        </p:nvPicPr>
-        <p:blipFill>
-          <a:blip r:embed="rId3"/>
-          <a:stretch>
-            <a:fillRect/>
-          </a:stretch>
-        </p:blipFill>
-        <p:spPr bwMode="auto">
-          <a:xfrm>
-            <a:off x="457200" y="1193800"/>
-            <a:ext cx="8229600" cy="3390900"/>
-          </a:xfrm>
-          <a:prstGeom prst="rect">
-            <a:avLst/>
-          </a:prstGeom>
-          <a:noFill/>
-          <a:ln w="9525">
-            <a:noFill/>
-            <a:headEnd/>
-            <a:tailEnd/>
-          </a:ln>
-        </p:spPr>
-      </p:pic>
+              <a:t>2. Moving around, and moving data</a:t>
+            </a:r>
+          </a:p>
+        </p:txBody>
+      </p:sp>
     </p:spTree>
   </p:cSld>
 </p:sld>
 </file>
 
 <file path=ppt/slides/slide7.xml><?xml version="1.0" encoding="utf-8"?>
-<p:sld xmlns:a="http://schemas.openxmlformats.org/drawingml/2006/main" xmlns:r="http://schemas.openxmlformats.org/officeDocument/2006/relationships" xmlns:p="http://schemas.openxmlformats.org/presentationml/2006/main">
-  <p:cSld>
-    <p:spTree>
-      <p:nvGrpSpPr>
-        <p:cNvPr id="1" name=""/>
-        <p:cNvGrpSpPr/>
-        <p:nvPr/>
-      </p:nvGrpSpPr>
-      <p:grpSpPr>
-        <a:xfrm>
-          <a:off x="0" y="0"/>
-          <a:ext cx="0" cy="0"/>
-          <a:chOff x="0" y="0"/>
-          <a:chExt cx="0" cy="0"/>
-        </a:xfrm>
-      </p:grpSpPr>
-      <p:sp>
-        <p:nvSpPr>
-          <p:cNvPr id="2" name="Title 1"/>
-          <p:cNvSpPr>
-            <a:spLocks noGrp="1"/>
-          </p:cNvSpPr>
-          <p:nvPr>
-            <p:ph type="title"/>
-          </p:nvPr>
-        </p:nvSpPr>
-        <p:spPr>
-          <a:xfrm>
-            <a:off x="722313" y="3305176"/>
-            <a:ext cx="7772400" cy="1021556"/>
-          </a:xfrm>
-        </p:spPr>
-        <p:txBody>
-          <a:bodyPr>
-            <a:normAutofit/>
-          </a:bodyPr>
-          <a:lstStyle/>
-          <a:p>
-            <a:pPr lvl="0" indent="0" marL="0">
-              <a:buNone/>
-            </a:pPr>
-            <a:r>
-              <a:rPr/>
-              <a:t>2. Moving around, and moving data</a:t>
-            </a:r>
-          </a:p>
-        </p:txBody>
-      </p:sp>
-    </p:spTree>
-  </p:cSld>
-</p:sld>
-</file>
-
-<file path=ppt/slides/slide8.xml><?xml version="1.0" encoding="utf-8"?>
 <p:sld xmlns:a="http://schemas.openxmlformats.org/drawingml/2006/main" xmlns:r="http://schemas.openxmlformats.org/officeDocument/2006/relationships" xmlns:p="http://schemas.openxmlformats.org/presentationml/2006/main">
   <p:cSld>
     <p:spTree>
@@ -6829,6 +5077,232 @@
 </p:sld>
 </file>
 
+<file path=ppt/slides/slide8.xml><?xml version="1.0" encoding="utf-8"?>
+<p:sld xmlns:a="http://schemas.openxmlformats.org/drawingml/2006/main" xmlns:r="http://schemas.openxmlformats.org/officeDocument/2006/relationships" xmlns:p="http://schemas.openxmlformats.org/presentationml/2006/main">
+  <p:cSld>
+    <p:spTree>
+      <p:nvGrpSpPr>
+        <p:cNvPr id="1" name=""/>
+        <p:cNvGrpSpPr/>
+        <p:nvPr/>
+      </p:nvGrpSpPr>
+      <p:grpSpPr>
+        <a:xfrm>
+          <a:off x="0" y="0"/>
+          <a:ext cx="0" cy="0"/>
+          <a:chOff x="0" y="0"/>
+          <a:chExt cx="0" cy="0"/>
+        </a:xfrm>
+      </p:grpSpPr>
+      <p:sp>
+        <p:nvSpPr>
+          <p:cNvPr id="2" name="Title 1"/>
+          <p:cNvSpPr>
+            <a:spLocks noGrp="1"/>
+          </p:cNvSpPr>
+          <p:nvPr>
+            <p:ph type="title"/>
+          </p:nvPr>
+        </p:nvSpPr>
+        <p:spPr/>
+        <p:txBody>
+          <a:bodyPr>
+            <a:normAutofit/>
+          </a:bodyPr>
+          <a:lstStyle/>
+          <a:p>
+            <a:pPr lvl="0" indent="0" marL="0">
+              <a:buNone/>
+            </a:pPr>
+            <a:r>
+              <a:rPr/>
+              <a:t>Five most usefull commands</a:t>
+            </a:r>
+          </a:p>
+        </p:txBody>
+      </p:sp>
+      <p:sp>
+        <p:nvSpPr>
+          <p:cNvPr id="3" name="Content Placeholder 2"/>
+          <p:cNvSpPr>
+            <a:spLocks noGrp="1"/>
+          </p:cNvSpPr>
+          <p:nvPr>
+            <p:ph idx="1"/>
+          </p:nvPr>
+        </p:nvSpPr>
+        <p:spPr/>
+        <p:txBody>
+          <a:bodyPr>
+            <a:normAutofit/>
+          </a:bodyPr>
+          <a:lstStyle/>
+          <a:p>
+            <a:pPr lvl="0" indent="0">
+              <a:buNone/>
+            </a:pPr>
+            <a:r>
+              <a:rPr>
+                <a:solidFill>
+                  <a:srgbClr val="008000"/>
+                </a:solidFill>
+                <a:latin typeface="Courier"/>
+              </a:rPr>
+              <a:t>pwd</a:t>
+            </a:r>
+            <a:r>
+              <a:rPr>
+                <a:latin typeface="Courier"/>
+              </a:rPr>
+              <a:t>                     </a:t>
+            </a:r>
+            <a:r>
+              <a:rPr i="1">
+                <a:solidFill>
+                  <a:srgbClr val="60A0B0"/>
+                </a:solidFill>
+                <a:latin typeface="Courier"/>
+              </a:rPr>
+              <a:t># where am I</a:t>
+            </a:r>
+            <a:br/>
+            <a:r>
+              <a:rPr>
+                <a:solidFill>
+                  <a:srgbClr val="008000"/>
+                </a:solidFill>
+                <a:latin typeface="Courier"/>
+              </a:rPr>
+              <a:t>cd</a:t>
+            </a:r>
+            <a:r>
+              <a:rPr>
+                <a:latin typeface="Courier"/>
+              </a:rPr>
+              <a:t> data/ecg             </a:t>
+            </a:r>
+            <a:r>
+              <a:rPr i="1">
+                <a:solidFill>
+                  <a:srgbClr val="60A0B0"/>
+                </a:solidFill>
+                <a:latin typeface="Courier"/>
+              </a:rPr>
+              <a:t># go there  (cd ..  goes up, cd  goes home)</a:t>
+            </a:r>
+            <a:br/>
+            <a:r>
+              <a:rPr>
+                <a:solidFill>
+                  <a:srgbClr val="06287E"/>
+                </a:solidFill>
+                <a:latin typeface="Courier"/>
+              </a:rPr>
+              <a:t>ls</a:t>
+            </a:r>
+            <a:r>
+              <a:rPr>
+                <a:latin typeface="Courier"/>
+              </a:rPr>
+              <a:t> </a:t>
+            </a:r>
+            <a:r>
+              <a:rPr>
+                <a:solidFill>
+                  <a:srgbClr val="7D9029"/>
+                </a:solidFill>
+                <a:latin typeface="Courier"/>
+              </a:rPr>
+              <a:t>-lh</a:t>
+            </a:r>
+            <a:r>
+              <a:rPr>
+                <a:latin typeface="Courier"/>
+              </a:rPr>
+              <a:t>                  </a:t>
+            </a:r>
+            <a:r>
+              <a:rPr i="1">
+                <a:solidFill>
+                  <a:srgbClr val="60A0B0"/>
+                </a:solidFill>
+                <a:latin typeface="Courier"/>
+              </a:rPr>
+              <a:t># what is here, with sizes</a:t>
+            </a:r>
+            <a:br/>
+            <a:r>
+              <a:rPr>
+                <a:solidFill>
+                  <a:srgbClr val="06287E"/>
+                </a:solidFill>
+                <a:latin typeface="Courier"/>
+              </a:rPr>
+              <a:t>mkdir</a:t>
+            </a:r>
+            <a:r>
+              <a:rPr>
+                <a:latin typeface="Courier"/>
+              </a:rPr>
+              <a:t> </a:t>
+            </a:r>
+            <a:r>
+              <a:rPr>
+                <a:solidFill>
+                  <a:srgbClr val="7D9029"/>
+                </a:solidFill>
+                <a:latin typeface="Courier"/>
+              </a:rPr>
+              <a:t>-p</a:t>
+            </a:r>
+            <a:r>
+              <a:rPr>
+                <a:latin typeface="Courier"/>
+              </a:rPr>
+              <a:t> results/2026   </a:t>
+            </a:r>
+            <a:r>
+              <a:rPr i="1">
+                <a:solidFill>
+                  <a:srgbClr val="60A0B0"/>
+                </a:solidFill>
+                <a:latin typeface="Courier"/>
+              </a:rPr>
+              <a:t># make a folder (and its parents)</a:t>
+            </a:r>
+            <a:br/>
+            <a:r>
+              <a:rPr>
+                <a:solidFill>
+                  <a:srgbClr val="06287E"/>
+                </a:solidFill>
+                <a:latin typeface="Courier"/>
+              </a:rPr>
+              <a:t>cp</a:t>
+            </a:r>
+            <a:r>
+              <a:rPr>
+                <a:latin typeface="Courier"/>
+              </a:rPr>
+              <a:t> a.csv backup/        </a:t>
+            </a:r>
+            <a:r>
+              <a:rPr i="1">
+                <a:solidFill>
+                  <a:srgbClr val="60A0B0"/>
+                </a:solidFill>
+                <a:latin typeface="Courier"/>
+              </a:rPr>
+              <a:t># copy      (mv = move / rename, rm = delete)</a:t>
+            </a:r>
+          </a:p>
+        </p:txBody>
+      </p:sp>
+    </p:spTree>
+  </p:cSld>
+</p:sld>
+</file>
+
 <file path=ppt/slides/slide9.xml><?xml version="1.0" encoding="utf-8"?>
 <p:sld xmlns:a="http://schemas.openxmlformats.org/drawingml/2006/main" xmlns:r="http://schemas.openxmlformats.org/officeDocument/2006/relationships" xmlns:p="http://schemas.openxmlformats.org/presentationml/2006/main">
   <p:cSld>
@@ -6868,188 +5342,41 @@
             </a:pPr>
             <a:r>
               <a:rPr/>
-              <a:t>Five most usefull commands</a:t>
-            </a:r>
-          </a:p>
-        </p:txBody>
-      </p:sp>
-      <p:sp>
-        <p:nvSpPr>
-          <p:cNvPr id="3" name="Content Placeholder 2"/>
-          <p:cNvSpPr>
-            <a:spLocks noGrp="1"/>
-          </p:cNvSpPr>
-          <p:nvPr>
-            <p:ph idx="1"/>
-          </p:nvPr>
-        </p:nvSpPr>
-        <p:spPr/>
-        <p:txBody>
-          <a:bodyPr>
-            <a:normAutofit/>
-          </a:bodyPr>
-          <a:lstStyle/>
-          <a:p>
-            <a:pPr lvl="0" indent="0">
-              <a:buNone/>
-            </a:pPr>
-            <a:r>
-              <a:rPr>
-                <a:solidFill>
-                  <a:srgbClr val="008000"/>
-                </a:solidFill>
-                <a:latin typeface="Courier"/>
-              </a:rPr>
-              <a:t>pwd</a:t>
-            </a:r>
-            <a:r>
-              <a:rPr>
-                <a:latin typeface="Courier"/>
-              </a:rPr>
-              <a:t>                     </a:t>
-            </a:r>
-            <a:r>
-              <a:rPr i="1">
-                <a:solidFill>
-                  <a:srgbClr val="60A0B0"/>
-                </a:solidFill>
-                <a:latin typeface="Courier"/>
-              </a:rPr>
-              <a:t># where am I</a:t>
-            </a:r>
-            <a:br/>
-            <a:r>
-              <a:rPr>
-                <a:solidFill>
-                  <a:srgbClr val="008000"/>
-                </a:solidFill>
-                <a:latin typeface="Courier"/>
-              </a:rPr>
-              <a:t>cd</a:t>
-            </a:r>
-            <a:r>
-              <a:rPr>
-                <a:latin typeface="Courier"/>
-              </a:rPr>
-              <a:t> data/ecg             </a:t>
-            </a:r>
-            <a:r>
-              <a:rPr i="1">
-                <a:solidFill>
-                  <a:srgbClr val="60A0B0"/>
-                </a:solidFill>
-                <a:latin typeface="Courier"/>
-              </a:rPr>
-              <a:t># go there  (cd ..  goes up, cd  goes home)</a:t>
-            </a:r>
-            <a:br/>
-            <a:r>
-              <a:rPr>
-                <a:solidFill>
-                  <a:srgbClr val="06287E"/>
-                </a:solidFill>
-                <a:latin typeface="Courier"/>
-              </a:rPr>
-              <a:t>ls</a:t>
-            </a:r>
-            <a:r>
-              <a:rPr>
-                <a:latin typeface="Courier"/>
-              </a:rPr>
-              <a:t> </a:t>
-            </a:r>
-            <a:r>
-              <a:rPr>
-                <a:solidFill>
-                  <a:srgbClr val="7D9029"/>
-                </a:solidFill>
-                <a:latin typeface="Courier"/>
-              </a:rPr>
-              <a:t>-lh</a:t>
-            </a:r>
-            <a:r>
-              <a:rPr>
-                <a:latin typeface="Courier"/>
-              </a:rPr>
-              <a:t>                  </a:t>
-            </a:r>
-            <a:r>
-              <a:rPr i="1">
-                <a:solidFill>
-                  <a:srgbClr val="60A0B0"/>
-                </a:solidFill>
-                <a:latin typeface="Courier"/>
-              </a:rPr>
-              <a:t># what is here, with sizes</a:t>
-            </a:r>
-            <a:br/>
-            <a:r>
-              <a:rPr>
-                <a:solidFill>
-                  <a:srgbClr val="06287E"/>
-                </a:solidFill>
-                <a:latin typeface="Courier"/>
-              </a:rPr>
-              <a:t>mkdir</a:t>
-            </a:r>
-            <a:r>
-              <a:rPr>
-                <a:latin typeface="Courier"/>
-              </a:rPr>
-              <a:t> </a:t>
-            </a:r>
-            <a:r>
-              <a:rPr>
-                <a:solidFill>
-                  <a:srgbClr val="7D9029"/>
-                </a:solidFill>
-                <a:latin typeface="Courier"/>
-              </a:rPr>
-              <a:t>-p</a:t>
-            </a:r>
-            <a:r>
-              <a:rPr>
-                <a:latin typeface="Courier"/>
-              </a:rPr>
-              <a:t> results/2026   </a:t>
-            </a:r>
-            <a:r>
-              <a:rPr i="1">
-                <a:solidFill>
-                  <a:srgbClr val="60A0B0"/>
-                </a:solidFill>
-                <a:latin typeface="Courier"/>
-              </a:rPr>
-              <a:t># make a folder (and its parents)</a:t>
-            </a:r>
-            <a:br/>
-            <a:r>
-              <a:rPr>
-                <a:solidFill>
-                  <a:srgbClr val="06287E"/>
-                </a:solidFill>
-                <a:latin typeface="Courier"/>
-              </a:rPr>
-              <a:t>cp</a:t>
-            </a:r>
-            <a:r>
-              <a:rPr>
-                <a:latin typeface="Courier"/>
-              </a:rPr>
-              <a:t> a.csv backup/        </a:t>
-            </a:r>
-            <a:r>
-              <a:rPr i="1">
-                <a:solidFill>
-                  <a:srgbClr val="60A0B0"/>
-                </a:solidFill>
-                <a:latin typeface="Courier"/>
-              </a:rPr>
-              <a:t># copy      (mv = move / rename, rm = delete)</a:t>
-            </a:r>
-          </a:p>
-        </p:txBody>
-      </p:sp>
+              <a:t>Text in, text out</a:t>
+            </a:r>
+          </a:p>
+        </p:txBody>
+      </p:sp>
+      <p:pic>
+        <p:nvPicPr>
+          <p:cNvPr descr="img/pipeline.png" id="0" name="Picture 1"/>
+          <p:cNvPicPr>
+            <a:picLocks noGrp="1" noChangeAspect="1"/>
+          </p:cNvPicPr>
+          <p:nvPr/>
+        </p:nvPicPr>
+        <p:blipFill>
+          <a:blip r:embed="rId3"/>
+          <a:stretch>
+            <a:fillRect/>
+          </a:stretch>
+        </p:blipFill>
+        <p:spPr bwMode="auto">
+          <a:xfrm>
+            <a:off x="457200" y="1193800"/>
+            <a:ext cx="8229600" cy="3390900"/>
+          </a:xfrm>
+          <a:prstGeom prst="rect">
+            <a:avLst/>
+          </a:prstGeom>
+          <a:noFill/>
+          <a:ln w="9525">
+            <a:noFill/>
+            <a:headEnd/>
+            <a:tailEnd/>
+          </a:ln>
+        </p:spPr>
+      </p:pic>
     </p:spTree>
   </p:cSld>
 </p:sld>

</xml_diff>

<commit_message>
added details slides on numpy dtype
</commit_message>
<xml_diff>
--- a/Programming01/Session01/slides.pptx
+++ b/Programming01/Session01/slides.pptx
@@ -5,7 +5,7 @@
     <p:sldMasterId id="2147483648" r:id="rId1"/>
   </p:sldMasterIdLst>
   <p:notesMasterIdLst>
-    <p:notesMasterId r:id="rId36"/>
+    <p:notesMasterId r:id="rId41"/>
   </p:notesMasterIdLst>
   <p:sldIdLst>
     <p:sldId id="256" r:id="rId2"/>
@@ -42,6 +42,11 @@
     <p:sldId id="287" r:id="rId33"/>
     <p:sldId id="288" r:id="rId34"/>
     <p:sldId id="289" r:id="rId35"/>
+    <p:sldId id="290" r:id="rId36"/>
+    <p:sldId id="291" r:id="rId37"/>
+    <p:sldId id="292" r:id="rId38"/>
+    <p:sldId id="293" r:id="rId39"/>
+    <p:sldId id="294" r:id="rId40"/>
   </p:sldIdLst>
   <p:sldSz cx="9144000" cy="5143500" type="screen16x9"/>
   <p:notesSz cx="6858000" cy="9144000"/>
@@ -2160,54 +2165,128 @@
               <a:buNone/>
             </a:pPr>
             <a:r>
-              <a:rPr>
-                <a:latin typeface="Courier"/>
-              </a:rPr>
-              <a:t>np</a:t>
-            </a:r>
-            <a:r>
-              <a:rPr/>
-              <a:t> is the universal alias; every tutorial, answer and library uses it. </a:t>
-            </a:r>
-            <a:r>
-              <a:rPr>
-                <a:latin typeface="Courier"/>
-              </a:rPr>
-              <a:t>arange</a:t>
-            </a:r>
-            <a:r>
-              <a:rPr/>
-              <a:t> works like </a:t>
-            </a:r>
-            <a:r>
-              <a:rPr>
-                <a:latin typeface="Courier"/>
-              </a:rPr>
-              <a:t>range</a:t>
-            </a:r>
-            <a:r>
-              <a:rPr/>
-              <a:t> (end excluded); </a:t>
-            </a:r>
-            <a:r>
-              <a:rPr>
-                <a:latin typeface="Courier"/>
-              </a:rPr>
-              <a:t>linspace</a:t>
-            </a:r>
-            <a:r>
-              <a:rPr/>
-              <a:t> takes a number of points and includes the end. </a:t>
-            </a:r>
-            <a:r>
-              <a:rPr>
-                <a:latin typeface="Courier"/>
-              </a:rPr>
-              <a:t>reshape</a:t>
-            </a:r>
-            <a:r>
-              <a:rPr/>
-              <a:t> rearranges without copying, as long as the sizes match: 12 values cannot become 5 x 2. Random numbers: always use a seeded generator, so the same script gives the same result tomorrow and on your colleague’s machine. That is reproducibility at the smallest scale.</a:t>
+              <a:rPr/>
+              <a:t>Python has one </a:t>
+            </a:r>
+            <a:r>
+              <a:rPr>
+                <a:latin typeface="Courier"/>
+              </a:rPr>
+              <a:t>int</a:t>
+            </a:r>
+            <a:r>
+              <a:rPr/>
+              <a:t> and one </a:t>
+            </a:r>
+            <a:r>
+              <a:rPr>
+                <a:latin typeface="Courier"/>
+              </a:rPr>
+              <a:t>float</a:t>
+            </a:r>
+            <a:r>
+              <a:rPr/>
+              <a:t>. NumPy has a family of each, with a fixed size in bytes, because every cell of an array must have the same size for the block of memory to work. The number in the name is the number of bits: </a:t>
+            </a:r>
+            <a:r>
+              <a:rPr>
+                <a:latin typeface="Courier"/>
+              </a:rPr>
+              <a:t>int16</a:t>
+            </a:r>
+            <a:r>
+              <a:rPr/>
+              <a:t> is 16 bits, 2 bytes. </a:t>
+            </a:r>
+            <a:r>
+              <a:rPr>
+                <a:latin typeface="Courier"/>
+              </a:rPr>
+              <a:t>u</a:t>
+            </a:r>
+            <a:r>
+              <a:rPr/>
+              <a:t> means unsigned (no negative values). You rarely pick: </a:t>
+            </a:r>
+            <a:r>
+              <a:rPr>
+                <a:latin typeface="Courier"/>
+              </a:rPr>
+              <a:t>np.array</a:t>
+            </a:r>
+            <a:r>
+              <a:rPr/>
+              <a:t> chooses </a:t>
+            </a:r>
+            <a:r>
+              <a:rPr>
+                <a:latin typeface="Courier"/>
+              </a:rPr>
+              <a:t>int64</a:t>
+            </a:r>
+            <a:r>
+              <a:rPr/>
+              <a:t> or </a:t>
+            </a:r>
+            <a:r>
+              <a:rPr>
+                <a:latin typeface="Courier"/>
+              </a:rPr>
+              <a:t>float64</a:t>
+            </a:r>
+            <a:r>
+              <a:rPr/>
+              <a:t>. But the files you read pick for you: a DICOM CT is usually </a:t>
+            </a:r>
+            <a:r>
+              <a:rPr>
+                <a:latin typeface="Courier"/>
+              </a:rPr>
+              <a:t>int16</a:t>
+            </a:r>
+            <a:r>
+              <a:rPr/>
+              <a:t>, a PNG </a:t>
+            </a:r>
+            <a:r>
+              <a:rPr>
+                <a:latin typeface="Courier"/>
+              </a:rPr>
+              <a:t>uint8</a:t>
+            </a:r>
+            <a:r>
+              <a:rPr/>
+              <a:t>, a NIfTI often </a:t>
+            </a:r>
+            <a:r>
+              <a:rPr>
+                <a:latin typeface="Courier"/>
+              </a:rPr>
+              <a:t>float32</a:t>
+            </a:r>
+            <a:r>
+              <a:rPr/>
+              <a:t>, and a deep learning model </a:t>
+            </a:r>
+            <a:r>
+              <a:rPr>
+                <a:latin typeface="Courier"/>
+              </a:rPr>
+              <a:t>float32</a:t>
+            </a:r>
+            <a:r>
+              <a:rPr/>
+              <a:t> or less. Always print </a:t>
+            </a:r>
+            <a:r>
+              <a:rPr>
+                <a:latin typeface="Courier"/>
+              </a:rPr>
+              <a:t>.dtype</a:t>
+            </a:r>
+            <a:r>
+              <a:rPr/>
+              <a:t> after loading data.</a:t>
             </a:r>
           </a:p>
         </p:txBody>
@@ -2289,87 +2368,77 @@
             </a:pPr>
             <a:r>
               <a:rPr/>
-              <a:t>Same grammar as lists and strings, with one index per axis, separated by a comma: </a:t>
-            </a:r>
-            <a:r>
-              <a:rPr>
-                <a:latin typeface="Courier"/>
-              </a:rPr>
-              <a:t>y[row, col]</a:t>
-            </a:r>
-            <a:r>
-              <a:rPr/>
-              <a:t>. A </a:t>
-            </a:r>
-            <a:r>
-              <a:rPr>
-                <a:latin typeface="Courier"/>
-              </a:rPr>
-              <a:t>:</a:t>
-            </a:r>
-            <a:r>
-              <a:rPr/>
-              <a:t> alone means “everything along this axis”. </a:t>
-            </a:r>
-            <a:r>
-              <a:rPr>
-                <a:latin typeface="Courier"/>
-              </a:rPr>
-              <a:t>y[1]</a:t>
-            </a:r>
-            <a:r>
-              <a:rPr/>
-              <a:t> is a whole row; </a:t>
-            </a:r>
-            <a:r>
-              <a:rPr>
-                <a:latin typeface="Courier"/>
-              </a:rPr>
-              <a:t>y[:, 2]</a:t>
-            </a:r>
-            <a:r>
-              <a:rPr/>
-              <a:t> a whole column (the thing lists of lists cannot do). Slices of an array are views, not copies: writing into </a:t>
-            </a:r>
-            <a:r>
-              <a:rPr>
-                <a:latin typeface="Courier"/>
-              </a:rPr>
-              <a:t>y[:2, :2]</a:t>
-            </a:r>
-            <a:r>
-              <a:rPr/>
-              <a:t> changes </a:t>
-            </a:r>
-            <a:r>
-              <a:rPr>
-                <a:latin typeface="Courier"/>
-              </a:rPr>
-              <a:t>y</a:t>
-            </a:r>
-            <a:r>
-              <a:rPr/>
-              <a:t>. This is the aliasing of the previous section again; use </a:t>
-            </a:r>
-            <a:r>
-              <a:rPr>
-                <a:latin typeface="Courier"/>
-              </a:rPr>
-              <a:t>.copy()</a:t>
-            </a:r>
-            <a:r>
-              <a:rPr/>
-              <a:t> when you want independence. Assignment works on whole slices: </a:t>
-            </a:r>
-            <a:r>
-              <a:rPr>
-                <a:latin typeface="Courier"/>
-              </a:rPr>
-              <a:t>t[:, 1] = 0</a:t>
-            </a:r>
-            <a:r>
-              <a:rPr/>
-              <a:t> sets a column at once.</a:t>
+              <a:t>A float is scientific notation in binary: a sign, an exponent (where the point goes: the range) and a mantissa (the significant digits: the precision). Halving the size costs both. </a:t>
+            </a:r>
+            <a:r>
+              <a:rPr>
+                <a:latin typeface="Courier"/>
+              </a:rPr>
+              <a:t>float32</a:t>
+            </a:r>
+            <a:r>
+              <a:rPr/>
+              <a:t> keeps 7 digits, plenty for any measurement made in a hospital. </a:t>
+            </a:r>
+            <a:r>
+              <a:rPr>
+                <a:latin typeface="Courier"/>
+              </a:rPr>
+              <a:t>float16</a:t>
+            </a:r>
+            <a:r>
+              <a:rPr/>
+              <a:t> keeps 3 digits and cannot go above 65 504. </a:t>
+            </a:r>
+            <a:r>
+              <a:rPr>
+                <a:latin typeface="Courier"/>
+              </a:rPr>
+              <a:t>float8</a:t>
+            </a:r>
+            <a:r>
+              <a:rPr/>
+              <a:t> keeps about one digit; it exists for deep learning on recent GPUs (two variants: e4m3 for precision, e5m2 for range). NumPy itself stops at </a:t>
+            </a:r>
+            <a:r>
+              <a:rPr>
+                <a:latin typeface="Courier"/>
+              </a:rPr>
+              <a:t>float16</a:t>
+            </a:r>
+            <a:r>
+              <a:rPr/>
+              <a:t>: </a:t>
+            </a:r>
+            <a:r>
+              <a:rPr>
+                <a:latin typeface="Courier"/>
+              </a:rPr>
+              <a:t>float8</a:t>
+            </a:r>
+            <a:r>
+              <a:rPr/>
+              <a:t> comes from the </a:t>
+            </a:r>
+            <a:r>
+              <a:rPr>
+                <a:latin typeface="Courier"/>
+              </a:rPr>
+              <a:t>ml_dtypes</a:t>
+            </a:r>
+            <a:r>
+              <a:rPr/>
+              <a:t> package or from </a:t>
+            </a:r>
+            <a:r>
+              <a:rPr>
+                <a:latin typeface="Courier"/>
+              </a:rPr>
+              <a:t>torch.float8_e4m3fn</a:t>
+            </a:r>
+            <a:r>
+              <a:rPr/>
+              <a:t>.</a:t>
             </a:r>
           </a:p>
         </p:txBody>
@@ -2451,77 +2520,47 @@
             </a:pPr>
             <a:r>
               <a:rPr/>
-              <a:t>Every arithmetic operator and every </a:t>
-            </a:r>
-            <a:r>
-              <a:rPr>
-                <a:latin typeface="Courier"/>
-              </a:rPr>
-              <a:t>np.</a:t>
-            </a:r>
-            <a:r>
-              <a:rPr/>
-              <a:t> maths function applies to each element: this is vectorization, and it is the whole style of numpy, pandas and torch. If you write a </a:t>
-            </a:r>
-            <a:r>
-              <a:rPr>
-                <a:latin typeface="Courier"/>
-              </a:rPr>
-              <a:t>for</a:t>
-            </a:r>
-            <a:r>
-              <a:rPr/>
-              <a:t> loop over the elements of an array, there is almost always a one-liner instead. Careful with </a:t>
-            </a:r>
-            <a:r>
-              <a:rPr>
-                <a:latin typeface="Courier"/>
-              </a:rPr>
-              <a:t>*</a:t>
-            </a:r>
-            <a:r>
-              <a:rPr/>
-              <a:t>: on arrays it multiplies element by element. The matrix product is </a:t>
-            </a:r>
-            <a:r>
-              <a:rPr>
-                <a:latin typeface="Courier"/>
-              </a:rPr>
-              <a:t>@</a:t>
-            </a:r>
-            <a:r>
-              <a:rPr/>
-              <a:t>. Compare with lists: </a:t>
-            </a:r>
-            <a:r>
-              <a:rPr>
-                <a:latin typeface="Courier"/>
-              </a:rPr>
-              <a:t>[1, 2] * 2</a:t>
-            </a:r>
-            <a:r>
-              <a:rPr/>
-              <a:t> is </a:t>
-            </a:r>
-            <a:r>
-              <a:rPr>
-                <a:latin typeface="Courier"/>
-              </a:rPr>
-              <a:t>[1, 2, 1, 2]</a:t>
-            </a:r>
-            <a:r>
-              <a:rPr/>
-              <a:t>, and </a:t>
-            </a:r>
-            <a:r>
-              <a:rPr>
-                <a:latin typeface="Courier"/>
-              </a:rPr>
-              <a:t>[1, 2] + [3]</a:t>
-            </a:r>
-            <a:r>
-              <a:rPr/>
-              <a:t> concatenates. Same symbol, different type, different meaning.</a:t>
+              <a:t>Every number on this slide was computed by numpy, not typed by hand. </a:t>
+            </a:r>
+            <a:r>
+              <a:rPr>
+                <a:latin typeface="Courier"/>
+              </a:rPr>
+              <a:t>float64</a:t>
+            </a:r>
+            <a:r>
+              <a:rPr/>
+              <a:t> and </a:t>
+            </a:r>
+            <a:r>
+              <a:rPr>
+                <a:latin typeface="Courier"/>
+              </a:rPr>
+              <a:t>float32</a:t>
+            </a:r>
+            <a:r>
+              <a:rPr/>
+              <a:t> agree to well beyond what a thermometer measures. </a:t>
+            </a:r>
+            <a:r>
+              <a:rPr>
+                <a:latin typeface="Courier"/>
+              </a:rPr>
+              <a:t>float16</a:t>
+            </a:r>
+            <a:r>
+              <a:rPr/>
+              <a:t> starts to show: 38.40625 instead of 38.4, harmless for a temperature, but the error grows with the value (1000.4 becomes 1000.5: the gap between two float16 neighbours near 1000 is 0.5). </a:t>
+            </a:r>
+            <a:r>
+              <a:rPr>
+                <a:latin typeface="Courier"/>
+              </a:rPr>
+              <a:t>float8</a:t>
+            </a:r>
+            <a:r>
+              <a:rPr/>
+              <a:t> turns a 38.4 °C fever into 40 °C, and a platelet count of 1000 into “not a number”. It is a format for neural network weights, which tolerate noise, not for clinical data.</a:t>
             </a:r>
           </a:p>
         </p:txBody>
@@ -2603,87 +2642,97 @@
             </a:pPr>
             <a:r>
               <a:rPr/>
-              <a:t>When the shapes differ, numpy stretches the smaller array along the missing axis, as if it were repeated (it is not actually copied). </a:t>
-            </a:r>
-            <a:r>
-              <a:rPr>
-                <a:latin typeface="Courier"/>
-              </a:rPr>
-              <a:t>x + 10</a:t>
-            </a:r>
-            <a:r>
-              <a:rPr/>
-              <a:t> was already broadcasting: a scalar stretched to every cell. The rule: compare shapes from the right; each pair of sizes must be equal, or one of them must be 1. </a:t>
-            </a:r>
-            <a:r>
-              <a:rPr>
-                <a:latin typeface="Courier"/>
-              </a:rPr>
-              <a:t>(3, 4)</a:t>
-            </a:r>
-            <a:r>
-              <a:rPr/>
-              <a:t> and </a:t>
-            </a:r>
-            <a:r>
-              <a:rPr>
-                <a:latin typeface="Courier"/>
-              </a:rPr>
-              <a:t>(4,)</a:t>
-            </a:r>
-            <a:r>
-              <a:rPr/>
-              <a:t> match. </a:t>
-            </a:r>
-            <a:r>
-              <a:rPr>
-                <a:latin typeface="Courier"/>
-              </a:rPr>
-              <a:t>(3, 4)</a:t>
-            </a:r>
-            <a:r>
-              <a:rPr/>
-              <a:t> and </a:t>
-            </a:r>
-            <a:r>
-              <a:rPr>
-                <a:latin typeface="Courier"/>
-              </a:rPr>
-              <a:t>(3,)</a:t>
-            </a:r>
-            <a:r>
-              <a:rPr/>
-              <a:t> do not: to add one value per row, make it a column, shape </a:t>
-            </a:r>
-            <a:r>
-              <a:rPr>
-                <a:latin typeface="Courier"/>
-              </a:rPr>
-              <a:t>(3, 1)</a:t>
-            </a:r>
-            <a:r>
-              <a:rPr/>
-              <a:t>, with </a:t>
-            </a:r>
-            <a:r>
-              <a:rPr>
-                <a:latin typeface="Courier"/>
-              </a:rPr>
-              <a:t>.reshape(3, 1)</a:t>
-            </a:r>
-            <a:r>
-              <a:rPr/>
-              <a:t> or </a:t>
-            </a:r>
-            <a:r>
-              <a:rPr>
-                <a:latin typeface="Courier"/>
-              </a:rPr>
-              <a:t>v[:, None]</a:t>
-            </a:r>
-            <a:r>
-              <a:rPr/>
-              <a:t>. Typical use: subtracting the mean of each column from a table, in one line.</a:t>
+              <a:t>Memory is bytes per value times number of values. One CT volume is 79 million voxels: 629 MB in </a:t>
+            </a:r>
+            <a:r>
+              <a:rPr>
+                <a:latin typeface="Courier"/>
+              </a:rPr>
+              <a:t>float64</a:t>
+            </a:r>
+            <a:r>
+              <a:rPr/>
+              <a:t>, 315 MB in </a:t>
+            </a:r>
+            <a:r>
+              <a:rPr>
+                <a:latin typeface="Courier"/>
+              </a:rPr>
+              <a:t>float32</a:t>
+            </a:r>
+            <a:r>
+              <a:rPr/>
+              <a:t>. A batch of scans for training does not fit on a GPU in </a:t>
+            </a:r>
+            <a:r>
+              <a:rPr>
+                <a:latin typeface="Courier"/>
+              </a:rPr>
+              <a:t>float64</a:t>
+            </a:r>
+            <a:r>
+              <a:rPr/>
+              <a:t>. Fewer bytes also means faster: more values per memory transfer, and GPUs have dedicated hardware for 16 and 8 bit arithmetic. This is why deep learning trains in </a:t>
+            </a:r>
+            <a:r>
+              <a:rPr>
+                <a:latin typeface="Courier"/>
+              </a:rPr>
+              <a:t>float32</a:t>
+            </a:r>
+            <a:r>
+              <a:rPr/>
+              <a:t> or “mixed precision” (</a:t>
+            </a:r>
+            <a:r>
+              <a:rPr>
+                <a:latin typeface="Courier"/>
+              </a:rPr>
+              <a:t>float16</a:t>
+            </a:r>
+            <a:r>
+              <a:rPr/>
+              <a:t>/</a:t>
+            </a:r>
+            <a:r>
+              <a:rPr>
+                <a:latin typeface="Courier"/>
+              </a:rPr>
+              <a:t>bfloat16</a:t>
+            </a:r>
+            <a:r>
+              <a:rPr/>
+              <a:t> for the bulk, </a:t>
+            </a:r>
+            <a:r>
+              <a:rPr>
+                <a:latin typeface="Courier"/>
+              </a:rPr>
+              <a:t>float32</a:t>
+            </a:r>
+            <a:r>
+              <a:rPr/>
+              <a:t> where it matters), and runs large models in 8 bits or less. The rule for this course: </a:t>
+            </a:r>
+            <a:r>
+              <a:rPr>
+                <a:latin typeface="Courier"/>
+              </a:rPr>
+              <a:t>float64</a:t>
+            </a:r>
+            <a:r>
+              <a:rPr/>
+              <a:t> for statistics and tables, </a:t>
+            </a:r>
+            <a:r>
+              <a:rPr>
+                <a:latin typeface="Courier"/>
+              </a:rPr>
+              <a:t>float32</a:t>
+            </a:r>
+            <a:r>
+              <a:rPr/>
+              <a:t> for images and neural networks, smaller only when a library does it for you.</a:t>
             </a:r>
           </a:p>
         </p:txBody>
@@ -2767,121 +2816,91 @@
               <a:rPr>
                 <a:latin typeface="Courier"/>
               </a:rPr>
-              <a:t>sum</a:t>
-            </a:r>
-            <a:r>
-              <a:rPr/>
-              <a:t>, </a:t>
-            </a:r>
-            <a:r>
-              <a:rPr>
-                <a:latin typeface="Courier"/>
-              </a:rPr>
-              <a:t>mean</a:t>
-            </a:r>
-            <a:r>
-              <a:rPr/>
-              <a:t>, </a:t>
-            </a:r>
-            <a:r>
-              <a:rPr>
-                <a:latin typeface="Courier"/>
-              </a:rPr>
-              <a:t>std</a:t>
-            </a:r>
-            <a:r>
-              <a:rPr/>
-              <a:t>, </a:t>
-            </a:r>
-            <a:r>
-              <a:rPr>
-                <a:latin typeface="Courier"/>
-              </a:rPr>
-              <a:t>min</a:t>
-            </a:r>
-            <a:r>
-              <a:rPr/>
-              <a:t>, </a:t>
-            </a:r>
-            <a:r>
-              <a:rPr>
-                <a:latin typeface="Courier"/>
-              </a:rPr>
-              <a:t>max</a:t>
-            </a:r>
-            <a:r>
-              <a:rPr/>
-              <a:t>, </a:t>
-            </a:r>
-            <a:r>
-              <a:rPr>
-                <a:latin typeface="Courier"/>
-              </a:rPr>
-              <a:t>argmax</a:t>
-            </a:r>
-            <a:r>
-              <a:rPr/>
-              <a:t> all take an </a:t>
-            </a:r>
-            <a:r>
-              <a:rPr>
-                <a:latin typeface="Courier"/>
-              </a:rPr>
-              <a:t>axis</a:t>
-            </a:r>
-            <a:r>
-              <a:rPr/>
-              <a:t>. Without it they reduce the whole array to one number. The sentence that ends the confusion: the axis you name is the one that disappears. </a:t>
-            </a:r>
-            <a:r>
-              <a:rPr>
-                <a:latin typeface="Courier"/>
-              </a:rPr>
-              <a:t>axis=0</a:t>
-            </a:r>
-            <a:r>
-              <a:rPr/>
-              <a:t> collapses the rows, so you get one value per column: on a patients x measurements table, the mean of each measurement. </a:t>
-            </a:r>
-            <a:r>
-              <a:rPr>
-                <a:latin typeface="Courier"/>
-              </a:rPr>
-              <a:t>axis=1</a:t>
-            </a:r>
-            <a:r>
-              <a:rPr/>
-              <a:t> gives one value per patient. Check the shape of the result every time: </a:t>
-            </a:r>
-            <a:r>
-              <a:rPr>
-                <a:latin typeface="Courier"/>
-              </a:rPr>
-              <a:t>(4,)</a:t>
-            </a:r>
-            <a:r>
-              <a:rPr/>
-              <a:t> versus </a:t>
-            </a:r>
-            <a:r>
-              <a:rPr>
-                <a:latin typeface="Courier"/>
-              </a:rPr>
-              <a:t>(3,)</a:t>
-            </a:r>
-            <a:r>
-              <a:rPr/>
-              <a:t> tells you which one you did. Standardising a table combines the two slides: </a:t>
-            </a:r>
-            <a:r>
-              <a:rPr>
-                <a:latin typeface="Courier"/>
-              </a:rPr>
-              <a:t>(m - m.mean(axis=0)) / m.std(axis=0)</a:t>
-            </a:r>
-            <a:r>
-              <a:rPr/>
-              <a:t>.</a:t>
+              <a:t>dtype=</a:t>
+            </a:r>
+            <a:r>
+              <a:rPr/>
+              <a:t> at creation, </a:t>
+            </a:r>
+            <a:r>
+              <a:rPr>
+                <a:latin typeface="Courier"/>
+              </a:rPr>
+              <a:t>.astype()</a:t>
+            </a:r>
+            <a:r>
+              <a:rPr/>
+              <a:t> to convert (it returns a new array), </a:t>
+            </a:r>
+            <a:r>
+              <a:rPr>
+                <a:latin typeface="Courier"/>
+              </a:rPr>
+              <a:t>.nbytes</a:t>
+            </a:r>
+            <a:r>
+              <a:rPr/>
+              <a:t> for the memory. Three silent failures, none of which raises an error: (1) integers wrap around: 250 + 10 in </a:t>
+            </a:r>
+            <a:r>
+              <a:rPr>
+                <a:latin typeface="Courier"/>
+              </a:rPr>
+              <a:t>uint8</a:t>
+            </a:r>
+            <a:r>
+              <a:rPr/>
+              <a:t> is 4. Typical when adjusting the brightness of an image; convert to a larger type first. (2) </a:t>
+            </a:r>
+            <a:r>
+              <a:rPr>
+                <a:latin typeface="Courier"/>
+              </a:rPr>
+              <a:t>float16</a:t>
+            </a:r>
+            <a:r>
+              <a:rPr/>
+              <a:t> overflows to </a:t>
+            </a:r>
+            <a:r>
+              <a:rPr>
+                <a:latin typeface="Courier"/>
+              </a:rPr>
+              <a:t>inf</a:t>
+            </a:r>
+            <a:r>
+              <a:rPr/>
+              <a:t> above 65 504. (3) adding many small numbers in low precision stalls: at 256 the next 0.1 is below half the gap between float16 neighbours (0.25), so the sum stops growing. Accumulate in </a:t>
+            </a:r>
+            <a:r>
+              <a:rPr>
+                <a:latin typeface="Courier"/>
+              </a:rPr>
+              <a:t>float32</a:t>
+            </a:r>
+            <a:r>
+              <a:rPr/>
+              <a:t> or </a:t>
+            </a:r>
+            <a:r>
+              <a:rPr>
+                <a:latin typeface="Courier"/>
+              </a:rPr>
+              <a:t>float64</a:t>
+            </a:r>
+            <a:r>
+              <a:rPr/>
+              <a:t> (numpy’s </a:t>
+            </a:r>
+            <a:r>
+              <a:rPr>
+                <a:latin typeface="Courier"/>
+              </a:rPr>
+              <a:t>.sum()</a:t>
+            </a:r>
+            <a:r>
+              <a:rPr/>
+              <a:t> already protects you better than a running total, but not completely).</a:t>
             </a:r>
           </a:p>
         </p:txBody>
@@ -2962,98 +2981,54 @@
               <a:buNone/>
             </a:pPr>
             <a:r>
-              <a:rPr/>
-              <a:t>A comparison on an array gives an array of booleans of the same shape: the mask. Indexing with a mask keeps the positions where it is True; the result is always 1D. This is how you filter without a loop, and exactly how pandas filters rows later (</a:t>
-            </a:r>
-            <a:r>
-              <a:rPr>
-                <a:latin typeface="Courier"/>
-              </a:rPr>
-              <a:t>df[df["bmi"] &gt;= 30]</a:t>
-            </a:r>
-            <a:r>
-              <a:rPr/>
-              <a:t>). Combine conditions with </a:t>
-            </a:r>
-            <a:r>
-              <a:rPr>
-                <a:latin typeface="Courier"/>
-              </a:rPr>
-              <a:t>&amp;</a:t>
-            </a:r>
-            <a:r>
-              <a:rPr/>
-              <a:t> and </a:t>
-            </a:r>
-            <a:r>
-              <a:rPr>
-                <a:latin typeface="Courier"/>
-              </a:rPr>
-              <a:t>|</a:t>
-            </a:r>
-            <a:r>
-              <a:rPr/>
-              <a:t>, not </a:t>
-            </a:r>
-            <a:r>
-              <a:rPr>
-                <a:latin typeface="Courier"/>
-              </a:rPr>
-              <a:t>and</a:t>
-            </a:r>
-            <a:r>
-              <a:rPr/>
-              <a:t> / </a:t>
-            </a:r>
-            <a:r>
-              <a:rPr>
-                <a:latin typeface="Courier"/>
-              </a:rPr>
-              <a:t>or</a:t>
-            </a:r>
-            <a:r>
-              <a:rPr/>
-              <a:t>, and parenthesise each condition: </a:t>
-            </a:r>
-            <a:r>
-              <a:rPr>
-                <a:latin typeface="Courier"/>
-              </a:rPr>
-              <a:t>(bmi &gt;= 18.5) &amp; (bmi &lt; 25)</a:t>
-            </a:r>
-            <a:r>
-              <a:rPr/>
-              <a:t>. Forgetting the parentheses is the error of the week. </a:t>
-            </a:r>
-            <a:r>
-              <a:rPr>
-                <a:latin typeface="Courier"/>
-              </a:rPr>
-              <a:t>np.where(cond, a, b)</a:t>
-            </a:r>
-            <a:r>
-              <a:rPr/>
-              <a:t> picks from </a:t>
-            </a:r>
-            <a:r>
-              <a:rPr>
-                <a:latin typeface="Courier"/>
-              </a:rPr>
-              <a:t>a</a:t>
-            </a:r>
-            <a:r>
-              <a:rPr/>
-              <a:t> where True and from </a:t>
-            </a:r>
-            <a:r>
-              <a:rPr>
-                <a:latin typeface="Courier"/>
-              </a:rPr>
-              <a:t>b</a:t>
-            </a:r>
-            <a:r>
-              <a:rPr/>
-              <a:t> elsewhere, e.g. to clip negative values to 0.</a:t>
+              <a:rPr>
+                <a:latin typeface="Courier"/>
+              </a:rPr>
+              <a:t>np</a:t>
+            </a:r>
+            <a:r>
+              <a:rPr/>
+              <a:t> is the universal alias; every tutorial, answer and library uses it. </a:t>
+            </a:r>
+            <a:r>
+              <a:rPr>
+                <a:latin typeface="Courier"/>
+              </a:rPr>
+              <a:t>arange</a:t>
+            </a:r>
+            <a:r>
+              <a:rPr/>
+              <a:t> works like </a:t>
+            </a:r>
+            <a:r>
+              <a:rPr>
+                <a:latin typeface="Courier"/>
+              </a:rPr>
+              <a:t>range</a:t>
+            </a:r>
+            <a:r>
+              <a:rPr/>
+              <a:t> (end excluded); </a:t>
+            </a:r>
+            <a:r>
+              <a:rPr>
+                <a:latin typeface="Courier"/>
+              </a:rPr>
+              <a:t>linspace</a:t>
+            </a:r>
+            <a:r>
+              <a:rPr/>
+              <a:t> takes a number of points and includes the end. </a:t>
+            </a:r>
+            <a:r>
+              <a:rPr>
+                <a:latin typeface="Courier"/>
+              </a:rPr>
+              <a:t>reshape</a:t>
+            </a:r>
+            <a:r>
+              <a:rPr/>
+              <a:t> rearranges without copying, as long as the sizes match: 12 values cannot become 5 x 2. Random numbers: always use a seeded generator, so the same script gives the same result tomorrow and on your colleague’s machine. That is reproducibility at the smallest scale.</a:t>
             </a:r>
           </a:p>
         </p:txBody>
@@ -3135,27 +3110,87 @@
             </a:pPr>
             <a:r>
               <a:rPr/>
-              <a:t>The mini use case of the notebook: 200 simulated patients (seed 42), heights and weights drawn from normal distributions. One line computes 200 BMIs, with broadcasting between two arrays of the same shape. A mean of a mask is a fraction (21.5 % obese here). </a:t>
-            </a:r>
-            <a:r>
-              <a:rPr>
-                <a:latin typeface="Courier"/>
-              </a:rPr>
-              <a:t>digitize</a:t>
-            </a:r>
-            <a:r>
-              <a:rPr/>
-              <a:t> turns a value into a category from the cut points, </a:t>
-            </a:r>
-            <a:r>
-              <a:rPr>
-                <a:latin typeface="Courier"/>
-              </a:rPr>
-              <a:t>bincount</a:t>
-            </a:r>
-            <a:r>
-              <a:rPr/>
-              <a:t> counts each category. Compare with the list of dicts from section 4: same questions, no loop, and it would take the same time on 200 000 patients. That is why every data library is built on arrays.</a:t>
+              <a:t>Same grammar as lists and strings, with one index per axis, separated by a comma: </a:t>
+            </a:r>
+            <a:r>
+              <a:rPr>
+                <a:latin typeface="Courier"/>
+              </a:rPr>
+              <a:t>y[row, col]</a:t>
+            </a:r>
+            <a:r>
+              <a:rPr/>
+              <a:t>. A </a:t>
+            </a:r>
+            <a:r>
+              <a:rPr>
+                <a:latin typeface="Courier"/>
+              </a:rPr>
+              <a:t>:</a:t>
+            </a:r>
+            <a:r>
+              <a:rPr/>
+              <a:t> alone means “everything along this axis”. </a:t>
+            </a:r>
+            <a:r>
+              <a:rPr>
+                <a:latin typeface="Courier"/>
+              </a:rPr>
+              <a:t>y[1]</a:t>
+            </a:r>
+            <a:r>
+              <a:rPr/>
+              <a:t> is a whole row; </a:t>
+            </a:r>
+            <a:r>
+              <a:rPr>
+                <a:latin typeface="Courier"/>
+              </a:rPr>
+              <a:t>y[:, 2]</a:t>
+            </a:r>
+            <a:r>
+              <a:rPr/>
+              <a:t> a whole column (the thing lists of lists cannot do). Slices of an array are views, not copies: writing into </a:t>
+            </a:r>
+            <a:r>
+              <a:rPr>
+                <a:latin typeface="Courier"/>
+              </a:rPr>
+              <a:t>y[:2, :2]</a:t>
+            </a:r>
+            <a:r>
+              <a:rPr/>
+              <a:t> changes </a:t>
+            </a:r>
+            <a:r>
+              <a:rPr>
+                <a:latin typeface="Courier"/>
+              </a:rPr>
+              <a:t>y</a:t>
+            </a:r>
+            <a:r>
+              <a:rPr/>
+              <a:t>. This is the aliasing of the previous section again; use </a:t>
+            </a:r>
+            <a:r>
+              <a:rPr>
+                <a:latin typeface="Courier"/>
+              </a:rPr>
+              <a:t>.copy()</a:t>
+            </a:r>
+            <a:r>
+              <a:rPr/>
+              <a:t> when you want independence. Assignment works on whole slices: </a:t>
+            </a:r>
+            <a:r>
+              <a:rPr>
+                <a:latin typeface="Courier"/>
+              </a:rPr>
+              <a:t>t[:, 1] = 0</a:t>
+            </a:r>
+            <a:r>
+              <a:rPr/>
+              <a:t> sets a column at once.</a:t>
             </a:r>
           </a:p>
         </p:txBody>
@@ -3178,6 +3213,518 @@
             <a:fld id="{18BDFEC3-8487-43E8-A154-7C12CBC1FFF2}" type="slidenum">
               <a:rPr lang="en-US"/>
               <a:t>33</a:t>
+            </a:fld>
+            <a:endParaRPr lang="en-US"/>
+          </a:p>
+        </p:txBody>
+      </p:sp>
+    </p:spTree>
+  </p:cSld>
+</p:notes>
+</file>
+
+<file path=ppt/notesSlides/notesSlide27.xml><?xml version="1.0" encoding="utf-8"?>
+<p:notes xmlns:a="http://schemas.openxmlformats.org/drawingml/2006/main" xmlns:r="http://schemas.openxmlformats.org/officeDocument/2006/relationships" xmlns:p="http://schemas.openxmlformats.org/presentationml/2006/main">
+  <p:cSld>
+    <p:spTree>
+      <p:nvGrpSpPr>
+        <p:cNvPr id="1" name=""/>
+        <p:cNvGrpSpPr/>
+        <p:nvPr/>
+      </p:nvGrpSpPr>
+      <p:grpSpPr>
+        <a:xfrm>
+          <a:off x="0" y="0"/>
+          <a:ext cx="0" cy="0"/>
+          <a:chOff x="0" y="0"/>
+          <a:chExt cx="0" cy="0"/>
+        </a:xfrm>
+      </p:grpSpPr>
+      <p:sp>
+        <p:nvSpPr>
+          <p:cNvPr id="2" name="Slide Image Placeholder 1"/>
+          <p:cNvSpPr>
+            <a:spLocks noGrp="1" noRot="1" noChangeAspect="1"/>
+          </p:cNvSpPr>
+          <p:nvPr>
+            <p:ph type="sldImg"/>
+          </p:nvPr>
+        </p:nvSpPr>
+        <p:spPr/>
+      </p:sp>
+      <p:sp>
+        <p:nvSpPr>
+          <p:cNvPr id="3" name="Notes Placeholder 2"/>
+          <p:cNvSpPr>
+            <a:spLocks noGrp="1"/>
+          </p:cNvSpPr>
+          <p:nvPr>
+            <p:ph type="body" idx="1"/>
+          </p:nvPr>
+        </p:nvSpPr>
+        <p:spPr/>
+        <p:txBody>
+          <a:bodyPr/>
+          <a:lstStyle/>
+          <a:p>
+            <a:pPr lvl="0" indent="0" marL="0">
+              <a:buNone/>
+            </a:pPr>
+            <a:r>
+              <a:rPr/>
+              <a:t>Every arithmetic operator and every </a:t>
+            </a:r>
+            <a:r>
+              <a:rPr>
+                <a:latin typeface="Courier"/>
+              </a:rPr>
+              <a:t>np.</a:t>
+            </a:r>
+            <a:r>
+              <a:rPr/>
+              <a:t> maths function applies to each element: this is vectorization, and it is the whole style of numpy, pandas and torch. If you write a </a:t>
+            </a:r>
+            <a:r>
+              <a:rPr>
+                <a:latin typeface="Courier"/>
+              </a:rPr>
+              <a:t>for</a:t>
+            </a:r>
+            <a:r>
+              <a:rPr/>
+              <a:t> loop over the elements of an array, there is almost always a one-liner instead. Careful with </a:t>
+            </a:r>
+            <a:r>
+              <a:rPr>
+                <a:latin typeface="Courier"/>
+              </a:rPr>
+              <a:t>*</a:t>
+            </a:r>
+            <a:r>
+              <a:rPr/>
+              <a:t>: on arrays it multiplies element by element. The matrix product is </a:t>
+            </a:r>
+            <a:r>
+              <a:rPr>
+                <a:latin typeface="Courier"/>
+              </a:rPr>
+              <a:t>@</a:t>
+            </a:r>
+            <a:r>
+              <a:rPr/>
+              <a:t>. Compare with lists: </a:t>
+            </a:r>
+            <a:r>
+              <a:rPr>
+                <a:latin typeface="Courier"/>
+              </a:rPr>
+              <a:t>[1, 2] * 2</a:t>
+            </a:r>
+            <a:r>
+              <a:rPr/>
+              <a:t> is </a:t>
+            </a:r>
+            <a:r>
+              <a:rPr>
+                <a:latin typeface="Courier"/>
+              </a:rPr>
+              <a:t>[1, 2, 1, 2]</a:t>
+            </a:r>
+            <a:r>
+              <a:rPr/>
+              <a:t>, and </a:t>
+            </a:r>
+            <a:r>
+              <a:rPr>
+                <a:latin typeface="Courier"/>
+              </a:rPr>
+              <a:t>[1, 2] + [3]</a:t>
+            </a:r>
+            <a:r>
+              <a:rPr/>
+              <a:t> concatenates. Same symbol, different type, different meaning.</a:t>
+            </a:r>
+          </a:p>
+        </p:txBody>
+      </p:sp>
+      <p:sp>
+        <p:nvSpPr>
+          <p:cNvPr id="4" name="Slide Number Placeholder 3"/>
+          <p:cNvSpPr>
+            <a:spLocks noGrp="1"/>
+          </p:cNvSpPr>
+          <p:nvPr>
+            <p:ph type="sldNum" sz="quarter" idx="10"/>
+          </p:nvPr>
+        </p:nvSpPr>
+        <p:spPr/>
+        <p:txBody>
+          <a:bodyPr/>
+          <a:lstStyle/>
+          <a:p>
+            <a:fld id="{18BDFEC3-8487-43E8-A154-7C12CBC1FFF2}" type="slidenum">
+              <a:rPr lang="en-US"/>
+              <a:t>34</a:t>
+            </a:fld>
+            <a:endParaRPr lang="en-US"/>
+          </a:p>
+        </p:txBody>
+      </p:sp>
+    </p:spTree>
+  </p:cSld>
+</p:notes>
+</file>
+
+<file path=ppt/notesSlides/notesSlide28.xml><?xml version="1.0" encoding="utf-8"?>
+<p:notes xmlns:a="http://schemas.openxmlformats.org/drawingml/2006/main" xmlns:r="http://schemas.openxmlformats.org/officeDocument/2006/relationships" xmlns:p="http://schemas.openxmlformats.org/presentationml/2006/main">
+  <p:cSld>
+    <p:spTree>
+      <p:nvGrpSpPr>
+        <p:cNvPr id="1" name=""/>
+        <p:cNvGrpSpPr/>
+        <p:nvPr/>
+      </p:nvGrpSpPr>
+      <p:grpSpPr>
+        <a:xfrm>
+          <a:off x="0" y="0"/>
+          <a:ext cx="0" cy="0"/>
+          <a:chOff x="0" y="0"/>
+          <a:chExt cx="0" cy="0"/>
+        </a:xfrm>
+      </p:grpSpPr>
+      <p:sp>
+        <p:nvSpPr>
+          <p:cNvPr id="2" name="Slide Image Placeholder 1"/>
+          <p:cNvSpPr>
+            <a:spLocks noGrp="1" noRot="1" noChangeAspect="1"/>
+          </p:cNvSpPr>
+          <p:nvPr>
+            <p:ph type="sldImg"/>
+          </p:nvPr>
+        </p:nvSpPr>
+        <p:spPr/>
+      </p:sp>
+      <p:sp>
+        <p:nvSpPr>
+          <p:cNvPr id="3" name="Notes Placeholder 2"/>
+          <p:cNvSpPr>
+            <a:spLocks noGrp="1"/>
+          </p:cNvSpPr>
+          <p:nvPr>
+            <p:ph type="body" idx="1"/>
+          </p:nvPr>
+        </p:nvSpPr>
+        <p:spPr/>
+        <p:txBody>
+          <a:bodyPr/>
+          <a:lstStyle/>
+          <a:p>
+            <a:pPr lvl="0" indent="0" marL="0">
+              <a:buNone/>
+            </a:pPr>
+            <a:r>
+              <a:rPr/>
+              <a:t>When the shapes differ, numpy stretches the smaller array along the missing axis, as if it were repeated (it is not actually copied). </a:t>
+            </a:r>
+            <a:r>
+              <a:rPr>
+                <a:latin typeface="Courier"/>
+              </a:rPr>
+              <a:t>x + 10</a:t>
+            </a:r>
+            <a:r>
+              <a:rPr/>
+              <a:t> was already broadcasting: a scalar stretched to every cell. The rule: compare shapes from the right; each pair of sizes must be equal, or one of them must be 1. </a:t>
+            </a:r>
+            <a:r>
+              <a:rPr>
+                <a:latin typeface="Courier"/>
+              </a:rPr>
+              <a:t>(3, 4)</a:t>
+            </a:r>
+            <a:r>
+              <a:rPr/>
+              <a:t> and </a:t>
+            </a:r>
+            <a:r>
+              <a:rPr>
+                <a:latin typeface="Courier"/>
+              </a:rPr>
+              <a:t>(4,)</a:t>
+            </a:r>
+            <a:r>
+              <a:rPr/>
+              <a:t> match. </a:t>
+            </a:r>
+            <a:r>
+              <a:rPr>
+                <a:latin typeface="Courier"/>
+              </a:rPr>
+              <a:t>(3, 4)</a:t>
+            </a:r>
+            <a:r>
+              <a:rPr/>
+              <a:t> and </a:t>
+            </a:r>
+            <a:r>
+              <a:rPr>
+                <a:latin typeface="Courier"/>
+              </a:rPr>
+              <a:t>(3,)</a:t>
+            </a:r>
+            <a:r>
+              <a:rPr/>
+              <a:t> do not: to add one value per row, make it a column, shape </a:t>
+            </a:r>
+            <a:r>
+              <a:rPr>
+                <a:latin typeface="Courier"/>
+              </a:rPr>
+              <a:t>(3, 1)</a:t>
+            </a:r>
+            <a:r>
+              <a:rPr/>
+              <a:t>, with </a:t>
+            </a:r>
+            <a:r>
+              <a:rPr>
+                <a:latin typeface="Courier"/>
+              </a:rPr>
+              <a:t>.reshape(3, 1)</a:t>
+            </a:r>
+            <a:r>
+              <a:rPr/>
+              <a:t> or </a:t>
+            </a:r>
+            <a:r>
+              <a:rPr>
+                <a:latin typeface="Courier"/>
+              </a:rPr>
+              <a:t>v[:, None]</a:t>
+            </a:r>
+            <a:r>
+              <a:rPr/>
+              <a:t>. Typical use: subtracting the mean of each column from a table, in one line.</a:t>
+            </a:r>
+          </a:p>
+        </p:txBody>
+      </p:sp>
+      <p:sp>
+        <p:nvSpPr>
+          <p:cNvPr id="4" name="Slide Number Placeholder 3"/>
+          <p:cNvSpPr>
+            <a:spLocks noGrp="1"/>
+          </p:cNvSpPr>
+          <p:nvPr>
+            <p:ph type="sldNum" sz="quarter" idx="10"/>
+          </p:nvPr>
+        </p:nvSpPr>
+        <p:spPr/>
+        <p:txBody>
+          <a:bodyPr/>
+          <a:lstStyle/>
+          <a:p>
+            <a:fld id="{18BDFEC3-8487-43E8-A154-7C12CBC1FFF2}" type="slidenum">
+              <a:rPr lang="en-US"/>
+              <a:t>35</a:t>
+            </a:fld>
+            <a:endParaRPr lang="en-US"/>
+          </a:p>
+        </p:txBody>
+      </p:sp>
+    </p:spTree>
+  </p:cSld>
+</p:notes>
+</file>
+
+<file path=ppt/notesSlides/notesSlide29.xml><?xml version="1.0" encoding="utf-8"?>
+<p:notes xmlns:a="http://schemas.openxmlformats.org/drawingml/2006/main" xmlns:r="http://schemas.openxmlformats.org/officeDocument/2006/relationships" xmlns:p="http://schemas.openxmlformats.org/presentationml/2006/main">
+  <p:cSld>
+    <p:spTree>
+      <p:nvGrpSpPr>
+        <p:cNvPr id="1" name=""/>
+        <p:cNvGrpSpPr/>
+        <p:nvPr/>
+      </p:nvGrpSpPr>
+      <p:grpSpPr>
+        <a:xfrm>
+          <a:off x="0" y="0"/>
+          <a:ext cx="0" cy="0"/>
+          <a:chOff x="0" y="0"/>
+          <a:chExt cx="0" cy="0"/>
+        </a:xfrm>
+      </p:grpSpPr>
+      <p:sp>
+        <p:nvSpPr>
+          <p:cNvPr id="2" name="Slide Image Placeholder 1"/>
+          <p:cNvSpPr>
+            <a:spLocks noGrp="1" noRot="1" noChangeAspect="1"/>
+          </p:cNvSpPr>
+          <p:nvPr>
+            <p:ph type="sldImg"/>
+          </p:nvPr>
+        </p:nvSpPr>
+        <p:spPr/>
+      </p:sp>
+      <p:sp>
+        <p:nvSpPr>
+          <p:cNvPr id="3" name="Notes Placeholder 2"/>
+          <p:cNvSpPr>
+            <a:spLocks noGrp="1"/>
+          </p:cNvSpPr>
+          <p:nvPr>
+            <p:ph type="body" idx="1"/>
+          </p:nvPr>
+        </p:nvSpPr>
+        <p:spPr/>
+        <p:txBody>
+          <a:bodyPr/>
+          <a:lstStyle/>
+          <a:p>
+            <a:pPr lvl="0" indent="0" marL="0">
+              <a:buNone/>
+            </a:pPr>
+            <a:r>
+              <a:rPr>
+                <a:latin typeface="Courier"/>
+              </a:rPr>
+              <a:t>sum</a:t>
+            </a:r>
+            <a:r>
+              <a:rPr/>
+              <a:t>, </a:t>
+            </a:r>
+            <a:r>
+              <a:rPr>
+                <a:latin typeface="Courier"/>
+              </a:rPr>
+              <a:t>mean</a:t>
+            </a:r>
+            <a:r>
+              <a:rPr/>
+              <a:t>, </a:t>
+            </a:r>
+            <a:r>
+              <a:rPr>
+                <a:latin typeface="Courier"/>
+              </a:rPr>
+              <a:t>std</a:t>
+            </a:r>
+            <a:r>
+              <a:rPr/>
+              <a:t>, </a:t>
+            </a:r>
+            <a:r>
+              <a:rPr>
+                <a:latin typeface="Courier"/>
+              </a:rPr>
+              <a:t>min</a:t>
+            </a:r>
+            <a:r>
+              <a:rPr/>
+              <a:t>, </a:t>
+            </a:r>
+            <a:r>
+              <a:rPr>
+                <a:latin typeface="Courier"/>
+              </a:rPr>
+              <a:t>max</a:t>
+            </a:r>
+            <a:r>
+              <a:rPr/>
+              <a:t>, </a:t>
+            </a:r>
+            <a:r>
+              <a:rPr>
+                <a:latin typeface="Courier"/>
+              </a:rPr>
+              <a:t>argmax</a:t>
+            </a:r>
+            <a:r>
+              <a:rPr/>
+              <a:t> all take an </a:t>
+            </a:r>
+            <a:r>
+              <a:rPr>
+                <a:latin typeface="Courier"/>
+              </a:rPr>
+              <a:t>axis</a:t>
+            </a:r>
+            <a:r>
+              <a:rPr/>
+              <a:t>. Without it they reduce the whole array to one number. The sentence that ends the confusion: the axis you name is the one that disappears. </a:t>
+            </a:r>
+            <a:r>
+              <a:rPr>
+                <a:latin typeface="Courier"/>
+              </a:rPr>
+              <a:t>axis=0</a:t>
+            </a:r>
+            <a:r>
+              <a:rPr/>
+              <a:t> collapses the rows, so you get one value per column: on a patients x measurements table, the mean of each measurement. </a:t>
+            </a:r>
+            <a:r>
+              <a:rPr>
+                <a:latin typeface="Courier"/>
+              </a:rPr>
+              <a:t>axis=1</a:t>
+            </a:r>
+            <a:r>
+              <a:rPr/>
+              <a:t> gives one value per patient. Check the shape of the result every time: </a:t>
+            </a:r>
+            <a:r>
+              <a:rPr>
+                <a:latin typeface="Courier"/>
+              </a:rPr>
+              <a:t>(4,)</a:t>
+            </a:r>
+            <a:r>
+              <a:rPr/>
+              <a:t> versus </a:t>
+            </a:r>
+            <a:r>
+              <a:rPr>
+                <a:latin typeface="Courier"/>
+              </a:rPr>
+              <a:t>(3,)</a:t>
+            </a:r>
+            <a:r>
+              <a:rPr/>
+              <a:t> tells you which one you did. Standardising a table combines the two slides: </a:t>
+            </a:r>
+            <a:r>
+              <a:rPr>
+                <a:latin typeface="Courier"/>
+              </a:rPr>
+              <a:t>(m - m.mean(axis=0)) / m.std(axis=0)</a:t>
+            </a:r>
+            <a:r>
+              <a:rPr/>
+              <a:t>.</a:t>
+            </a:r>
+          </a:p>
+        </p:txBody>
+      </p:sp>
+      <p:sp>
+        <p:nvSpPr>
+          <p:cNvPr id="4" name="Slide Number Placeholder 3"/>
+          <p:cNvSpPr>
+            <a:spLocks noGrp="1"/>
+          </p:cNvSpPr>
+          <p:nvPr>
+            <p:ph type="sldNum" sz="quarter" idx="10"/>
+          </p:nvPr>
+        </p:nvSpPr>
+        <p:spPr/>
+        <p:txBody>
+          <a:bodyPr/>
+          <a:lstStyle/>
+          <a:p>
+            <a:fld id="{18BDFEC3-8487-43E8-A154-7C12CBC1FFF2}" type="slidenum">
+              <a:rPr lang="en-US"/>
+              <a:t>36</a:t>
             </a:fld>
             <a:endParaRPr lang="en-US"/>
           </a:p>
@@ -3260,6 +3807,280 @@
             <a:fld id="{18BDFEC3-8487-43E8-A154-7C12CBC1FFF2}" type="slidenum">
               <a:rPr lang="en-US"/>
               <a:t>5</a:t>
+            </a:fld>
+            <a:endParaRPr lang="en-US"/>
+          </a:p>
+        </p:txBody>
+      </p:sp>
+    </p:spTree>
+  </p:cSld>
+</p:notes>
+</file>
+
+<file path=ppt/notesSlides/notesSlide30.xml><?xml version="1.0" encoding="utf-8"?>
+<p:notes xmlns:a="http://schemas.openxmlformats.org/drawingml/2006/main" xmlns:r="http://schemas.openxmlformats.org/officeDocument/2006/relationships" xmlns:p="http://schemas.openxmlformats.org/presentationml/2006/main">
+  <p:cSld>
+    <p:spTree>
+      <p:nvGrpSpPr>
+        <p:cNvPr id="1" name=""/>
+        <p:cNvGrpSpPr/>
+        <p:nvPr/>
+      </p:nvGrpSpPr>
+      <p:grpSpPr>
+        <a:xfrm>
+          <a:off x="0" y="0"/>
+          <a:ext cx="0" cy="0"/>
+          <a:chOff x="0" y="0"/>
+          <a:chExt cx="0" cy="0"/>
+        </a:xfrm>
+      </p:grpSpPr>
+      <p:sp>
+        <p:nvSpPr>
+          <p:cNvPr id="2" name="Slide Image Placeholder 1"/>
+          <p:cNvSpPr>
+            <a:spLocks noGrp="1" noRot="1" noChangeAspect="1"/>
+          </p:cNvSpPr>
+          <p:nvPr>
+            <p:ph type="sldImg"/>
+          </p:nvPr>
+        </p:nvSpPr>
+        <p:spPr/>
+      </p:sp>
+      <p:sp>
+        <p:nvSpPr>
+          <p:cNvPr id="3" name="Notes Placeholder 2"/>
+          <p:cNvSpPr>
+            <a:spLocks noGrp="1"/>
+          </p:cNvSpPr>
+          <p:nvPr>
+            <p:ph type="body" idx="1"/>
+          </p:nvPr>
+        </p:nvSpPr>
+        <p:spPr/>
+        <p:txBody>
+          <a:bodyPr/>
+          <a:lstStyle/>
+          <a:p>
+            <a:pPr lvl="0" indent="0" marL="0">
+              <a:buNone/>
+            </a:pPr>
+            <a:r>
+              <a:rPr/>
+              <a:t>A comparison on an array gives an array of booleans of the same shape: the mask. Indexing with a mask keeps the positions where it is True; the result is always 1D. This is how you filter without a loop, and exactly how pandas filters rows later (</a:t>
+            </a:r>
+            <a:r>
+              <a:rPr>
+                <a:latin typeface="Courier"/>
+              </a:rPr>
+              <a:t>df[df["bmi"] &gt;= 30]</a:t>
+            </a:r>
+            <a:r>
+              <a:rPr/>
+              <a:t>). Combine conditions with </a:t>
+            </a:r>
+            <a:r>
+              <a:rPr>
+                <a:latin typeface="Courier"/>
+              </a:rPr>
+              <a:t>&amp;</a:t>
+            </a:r>
+            <a:r>
+              <a:rPr/>
+              <a:t> and </a:t>
+            </a:r>
+            <a:r>
+              <a:rPr>
+                <a:latin typeface="Courier"/>
+              </a:rPr>
+              <a:t>|</a:t>
+            </a:r>
+            <a:r>
+              <a:rPr/>
+              <a:t>, not </a:t>
+            </a:r>
+            <a:r>
+              <a:rPr>
+                <a:latin typeface="Courier"/>
+              </a:rPr>
+              <a:t>and</a:t>
+            </a:r>
+            <a:r>
+              <a:rPr/>
+              <a:t> / </a:t>
+            </a:r>
+            <a:r>
+              <a:rPr>
+                <a:latin typeface="Courier"/>
+              </a:rPr>
+              <a:t>or</a:t>
+            </a:r>
+            <a:r>
+              <a:rPr/>
+              <a:t>, and parenthesise each condition: </a:t>
+            </a:r>
+            <a:r>
+              <a:rPr>
+                <a:latin typeface="Courier"/>
+              </a:rPr>
+              <a:t>(bmi &gt;= 18.5) &amp; (bmi &lt; 25)</a:t>
+            </a:r>
+            <a:r>
+              <a:rPr/>
+              <a:t>. Forgetting the parentheses is the error of the week. </a:t>
+            </a:r>
+            <a:r>
+              <a:rPr>
+                <a:latin typeface="Courier"/>
+              </a:rPr>
+              <a:t>np.where(cond, a, b)</a:t>
+            </a:r>
+            <a:r>
+              <a:rPr/>
+              <a:t> picks from </a:t>
+            </a:r>
+            <a:r>
+              <a:rPr>
+                <a:latin typeface="Courier"/>
+              </a:rPr>
+              <a:t>a</a:t>
+            </a:r>
+            <a:r>
+              <a:rPr/>
+              <a:t> where True and from </a:t>
+            </a:r>
+            <a:r>
+              <a:rPr>
+                <a:latin typeface="Courier"/>
+              </a:rPr>
+              <a:t>b</a:t>
+            </a:r>
+            <a:r>
+              <a:rPr/>
+              <a:t> elsewhere, e.g. to clip negative values to 0.</a:t>
+            </a:r>
+          </a:p>
+        </p:txBody>
+      </p:sp>
+      <p:sp>
+        <p:nvSpPr>
+          <p:cNvPr id="4" name="Slide Number Placeholder 3"/>
+          <p:cNvSpPr>
+            <a:spLocks noGrp="1"/>
+          </p:cNvSpPr>
+          <p:nvPr>
+            <p:ph type="sldNum" sz="quarter" idx="10"/>
+          </p:nvPr>
+        </p:nvSpPr>
+        <p:spPr/>
+        <p:txBody>
+          <a:bodyPr/>
+          <a:lstStyle/>
+          <a:p>
+            <a:fld id="{18BDFEC3-8487-43E8-A154-7C12CBC1FFF2}" type="slidenum">
+              <a:rPr lang="en-US"/>
+              <a:t>37</a:t>
+            </a:fld>
+            <a:endParaRPr lang="en-US"/>
+          </a:p>
+        </p:txBody>
+      </p:sp>
+    </p:spTree>
+  </p:cSld>
+</p:notes>
+</file>
+
+<file path=ppt/notesSlides/notesSlide31.xml><?xml version="1.0" encoding="utf-8"?>
+<p:notes xmlns:a="http://schemas.openxmlformats.org/drawingml/2006/main" xmlns:r="http://schemas.openxmlformats.org/officeDocument/2006/relationships" xmlns:p="http://schemas.openxmlformats.org/presentationml/2006/main">
+  <p:cSld>
+    <p:spTree>
+      <p:nvGrpSpPr>
+        <p:cNvPr id="1" name=""/>
+        <p:cNvGrpSpPr/>
+        <p:nvPr/>
+      </p:nvGrpSpPr>
+      <p:grpSpPr>
+        <a:xfrm>
+          <a:off x="0" y="0"/>
+          <a:ext cx="0" cy="0"/>
+          <a:chOff x="0" y="0"/>
+          <a:chExt cx="0" cy="0"/>
+        </a:xfrm>
+      </p:grpSpPr>
+      <p:sp>
+        <p:nvSpPr>
+          <p:cNvPr id="2" name="Slide Image Placeholder 1"/>
+          <p:cNvSpPr>
+            <a:spLocks noGrp="1" noRot="1" noChangeAspect="1"/>
+          </p:cNvSpPr>
+          <p:nvPr>
+            <p:ph type="sldImg"/>
+          </p:nvPr>
+        </p:nvSpPr>
+        <p:spPr/>
+      </p:sp>
+      <p:sp>
+        <p:nvSpPr>
+          <p:cNvPr id="3" name="Notes Placeholder 2"/>
+          <p:cNvSpPr>
+            <a:spLocks noGrp="1"/>
+          </p:cNvSpPr>
+          <p:nvPr>
+            <p:ph type="body" idx="1"/>
+          </p:nvPr>
+        </p:nvSpPr>
+        <p:spPr/>
+        <p:txBody>
+          <a:bodyPr/>
+          <a:lstStyle/>
+          <a:p>
+            <a:pPr lvl="0" indent="0" marL="0">
+              <a:buNone/>
+            </a:pPr>
+            <a:r>
+              <a:rPr/>
+              <a:t>The mini use case of the notebook: 200 simulated patients (seed 42), heights and weights drawn from normal distributions. One line computes 200 BMIs, with broadcasting between two arrays of the same shape. A mean of a mask is a fraction (21.5 % obese here). </a:t>
+            </a:r>
+            <a:r>
+              <a:rPr>
+                <a:latin typeface="Courier"/>
+              </a:rPr>
+              <a:t>digitize</a:t>
+            </a:r>
+            <a:r>
+              <a:rPr/>
+              <a:t> turns a value into a category from the cut points, </a:t>
+            </a:r>
+            <a:r>
+              <a:rPr>
+                <a:latin typeface="Courier"/>
+              </a:rPr>
+              <a:t>bincount</a:t>
+            </a:r>
+            <a:r>
+              <a:rPr/>
+              <a:t> counts each category. Compare with the list of dicts from section 4: same questions, no loop, and it would take the same time on 200 000 patients. That is why every data library is built on arrays.</a:t>
+            </a:r>
+          </a:p>
+        </p:txBody>
+      </p:sp>
+      <p:sp>
+        <p:nvSpPr>
+          <p:cNvPr id="4" name="Slide Number Placeholder 3"/>
+          <p:cNvSpPr>
+            <a:spLocks noGrp="1"/>
+          </p:cNvSpPr>
+          <p:nvPr>
+            <p:ph type="sldNum" sz="quarter" idx="10"/>
+          </p:nvPr>
+        </p:nvSpPr>
+        <p:spPr/>
+        <p:txBody>
+          <a:bodyPr/>
+          <a:lstStyle/>
+          <a:p>
+            <a:fld id="{18BDFEC3-8487-43E8-A154-7C12CBC1FFF2}" type="slidenum">
+              <a:rPr lang="en-US"/>
+              <a:t>38</a:t>
             </a:fld>
             <a:endParaRPr lang="en-US"/>
           </a:p>
@@ -10272,388 +11093,631 @@
             </a:pPr>
             <a:r>
               <a:rPr/>
-              <a:t>Creating arrays</a:t>
-            </a:r>
-          </a:p>
-        </p:txBody>
-      </p:sp>
-      <p:sp>
-        <p:nvSpPr>
-          <p:cNvPr id="3" name="Content Placeholder 2"/>
-          <p:cNvSpPr>
-            <a:spLocks noGrp="1"/>
-          </p:cNvSpPr>
+              <a:t>NumPy data types</a:t>
+            </a:r>
+          </a:p>
+        </p:txBody>
+      </p:sp>
+      <p:graphicFrame>
+        <p:nvGraphicFramePr>
+          <p:cNvPr id="6" name="Content Placeholder 5"/>
+          <p:cNvGraphicFramePr>
+            <a:graphicFrameLocks noGrp="1"/>
+          </p:cNvGraphicFramePr>
           <p:nvPr>
             <p:ph idx="1"/>
           </p:nvPr>
-        </p:nvSpPr>
-        <p:spPr/>
-        <p:txBody>
-          <a:bodyPr>
-            <a:normAutofit/>
-          </a:bodyPr>
-          <a:lstStyle/>
-          <a:p>
-            <a:pPr lvl="0" indent="0">
-              <a:buNone/>
-            </a:pPr>
-            <a:r>
-              <a:rPr b="1">
-                <a:solidFill>
-                  <a:srgbClr val="008000"/>
-                </a:solidFill>
-                <a:latin typeface="Courier"/>
-              </a:rPr>
-              <a:t>import</a:t>
-            </a:r>
-            <a:r>
-              <a:rPr>
-                <a:latin typeface="Courier"/>
-              </a:rPr>
-              <a:t> numpy </a:t>
-            </a:r>
-            <a:r>
-              <a:rPr b="1">
-                <a:solidFill>
-                  <a:srgbClr val="008000"/>
-                </a:solidFill>
-                <a:latin typeface="Courier"/>
-              </a:rPr>
-              <a:t>as</a:t>
-            </a:r>
-            <a:r>
-              <a:rPr>
-                <a:latin typeface="Courier"/>
-              </a:rPr>
-              <a:t> np</a:t>
-            </a:r>
-            <a:br/>
-            <a:br/>
-            <a:r>
-              <a:rPr>
-                <a:latin typeface="Courier"/>
-              </a:rPr>
-              <a:t>np.array([</a:t>
-            </a:r>
-            <a:r>
-              <a:rPr>
-                <a:solidFill>
-                  <a:srgbClr val="40A070"/>
-                </a:solidFill>
-                <a:latin typeface="Courier"/>
-              </a:rPr>
-              <a:t>72</a:t>
-            </a:r>
-            <a:r>
-              <a:rPr>
-                <a:latin typeface="Courier"/>
-              </a:rPr>
-              <a:t>, </a:t>
-            </a:r>
-            <a:r>
-              <a:rPr>
-                <a:solidFill>
-                  <a:srgbClr val="40A070"/>
-                </a:solidFill>
-                <a:latin typeface="Courier"/>
-              </a:rPr>
-              <a:t>85</a:t>
-            </a:r>
-            <a:r>
-              <a:rPr>
-                <a:latin typeface="Courier"/>
-              </a:rPr>
-              <a:t>, </a:t>
-            </a:r>
-            <a:r>
-              <a:rPr>
-                <a:solidFill>
-                  <a:srgbClr val="40A070"/>
-                </a:solidFill>
-                <a:latin typeface="Courier"/>
-              </a:rPr>
-              <a:t>64</a:t>
-            </a:r>
-            <a:r>
-              <a:rPr>
-                <a:latin typeface="Courier"/>
-              </a:rPr>
-              <a:t>])</a:t>
-            </a:r>
-            <a:br/>
-            <a:r>
-              <a:rPr>
-                <a:latin typeface="Courier"/>
-              </a:rPr>
-              <a:t>np.arange(</a:t>
-            </a:r>
-            <a:r>
-              <a:rPr>
-                <a:solidFill>
-                  <a:srgbClr val="40A070"/>
-                </a:solidFill>
-                <a:latin typeface="Courier"/>
-              </a:rPr>
-              <a:t>12</a:t>
-            </a:r>
-            <a:r>
-              <a:rPr>
-                <a:latin typeface="Courier"/>
-              </a:rPr>
-              <a:t>).reshape(</a:t>
-            </a:r>
-            <a:r>
-              <a:rPr>
-                <a:solidFill>
-                  <a:srgbClr val="40A070"/>
-                </a:solidFill>
-                <a:latin typeface="Courier"/>
-              </a:rPr>
-              <a:t>3</a:t>
-            </a:r>
-            <a:r>
-              <a:rPr>
-                <a:latin typeface="Courier"/>
-              </a:rPr>
-              <a:t>, </a:t>
-            </a:r>
-            <a:r>
-              <a:rPr>
-                <a:solidFill>
-                  <a:srgbClr val="40A070"/>
-                </a:solidFill>
-                <a:latin typeface="Courier"/>
-              </a:rPr>
-              <a:t>4</a:t>
-            </a:r>
-            <a:r>
-              <a:rPr>
-                <a:latin typeface="Courier"/>
-              </a:rPr>
-              <a:t>)</a:t>
-            </a:r>
-            <a:br/>
-            <a:r>
-              <a:rPr>
-                <a:latin typeface="Courier"/>
-              </a:rPr>
-              <a:t>np.linspace(</a:t>
-            </a:r>
-            <a:r>
-              <a:rPr>
-                <a:solidFill>
-                  <a:srgbClr val="40A070"/>
-                </a:solidFill>
-                <a:latin typeface="Courier"/>
-              </a:rPr>
-              <a:t>0</a:t>
-            </a:r>
-            <a:r>
-              <a:rPr>
-                <a:latin typeface="Courier"/>
-              </a:rPr>
-              <a:t>, </a:t>
-            </a:r>
-            <a:r>
-              <a:rPr>
-                <a:solidFill>
-                  <a:srgbClr val="40A070"/>
-                </a:solidFill>
-                <a:latin typeface="Courier"/>
-              </a:rPr>
-              <a:t>1</a:t>
-            </a:r>
-            <a:r>
-              <a:rPr>
-                <a:latin typeface="Courier"/>
-              </a:rPr>
-              <a:t>, </a:t>
-            </a:r>
-            <a:r>
-              <a:rPr>
-                <a:solidFill>
-                  <a:srgbClr val="40A070"/>
-                </a:solidFill>
-                <a:latin typeface="Courier"/>
-              </a:rPr>
-              <a:t>5</a:t>
-            </a:r>
-            <a:r>
-              <a:rPr>
-                <a:latin typeface="Courier"/>
-              </a:rPr>
-              <a:t>)     </a:t>
-            </a:r>
-            <a:r>
-              <a:rPr i="1">
-                <a:solidFill>
-                  <a:srgbClr val="60A0B0"/>
-                </a:solidFill>
-                <a:latin typeface="Courier"/>
-              </a:rPr>
-              <a:t># 5 points</a:t>
-            </a:r>
-            <a:br/>
-            <a:r>
-              <a:rPr>
-                <a:latin typeface="Courier"/>
-              </a:rPr>
-              <a:t>np.zeros((</a:t>
-            </a:r>
-            <a:r>
-              <a:rPr>
-                <a:solidFill>
-                  <a:srgbClr val="40A070"/>
-                </a:solidFill>
-                <a:latin typeface="Courier"/>
-              </a:rPr>
-              <a:t>3</a:t>
-            </a:r>
-            <a:r>
-              <a:rPr>
-                <a:latin typeface="Courier"/>
-              </a:rPr>
-              <a:t>, </a:t>
-            </a:r>
-            <a:r>
-              <a:rPr>
-                <a:solidFill>
-                  <a:srgbClr val="40A070"/>
-                </a:solidFill>
-                <a:latin typeface="Courier"/>
-              </a:rPr>
-              <a:t>4</a:t>
-            </a:r>
-            <a:r>
-              <a:rPr>
-                <a:latin typeface="Courier"/>
-              </a:rPr>
-              <a:t>))</a:t>
-            </a:r>
-            <a:br/>
-            <a:r>
-              <a:rPr>
-                <a:latin typeface="Courier"/>
-              </a:rPr>
-              <a:t>np.eye(</a:t>
-            </a:r>
-            <a:r>
-              <a:rPr>
-                <a:solidFill>
-                  <a:srgbClr val="40A070"/>
-                </a:solidFill>
-                <a:latin typeface="Courier"/>
-              </a:rPr>
-              <a:t>4</a:t>
-            </a:r>
-            <a:r>
-              <a:rPr>
-                <a:latin typeface="Courier"/>
-              </a:rPr>
-              <a:t>)                </a:t>
-            </a:r>
-            <a:r>
-              <a:rPr i="1">
-                <a:solidFill>
-                  <a:srgbClr val="60A0B0"/>
-                </a:solidFill>
-                <a:latin typeface="Courier"/>
-              </a:rPr>
-              <a:t># identity</a:t>
-            </a:r>
-            <a:br/>
-            <a:br/>
-            <a:r>
-              <a:rPr>
-                <a:latin typeface="Courier"/>
-              </a:rPr>
-              <a:t>rng </a:t>
-            </a:r>
-            <a:r>
-              <a:rPr>
-                <a:solidFill>
-                  <a:srgbClr val="666666"/>
-                </a:solidFill>
-                <a:latin typeface="Courier"/>
-              </a:rPr>
-              <a:t>=</a:t>
-            </a:r>
-            <a:r>
-              <a:rPr>
-                <a:latin typeface="Courier"/>
-              </a:rPr>
-              <a:t> np.random.default_rng(</a:t>
-            </a:r>
-            <a:r>
-              <a:rPr>
-                <a:solidFill>
-                  <a:srgbClr val="40A070"/>
-                </a:solidFill>
-                <a:latin typeface="Courier"/>
-              </a:rPr>
-              <a:t>0</a:t>
-            </a:r>
-            <a:r>
-              <a:rPr>
-                <a:latin typeface="Courier"/>
-              </a:rPr>
-              <a:t>)</a:t>
-            </a:r>
-            <a:br/>
-            <a:r>
-              <a:rPr>
-                <a:latin typeface="Courier"/>
-              </a:rPr>
-              <a:t>rng.normal(</a:t>
-            </a:r>
-            <a:r>
-              <a:rPr>
-                <a:solidFill>
-                  <a:srgbClr val="40A070"/>
-                </a:solidFill>
-                <a:latin typeface="Courier"/>
-              </a:rPr>
-              <a:t>1.70</a:t>
-            </a:r>
-            <a:r>
-              <a:rPr>
-                <a:latin typeface="Courier"/>
-              </a:rPr>
-              <a:t>, </a:t>
-            </a:r>
-            <a:r>
-              <a:rPr>
-                <a:solidFill>
-                  <a:srgbClr val="40A070"/>
-                </a:solidFill>
-                <a:latin typeface="Courier"/>
-              </a:rPr>
-              <a:t>0.09</a:t>
-            </a:r>
-            <a:r>
-              <a:rPr>
-                <a:latin typeface="Courier"/>
-              </a:rPr>
-              <a:t>, </a:t>
-            </a:r>
-            <a:r>
-              <a:rPr>
-                <a:solidFill>
-                  <a:srgbClr val="40A070"/>
-                </a:solidFill>
-                <a:latin typeface="Courier"/>
-              </a:rPr>
-              <a:t>200</a:t>
-            </a:r>
-            <a:r>
-              <a:rPr>
-                <a:latin typeface="Courier"/>
-              </a:rPr>
-              <a:t>)</a:t>
-            </a:r>
-          </a:p>
-        </p:txBody>
-      </p:sp>
+        </p:nvGraphicFramePr>
+        <p:xfrm>
+          <a:off x="457200" y="1193800"/>
+          <a:ext cx="8229600" cy="3390900"/>
+        </p:xfrm>
+        <a:graphic>
+          <a:graphicData uri="http://schemas.openxmlformats.org/drawingml/2006/table">
+            <a:tbl>
+              <a:tblPr firstRow="1" bandRow="1">
+                <a:tableStyleId>{5C22544A-7EE6-4342-B048-85BDC9FD1C3A}</a:tableStyleId>
+              </a:tblPr>
+              <a:tblGrid>
+                <a:gridCol w="2057400"/>
+                <a:gridCol w="2057400"/>
+                <a:gridCol w="2057400"/>
+                <a:gridCol w="2057400"/>
+              </a:tblGrid>
+              <a:tr h="0">
+                <a:tc>
+                  <a:txBody>
+                    <a:bodyPr>
+                      <a:normAutofit/>
+                    </a:bodyPr>
+                    <a:lstStyle/>
+                    <a:p>
+                      <a:pPr lvl="0" indent="0" marL="0">
+                        <a:buNone/>
+                      </a:pPr>
+                      <a:r>
+                        <a:rPr/>
+                        <a:t>dtype</a:t>
+                      </a:r>
+                    </a:p>
+                  </a:txBody>
+                  <a:tcPr/>
+                </a:tc>
+                <a:tc>
+                  <a:txBody>
+                    <a:bodyPr>
+                      <a:normAutofit/>
+                    </a:bodyPr>
+                    <a:lstStyle/>
+                    <a:p>
+                      <a:pPr lvl="0" indent="0" marL="0">
+                        <a:buNone/>
+                      </a:pPr>
+                      <a:r>
+                        <a:rPr/>
+                        <a:t>bytes</a:t>
+                      </a:r>
+                    </a:p>
+                  </a:txBody>
+                  <a:tcPr/>
+                </a:tc>
+                <a:tc>
+                  <a:txBody>
+                    <a:bodyPr>
+                      <a:normAutofit/>
+                    </a:bodyPr>
+                    <a:lstStyle/>
+                    <a:p>
+                      <a:pPr lvl="0" indent="0" marL="0">
+                        <a:buNone/>
+                      </a:pPr>
+                      <a:r>
+                        <a:rPr/>
+                        <a:t>holds</a:t>
+                      </a:r>
+                    </a:p>
+                  </a:txBody>
+                  <a:tcPr/>
+                </a:tc>
+                <a:tc>
+                  <a:txBody>
+                    <a:bodyPr>
+                      <a:normAutofit/>
+                    </a:bodyPr>
+                    <a:lstStyle/>
+                    <a:p>
+                      <a:pPr lvl="0" indent="0" marL="0">
+                        <a:buNone/>
+                      </a:pPr>
+                      <a:r>
+                        <a:rPr/>
+                        <a:t>typical use</a:t>
+                      </a:r>
+                    </a:p>
+                  </a:txBody>
+                  <a:tcPr/>
+                </a:tc>
+              </a:tr>
+              <a:tr h="0">
+                <a:tc>
+                  <a:txBody>
+                    <a:bodyPr>
+                      <a:normAutofit/>
+                    </a:bodyPr>
+                    <a:lstStyle/>
+                    <a:p>
+                      <a:pPr lvl="0" indent="0" marL="0">
+                        <a:buNone/>
+                      </a:pPr>
+                      <a:r>
+                        <a:rPr>
+                          <a:latin typeface="Courier"/>
+                        </a:rPr>
+                        <a:t>bool</a:t>
+                      </a:r>
+                    </a:p>
+                  </a:txBody>
+                </a:tc>
+                <a:tc>
+                  <a:txBody>
+                    <a:bodyPr>
+                      <a:normAutofit/>
+                    </a:bodyPr>
+                    <a:lstStyle/>
+                    <a:p>
+                      <a:pPr lvl="0" indent="0" marL="0">
+                        <a:buNone/>
+                      </a:pPr>
+                      <a:r>
+                        <a:rPr/>
+                        <a:t>1</a:t>
+                      </a:r>
+                    </a:p>
+                  </a:txBody>
+                </a:tc>
+                <a:tc>
+                  <a:txBody>
+                    <a:bodyPr>
+                      <a:normAutofit/>
+                    </a:bodyPr>
+                    <a:lstStyle/>
+                    <a:p>
+                      <a:pPr lvl="0" indent="0" marL="0">
+                        <a:buNone/>
+                      </a:pPr>
+                      <a:r>
+                        <a:rPr>
+                          <a:latin typeface="Courier"/>
+                        </a:rPr>
+                        <a:t>True</a:t>
+                      </a:r>
+                      <a:r>
+                        <a:rPr/>
+                        <a:t> / </a:t>
+                      </a:r>
+                      <a:r>
+                        <a:rPr>
+                          <a:latin typeface="Courier"/>
+                        </a:rPr>
+                        <a:t>False</a:t>
+                      </a:r>
+                    </a:p>
+                  </a:txBody>
+                </a:tc>
+                <a:tc>
+                  <a:txBody>
+                    <a:bodyPr>
+                      <a:normAutofit/>
+                    </a:bodyPr>
+                    <a:lstStyle/>
+                    <a:p>
+                      <a:pPr lvl="0" indent="0" marL="0">
+                        <a:buNone/>
+                      </a:pPr>
+                      <a:r>
+                        <a:rPr/>
+                        <a:t>masks</a:t>
+                      </a:r>
+                    </a:p>
+                  </a:txBody>
+                </a:tc>
+              </a:tr>
+              <a:tr h="0">
+                <a:tc>
+                  <a:txBody>
+                    <a:bodyPr>
+                      <a:normAutofit/>
+                    </a:bodyPr>
+                    <a:lstStyle/>
+                    <a:p>
+                      <a:pPr lvl="0" indent="0" marL="0">
+                        <a:buNone/>
+                      </a:pPr>
+                      <a:r>
+                        <a:rPr>
+                          <a:latin typeface="Courier"/>
+                        </a:rPr>
+                        <a:t>uint8</a:t>
+                      </a:r>
+                    </a:p>
+                  </a:txBody>
+                </a:tc>
+                <a:tc>
+                  <a:txBody>
+                    <a:bodyPr>
+                      <a:normAutofit/>
+                    </a:bodyPr>
+                    <a:lstStyle/>
+                    <a:p>
+                      <a:pPr lvl="0" indent="0" marL="0">
+                        <a:buNone/>
+                      </a:pPr>
+                      <a:r>
+                        <a:rPr/>
+                        <a:t>1</a:t>
+                      </a:r>
+                    </a:p>
+                  </a:txBody>
+                </a:tc>
+                <a:tc>
+                  <a:txBody>
+                    <a:bodyPr>
+                      <a:normAutofit/>
+                    </a:bodyPr>
+                    <a:lstStyle/>
+                    <a:p>
+                      <a:pPr lvl="0" indent="0" marL="0">
+                        <a:buNone/>
+                      </a:pPr>
+                      <a:r>
+                        <a:rPr/>
+                        <a:t>0 to 255</a:t>
+                      </a:r>
+                    </a:p>
+                  </a:txBody>
+                </a:tc>
+                <a:tc>
+                  <a:txBody>
+                    <a:bodyPr>
+                      <a:normAutofit/>
+                    </a:bodyPr>
+                    <a:lstStyle/>
+                    <a:p>
+                      <a:pPr lvl="0" indent="0" marL="0">
+                        <a:buNone/>
+                      </a:pPr>
+                      <a:r>
+                        <a:rPr/>
+                        <a:t>image pixels</a:t>
+                      </a:r>
+                    </a:p>
+                  </a:txBody>
+                </a:tc>
+              </a:tr>
+              <a:tr h="0">
+                <a:tc>
+                  <a:txBody>
+                    <a:bodyPr>
+                      <a:normAutofit/>
+                    </a:bodyPr>
+                    <a:lstStyle/>
+                    <a:p>
+                      <a:pPr lvl="0" indent="0" marL="0">
+                        <a:buNone/>
+                      </a:pPr>
+                      <a:r>
+                        <a:rPr>
+                          <a:latin typeface="Courier"/>
+                        </a:rPr>
+                        <a:t>int16</a:t>
+                      </a:r>
+                    </a:p>
+                  </a:txBody>
+                </a:tc>
+                <a:tc>
+                  <a:txBody>
+                    <a:bodyPr>
+                      <a:normAutofit/>
+                    </a:bodyPr>
+                    <a:lstStyle/>
+                    <a:p>
+                      <a:pPr lvl="0" indent="0" marL="0">
+                        <a:buNone/>
+                      </a:pPr>
+                      <a:r>
+                        <a:rPr/>
+                        <a:t>2</a:t>
+                      </a:r>
+                    </a:p>
+                  </a:txBody>
+                </a:tc>
+                <a:tc>
+                  <a:txBody>
+                    <a:bodyPr>
+                      <a:normAutofit/>
+                    </a:bodyPr>
+                    <a:lstStyle/>
+                    <a:p>
+                      <a:pPr lvl="0" indent="0" marL="0">
+                        <a:buNone/>
+                      </a:pPr>
+                      <a:r>
+                        <a:rPr/>
+                        <a:t>-32 768 to 32 767</a:t>
+                      </a:r>
+                    </a:p>
+                  </a:txBody>
+                </a:tc>
+                <a:tc>
+                  <a:txBody>
+                    <a:bodyPr>
+                      <a:normAutofit/>
+                    </a:bodyPr>
+                    <a:lstStyle/>
+                    <a:p>
+                      <a:pPr lvl="0" indent="0" marL="0">
+                        <a:buNone/>
+                      </a:pPr>
+                      <a:r>
+                        <a:rPr/>
+                        <a:t>CT scans (Hounsfield units)</a:t>
+                      </a:r>
+                    </a:p>
+                  </a:txBody>
+                </a:tc>
+              </a:tr>
+              <a:tr h="0">
+                <a:tc>
+                  <a:txBody>
+                    <a:bodyPr>
+                      <a:normAutofit/>
+                    </a:bodyPr>
+                    <a:lstStyle/>
+                    <a:p>
+                      <a:pPr lvl="0" indent="0" marL="0">
+                        <a:buNone/>
+                      </a:pPr>
+                      <a:r>
+                        <a:rPr>
+                          <a:latin typeface="Courier"/>
+                        </a:rPr>
+                        <a:t>int64</a:t>
+                      </a:r>
+                    </a:p>
+                  </a:txBody>
+                </a:tc>
+                <a:tc>
+                  <a:txBody>
+                    <a:bodyPr>
+                      <a:normAutofit/>
+                    </a:bodyPr>
+                    <a:lstStyle/>
+                    <a:p>
+                      <a:pPr lvl="0" indent="0" marL="0">
+                        <a:buNone/>
+                      </a:pPr>
+                      <a:r>
+                        <a:rPr/>
+                        <a:t>8</a:t>
+                      </a:r>
+                    </a:p>
+                  </a:txBody>
+                </a:tc>
+                <a:tc>
+                  <a:txBody>
+                    <a:bodyPr>
+                      <a:normAutofit/>
+                    </a:bodyPr>
+                    <a:lstStyle/>
+                    <a:p>
+                      <a:pPr lvl="0" indent="0" marL="0">
+                        <a:buNone/>
+                      </a:pPr>
+                      <a:r>
+                        <a:rPr/>
+                        <a:t>about ±9.2e18</a:t>
+                      </a:r>
+                    </a:p>
+                  </a:txBody>
+                </a:tc>
+                <a:tc>
+                  <a:txBody>
+                    <a:bodyPr>
+                      <a:normAutofit/>
+                    </a:bodyPr>
+                    <a:lstStyle/>
+                    <a:p>
+                      <a:pPr lvl="0" indent="0" marL="0">
+                        <a:buNone/>
+                      </a:pPr>
+                      <a:r>
+                        <a:rPr/>
+                        <a:t>counts, ids (the default int)</a:t>
+                      </a:r>
+                    </a:p>
+                  </a:txBody>
+                </a:tc>
+              </a:tr>
+              <a:tr h="0">
+                <a:tc>
+                  <a:txBody>
+                    <a:bodyPr>
+                      <a:normAutofit/>
+                    </a:bodyPr>
+                    <a:lstStyle/>
+                    <a:p>
+                      <a:pPr lvl="0" indent="0" marL="0">
+                        <a:buNone/>
+                      </a:pPr>
+                      <a:r>
+                        <a:rPr>
+                          <a:latin typeface="Courier"/>
+                        </a:rPr>
+                        <a:t>float16</a:t>
+                      </a:r>
+                    </a:p>
+                  </a:txBody>
+                </a:tc>
+                <a:tc>
+                  <a:txBody>
+                    <a:bodyPr>
+                      <a:normAutofit/>
+                    </a:bodyPr>
+                    <a:lstStyle/>
+                    <a:p>
+                      <a:pPr lvl="0" indent="0" marL="0">
+                        <a:buNone/>
+                      </a:pPr>
+                      <a:r>
+                        <a:rPr/>
+                        <a:t>2</a:t>
+                      </a:r>
+                    </a:p>
+                  </a:txBody>
+                </a:tc>
+                <a:tc>
+                  <a:txBody>
+                    <a:bodyPr>
+                      <a:normAutofit/>
+                    </a:bodyPr>
+                    <a:lstStyle/>
+                    <a:p>
+                      <a:pPr lvl="0" indent="0" marL="0">
+                        <a:buNone/>
+                      </a:pPr>
+                      <a:r>
+                        <a:rPr/>
+                        <a:t>~3 digits, up to 65 504</a:t>
+                      </a:r>
+                    </a:p>
+                  </a:txBody>
+                </a:tc>
+                <a:tc>
+                  <a:txBody>
+                    <a:bodyPr>
+                      <a:normAutofit/>
+                    </a:bodyPr>
+                    <a:lstStyle/>
+                    <a:p>
+                      <a:pPr lvl="0" indent="0" marL="0">
+                        <a:buNone/>
+                      </a:pPr>
+                      <a:r>
+                        <a:rPr/>
+                        <a:t>deep learning</a:t>
+                      </a:r>
+                    </a:p>
+                  </a:txBody>
+                </a:tc>
+              </a:tr>
+              <a:tr h="0">
+                <a:tc>
+                  <a:txBody>
+                    <a:bodyPr>
+                      <a:normAutofit/>
+                    </a:bodyPr>
+                    <a:lstStyle/>
+                    <a:p>
+                      <a:pPr lvl="0" indent="0" marL="0">
+                        <a:buNone/>
+                      </a:pPr>
+                      <a:r>
+                        <a:rPr>
+                          <a:latin typeface="Courier"/>
+                        </a:rPr>
+                        <a:t>float32</a:t>
+                      </a:r>
+                    </a:p>
+                  </a:txBody>
+                </a:tc>
+                <a:tc>
+                  <a:txBody>
+                    <a:bodyPr>
+                      <a:normAutofit/>
+                    </a:bodyPr>
+                    <a:lstStyle/>
+                    <a:p>
+                      <a:pPr lvl="0" indent="0" marL="0">
+                        <a:buNone/>
+                      </a:pPr>
+                      <a:r>
+                        <a:rPr/>
+                        <a:t>4</a:t>
+                      </a:r>
+                    </a:p>
+                  </a:txBody>
+                </a:tc>
+                <a:tc>
+                  <a:txBody>
+                    <a:bodyPr>
+                      <a:normAutofit/>
+                    </a:bodyPr>
+                    <a:lstStyle/>
+                    <a:p>
+                      <a:pPr lvl="0" indent="0" marL="0">
+                        <a:buNone/>
+                      </a:pPr>
+                      <a:r>
+                        <a:rPr/>
+                        <a:t>~7 digits</a:t>
+                      </a:r>
+                    </a:p>
+                  </a:txBody>
+                </a:tc>
+                <a:tc>
+                  <a:txBody>
+                    <a:bodyPr>
+                      <a:normAutofit/>
+                    </a:bodyPr>
+                    <a:lstStyle/>
+                    <a:p>
+                      <a:pPr lvl="0" indent="0" marL="0">
+                        <a:buNone/>
+                      </a:pPr>
+                      <a:r>
+                        <a:rPr/>
+                        <a:t>images, deep learning, GPUs</a:t>
+                      </a:r>
+                    </a:p>
+                  </a:txBody>
+                </a:tc>
+              </a:tr>
+              <a:tr h="0">
+                <a:tc>
+                  <a:txBody>
+                    <a:bodyPr>
+                      <a:normAutofit/>
+                    </a:bodyPr>
+                    <a:lstStyle/>
+                    <a:p>
+                      <a:pPr lvl="0" indent="0" marL="0">
+                        <a:buNone/>
+                      </a:pPr>
+                      <a:r>
+                        <a:rPr>
+                          <a:latin typeface="Courier"/>
+                        </a:rPr>
+                        <a:t>float64</a:t>
+                      </a:r>
+                    </a:p>
+                  </a:txBody>
+                </a:tc>
+                <a:tc>
+                  <a:txBody>
+                    <a:bodyPr>
+                      <a:normAutofit/>
+                    </a:bodyPr>
+                    <a:lstStyle/>
+                    <a:p>
+                      <a:pPr lvl="0" indent="0" marL="0">
+                        <a:buNone/>
+                      </a:pPr>
+                      <a:r>
+                        <a:rPr/>
+                        <a:t>8</a:t>
+                      </a:r>
+                    </a:p>
+                  </a:txBody>
+                </a:tc>
+                <a:tc>
+                  <a:txBody>
+                    <a:bodyPr>
+                      <a:normAutofit/>
+                    </a:bodyPr>
+                    <a:lstStyle/>
+                    <a:p>
+                      <a:pPr lvl="0" indent="0" marL="0">
+                        <a:buNone/>
+                      </a:pPr>
+                      <a:r>
+                        <a:rPr/>
+                        <a:t>~16 digits</a:t>
+                      </a:r>
+                    </a:p>
+                  </a:txBody>
+                </a:tc>
+                <a:tc>
+                  <a:txBody>
+                    <a:bodyPr>
+                      <a:normAutofit/>
+                    </a:bodyPr>
+                    <a:lstStyle/>
+                    <a:p>
+                      <a:pPr lvl="0" indent="0" marL="0">
+                        <a:buNone/>
+                      </a:pPr>
+                      <a:r>
+                        <a:rPr/>
+                        <a:t>statistics (the default float)</a:t>
+                      </a:r>
+                    </a:p>
+                  </a:txBody>
+                </a:tc>
+              </a:tr>
+            </a:tbl>
+          </a:graphicData>
+        </a:graphic>
+      </p:graphicFrame>
     </p:spTree>
   </p:cSld>
 </p:sld>
@@ -10698,14 +11762,14 @@
             </a:pPr>
             <a:r>
               <a:rPr/>
-              <a:t>Indexing in two dimensions</a:t>
+              <a:t>Inside a float</a:t>
             </a:r>
           </a:p>
         </p:txBody>
       </p:sp>
       <p:pic>
         <p:nvPicPr>
-          <p:cNvPr descr="img/array_index.png" id="0" name="Picture 1"/>
+          <p:cNvPr descr="img/float_bits.png" id="0" name="Picture 1"/>
           <p:cNvPicPr>
             <a:picLocks noGrp="1" noChangeAspect="1"/>
           </p:cNvPicPr>
@@ -10777,251 +11841,41 @@
             </a:pPr>
             <a:r>
               <a:rPr/>
-              <a:t>Operations are element-wise</a:t>
-            </a:r>
-          </a:p>
-        </p:txBody>
-      </p:sp>
-      <p:sp>
-        <p:nvSpPr>
-          <p:cNvPr id="3" name="Content Placeholder 2"/>
-          <p:cNvSpPr>
-            <a:spLocks noGrp="1"/>
-          </p:cNvSpPr>
-          <p:nvPr>
-            <p:ph idx="1"/>
-          </p:nvPr>
-        </p:nvSpPr>
-        <p:spPr/>
-        <p:txBody>
-          <a:bodyPr>
-            <a:normAutofit/>
-          </a:bodyPr>
-          <a:lstStyle/>
-          <a:p>
-            <a:pPr lvl="0" indent="0">
-              <a:buNone/>
-            </a:pPr>
-            <a:r>
-              <a:rPr>
-                <a:latin typeface="Courier"/>
-              </a:rPr>
-              <a:t>x </a:t>
-            </a:r>
-            <a:r>
-              <a:rPr>
-                <a:solidFill>
-                  <a:srgbClr val="666666"/>
-                </a:solidFill>
-                <a:latin typeface="Courier"/>
-              </a:rPr>
-              <a:t>=</a:t>
-            </a:r>
-            <a:r>
-              <a:rPr>
-                <a:latin typeface="Courier"/>
-              </a:rPr>
-              <a:t> np.arange(</a:t>
-            </a:r>
-            <a:r>
-              <a:rPr>
-                <a:solidFill>
-                  <a:srgbClr val="40A070"/>
-                </a:solidFill>
-                <a:latin typeface="Courier"/>
-              </a:rPr>
-              <a:t>5</a:t>
-            </a:r>
-            <a:r>
-              <a:rPr>
-                <a:latin typeface="Courier"/>
-              </a:rPr>
-              <a:t>)   </a:t>
-            </a:r>
-            <a:r>
-              <a:rPr i="1">
-                <a:solidFill>
-                  <a:srgbClr val="60A0B0"/>
-                </a:solidFill>
-                <a:latin typeface="Courier"/>
-              </a:rPr>
-              <a:t># [0 1 2 3 4]</a:t>
-            </a:r>
-            <a:br/>
-            <a:br/>
-            <a:r>
-              <a:rPr>
-                <a:latin typeface="Courier"/>
-              </a:rPr>
-              <a:t>x </a:t>
-            </a:r>
-            <a:r>
-              <a:rPr>
-                <a:solidFill>
-                  <a:srgbClr val="666666"/>
-                </a:solidFill>
-                <a:latin typeface="Courier"/>
-              </a:rPr>
-              <a:t>**</a:t>
-            </a:r>
-            <a:r>
-              <a:rPr>
-                <a:latin typeface="Courier"/>
-              </a:rPr>
-              <a:t> </a:t>
-            </a:r>
-            <a:r>
-              <a:rPr>
-                <a:solidFill>
-                  <a:srgbClr val="40A070"/>
-                </a:solidFill>
-                <a:latin typeface="Courier"/>
-              </a:rPr>
-              <a:t>2</a:t>
-            </a:r>
-            <a:r>
-              <a:rPr>
-                <a:latin typeface="Courier"/>
-              </a:rPr>
-              <a:t>             </a:t>
-            </a:r>
-            <a:r>
-              <a:rPr i="1">
-                <a:solidFill>
-                  <a:srgbClr val="60A0B0"/>
-                </a:solidFill>
-                <a:latin typeface="Courier"/>
-              </a:rPr>
-              <a:t># [0 1 4 9 16]</a:t>
-            </a:r>
-            <a:br/>
-            <a:r>
-              <a:rPr>
-                <a:latin typeface="Courier"/>
-              </a:rPr>
-              <a:t>x </a:t>
-            </a:r>
-            <a:r>
-              <a:rPr>
-                <a:solidFill>
-                  <a:srgbClr val="666666"/>
-                </a:solidFill>
-                <a:latin typeface="Courier"/>
-              </a:rPr>
-              <a:t>+</a:t>
-            </a:r>
-            <a:r>
-              <a:rPr>
-                <a:latin typeface="Courier"/>
-              </a:rPr>
-              <a:t> </a:t>
-            </a:r>
-            <a:r>
-              <a:rPr>
-                <a:solidFill>
-                  <a:srgbClr val="40A070"/>
-                </a:solidFill>
-                <a:latin typeface="Courier"/>
-              </a:rPr>
-              <a:t>10</a:t>
-            </a:r>
-            <a:r>
-              <a:rPr>
-                <a:latin typeface="Courier"/>
-              </a:rPr>
-              <a:t>             </a:t>
-            </a:r>
-            <a:r>
-              <a:rPr i="1">
-                <a:solidFill>
-                  <a:srgbClr val="60A0B0"/>
-                </a:solidFill>
-                <a:latin typeface="Courier"/>
-              </a:rPr>
-              <a:t># [10 11 12 13 14]</a:t>
-            </a:r>
-            <a:br/>
-            <a:r>
-              <a:rPr>
-                <a:latin typeface="Courier"/>
-              </a:rPr>
-              <a:t>np.sqrt(x)         </a:t>
-            </a:r>
-            <a:r>
-              <a:rPr i="1">
-                <a:solidFill>
-                  <a:srgbClr val="60A0B0"/>
-                </a:solidFill>
-                <a:latin typeface="Courier"/>
-              </a:rPr>
-              <a:t># no loop</a:t>
-            </a:r>
-            <a:br/>
-            <a:br/>
-            <a:r>
-              <a:rPr>
-                <a:latin typeface="Courier"/>
-              </a:rPr>
-              <a:t>t </a:t>
-            </a:r>
-            <a:r>
-              <a:rPr>
-                <a:solidFill>
-                  <a:srgbClr val="666666"/>
-                </a:solidFill>
-                <a:latin typeface="Courier"/>
-              </a:rPr>
-              <a:t>*</a:t>
-            </a:r>
-            <a:r>
-              <a:rPr>
-                <a:latin typeface="Courier"/>
-              </a:rPr>
-              <a:t> t              </a:t>
-            </a:r>
-            <a:r>
-              <a:rPr i="1">
-                <a:solidFill>
-                  <a:srgbClr val="60A0B0"/>
-                </a:solidFill>
-                <a:latin typeface="Courier"/>
-              </a:rPr>
-              <a:t># element-wise</a:t>
-            </a:r>
-            <a:br/>
-            <a:r>
-              <a:rPr>
-                <a:latin typeface="Courier"/>
-              </a:rPr>
-              <a:t>t </a:t>
-            </a:r>
-            <a:r>
-              <a:rPr>
-                <a:solidFill>
-                  <a:srgbClr val="666666"/>
-                </a:solidFill>
-                <a:latin typeface="Courier"/>
-              </a:rPr>
-              <a:t>@</a:t>
-            </a:r>
-            <a:r>
-              <a:rPr>
-                <a:latin typeface="Courier"/>
-              </a:rPr>
-              <a:t> t.T            </a:t>
-            </a:r>
-            <a:r>
-              <a:rPr i="1">
-                <a:solidFill>
-                  <a:srgbClr val="60A0B0"/>
-                </a:solidFill>
-                <a:latin typeface="Courier"/>
-              </a:rPr>
-              <a:t># matrix product</a:t>
-            </a:r>
-          </a:p>
-        </p:txBody>
-      </p:sp>
+              <a:t>The same values, four precisions</a:t>
+            </a:r>
+          </a:p>
+        </p:txBody>
+      </p:sp>
+      <p:pic>
+        <p:nvPicPr>
+          <p:cNvPr descr="img/float_precision.png" id="0" name="Picture 1"/>
+          <p:cNvPicPr>
+            <a:picLocks noGrp="1" noChangeAspect="1"/>
+          </p:cNvPicPr>
+          <p:nvPr/>
+        </p:nvPicPr>
+        <p:blipFill>
+          <a:blip r:embed="rId3"/>
+          <a:stretch>
+            <a:fillRect/>
+          </a:stretch>
+        </p:blipFill>
+        <p:spPr bwMode="auto">
+          <a:xfrm>
+            <a:off x="457200" y="1193800"/>
+            <a:ext cx="8229600" cy="3390900"/>
+          </a:xfrm>
+          <a:prstGeom prst="rect">
+            <a:avLst/>
+          </a:prstGeom>
+          <a:noFill/>
+          <a:ln w="9525">
+            <a:noFill/>
+            <a:headEnd/>
+            <a:tailEnd/>
+          </a:ln>
+        </p:spPr>
+      </p:pic>
     </p:spTree>
   </p:cSld>
 </p:sld>
@@ -11145,14 +11999,14 @@
             </a:pPr>
             <a:r>
               <a:rPr/>
-              <a:t>Broadcasting</a:t>
+              <a:t>Smaller is lighter and faster</a:t>
             </a:r>
           </a:p>
         </p:txBody>
       </p:sp>
       <p:pic>
         <p:nvPicPr>
-          <p:cNvPr descr="img/broadcasting.png" id="0" name="Picture 1"/>
+          <p:cNvPr descr="img/dtype_memory.png" id="0" name="Picture 1"/>
           <p:cNvPicPr>
             <a:picLocks noGrp="1" noChangeAspect="1"/>
           </p:cNvPicPr>
@@ -11224,6 +12078,1251 @@
             </a:pPr>
             <a:r>
               <a:rPr/>
+              <a:t>Choosing and converting</a:t>
+            </a:r>
+          </a:p>
+        </p:txBody>
+      </p:sp>
+      <p:sp>
+        <p:nvSpPr>
+          <p:cNvPr id="3" name="Content Placeholder 2"/>
+          <p:cNvSpPr>
+            <a:spLocks noGrp="1"/>
+          </p:cNvSpPr>
+          <p:nvPr>
+            <p:ph idx="1"/>
+          </p:nvPr>
+        </p:nvSpPr>
+        <p:spPr/>
+        <p:txBody>
+          <a:bodyPr>
+            <a:normAutofit/>
+          </a:bodyPr>
+          <a:lstStyle/>
+          <a:p>
+            <a:pPr lvl="0" indent="0">
+              <a:buNone/>
+            </a:pPr>
+            <a:r>
+              <a:rPr>
+                <a:latin typeface="Courier"/>
+              </a:rPr>
+              <a:t>x </a:t>
+            </a:r>
+            <a:r>
+              <a:rPr>
+                <a:solidFill>
+                  <a:srgbClr val="666666"/>
+                </a:solidFill>
+                <a:latin typeface="Courier"/>
+              </a:rPr>
+              <a:t>=</a:t>
+            </a:r>
+            <a:r>
+              <a:rPr>
+                <a:latin typeface="Courier"/>
+              </a:rPr>
+              <a:t> np.arange(</a:t>
+            </a:r>
+            <a:r>
+              <a:rPr>
+                <a:solidFill>
+                  <a:srgbClr val="40A070"/>
+                </a:solidFill>
+                <a:latin typeface="Courier"/>
+              </a:rPr>
+              <a:t>4</a:t>
+            </a:r>
+            <a:r>
+              <a:rPr>
+                <a:latin typeface="Courier"/>
+              </a:rPr>
+              <a:t>, dtype</a:t>
+            </a:r>
+            <a:r>
+              <a:rPr>
+                <a:solidFill>
+                  <a:srgbClr val="666666"/>
+                </a:solidFill>
+                <a:latin typeface="Courier"/>
+              </a:rPr>
+              <a:t>=</a:t>
+            </a:r>
+            <a:r>
+              <a:rPr>
+                <a:latin typeface="Courier"/>
+              </a:rPr>
+              <a:t>np.float32)</a:t>
+            </a:r>
+            <a:br/>
+            <a:r>
+              <a:rPr>
+                <a:latin typeface="Courier"/>
+              </a:rPr>
+              <a:t>x.dtype, x.nbytes        </a:t>
+            </a:r>
+            <a:r>
+              <a:rPr i="1">
+                <a:solidFill>
+                  <a:srgbClr val="60A0B0"/>
+                </a:solidFill>
+                <a:latin typeface="Courier"/>
+              </a:rPr>
+              <a:t># float32, 16</a:t>
+            </a:r>
+            <a:br/>
+            <a:r>
+              <a:rPr>
+                <a:latin typeface="Courier"/>
+              </a:rPr>
+              <a:t>x.astype(np.float16)     </a:t>
+            </a:r>
+            <a:r>
+              <a:rPr i="1">
+                <a:solidFill>
+                  <a:srgbClr val="60A0B0"/>
+                </a:solidFill>
+                <a:latin typeface="Courier"/>
+              </a:rPr>
+              <a:t># convert: a copy</a:t>
+            </a:r>
+            <a:br/>
+            <a:br/>
+            <a:r>
+              <a:rPr>
+                <a:latin typeface="Courier"/>
+              </a:rPr>
+              <a:t>np.array([</a:t>
+            </a:r>
+            <a:r>
+              <a:rPr>
+                <a:solidFill>
+                  <a:srgbClr val="40A070"/>
+                </a:solidFill>
+                <a:latin typeface="Courier"/>
+              </a:rPr>
+              <a:t>250</a:t>
+            </a:r>
+            <a:r>
+              <a:rPr>
+                <a:latin typeface="Courier"/>
+              </a:rPr>
+              <a:t>], dtype</a:t>
+            </a:r>
+            <a:r>
+              <a:rPr>
+                <a:solidFill>
+                  <a:srgbClr val="666666"/>
+                </a:solidFill>
+                <a:latin typeface="Courier"/>
+              </a:rPr>
+              <a:t>=</a:t>
+            </a:r>
+            <a:r>
+              <a:rPr>
+                <a:latin typeface="Courier"/>
+              </a:rPr>
+              <a:t>np.uint8) </a:t>
+            </a:r>
+            <a:r>
+              <a:rPr>
+                <a:solidFill>
+                  <a:srgbClr val="666666"/>
+                </a:solidFill>
+                <a:latin typeface="Courier"/>
+              </a:rPr>
+              <a:t>+</a:t>
+            </a:r>
+            <a:r>
+              <a:rPr>
+                <a:latin typeface="Courier"/>
+              </a:rPr>
+              <a:t> </a:t>
+            </a:r>
+            <a:r>
+              <a:rPr>
+                <a:solidFill>
+                  <a:srgbClr val="40A070"/>
+                </a:solidFill>
+                <a:latin typeface="Courier"/>
+              </a:rPr>
+              <a:t>10</a:t>
+            </a:r>
+            <a:br/>
+            <a:r>
+              <a:rPr>
+                <a:latin typeface="Courier"/>
+              </a:rPr>
+              <a:t>                         </a:t>
+            </a:r>
+            <a:r>
+              <a:rPr i="1">
+                <a:solidFill>
+                  <a:srgbClr val="60A0B0"/>
+                </a:solidFill>
+                <a:latin typeface="Courier"/>
+              </a:rPr>
+              <a:t># [4], not 260</a:t>
+            </a:r>
+            <a:br/>
+            <a:r>
+              <a:rPr>
+                <a:latin typeface="Courier"/>
+              </a:rPr>
+              <a:t>np.float16(</a:t>
+            </a:r>
+            <a:r>
+              <a:rPr>
+                <a:solidFill>
+                  <a:srgbClr val="40A070"/>
+                </a:solidFill>
+                <a:latin typeface="Courier"/>
+              </a:rPr>
+              <a:t>70000</a:t>
+            </a:r>
+            <a:r>
+              <a:rPr>
+                <a:latin typeface="Courier"/>
+              </a:rPr>
+              <a:t>)        </a:t>
+            </a:r>
+            <a:r>
+              <a:rPr i="1">
+                <a:solidFill>
+                  <a:srgbClr val="60A0B0"/>
+                </a:solidFill>
+                <a:latin typeface="Courier"/>
+              </a:rPr>
+              <a:t># inf: overflow</a:t>
+            </a:r>
+            <a:br/>
+            <a:br/>
+            <a:r>
+              <a:rPr>
+                <a:latin typeface="Courier"/>
+              </a:rPr>
+              <a:t>h </a:t>
+            </a:r>
+            <a:r>
+              <a:rPr>
+                <a:solidFill>
+                  <a:srgbClr val="666666"/>
+                </a:solidFill>
+                <a:latin typeface="Courier"/>
+              </a:rPr>
+              <a:t>=</a:t>
+            </a:r>
+            <a:r>
+              <a:rPr>
+                <a:latin typeface="Courier"/>
+              </a:rPr>
+              <a:t> np.full(</a:t>
+            </a:r>
+            <a:r>
+              <a:rPr>
+                <a:solidFill>
+                  <a:srgbClr val="40A070"/>
+                </a:solidFill>
+                <a:latin typeface="Courier"/>
+              </a:rPr>
+              <a:t>10000</a:t>
+            </a:r>
+            <a:r>
+              <a:rPr>
+                <a:latin typeface="Courier"/>
+              </a:rPr>
+              <a:t>, </a:t>
+            </a:r>
+            <a:r>
+              <a:rPr>
+                <a:solidFill>
+                  <a:srgbClr val="40A070"/>
+                </a:solidFill>
+                <a:latin typeface="Courier"/>
+              </a:rPr>
+              <a:t>0.1</a:t>
+            </a:r>
+            <a:r>
+              <a:rPr>
+                <a:latin typeface="Courier"/>
+              </a:rPr>
+              <a:t>, dtype</a:t>
+            </a:r>
+            <a:r>
+              <a:rPr>
+                <a:solidFill>
+                  <a:srgbClr val="666666"/>
+                </a:solidFill>
+                <a:latin typeface="Courier"/>
+              </a:rPr>
+              <a:t>=</a:t>
+            </a:r>
+            <a:r>
+              <a:rPr>
+                <a:latin typeface="Courier"/>
+              </a:rPr>
+              <a:t>np.float16)</a:t>
+            </a:r>
+            <a:br/>
+            <a:r>
+              <a:rPr>
+                <a:latin typeface="Courier"/>
+              </a:rPr>
+              <a:t>h.cumsum()[</a:t>
+            </a:r>
+            <a:r>
+              <a:rPr>
+                <a:solidFill>
+                  <a:srgbClr val="666666"/>
+                </a:solidFill>
+                <a:latin typeface="Courier"/>
+              </a:rPr>
+              <a:t>-</a:t>
+            </a:r>
+            <a:r>
+              <a:rPr>
+                <a:solidFill>
+                  <a:srgbClr val="40A070"/>
+                </a:solidFill>
+                <a:latin typeface="Courier"/>
+              </a:rPr>
+              <a:t>1</a:t>
+            </a:r>
+            <a:r>
+              <a:rPr>
+                <a:latin typeface="Courier"/>
+              </a:rPr>
+              <a:t>]           </a:t>
+            </a:r>
+            <a:r>
+              <a:rPr i="1">
+                <a:solidFill>
+                  <a:srgbClr val="60A0B0"/>
+                </a:solidFill>
+                <a:latin typeface="Courier"/>
+              </a:rPr>
+              <a:t># 256.0, not 1000</a:t>
+            </a:r>
+          </a:p>
+        </p:txBody>
+      </p:sp>
+    </p:spTree>
+  </p:cSld>
+</p:sld>
+</file>
+
+<file path=ppt/slides/slide32.xml><?xml version="1.0" encoding="utf-8"?>
+<p:sld xmlns:a="http://schemas.openxmlformats.org/drawingml/2006/main" xmlns:r="http://schemas.openxmlformats.org/officeDocument/2006/relationships" xmlns:p="http://schemas.openxmlformats.org/presentationml/2006/main">
+  <p:cSld>
+    <p:spTree>
+      <p:nvGrpSpPr>
+        <p:cNvPr id="1" name=""/>
+        <p:cNvGrpSpPr/>
+        <p:nvPr/>
+      </p:nvGrpSpPr>
+      <p:grpSpPr>
+        <a:xfrm>
+          <a:off x="0" y="0"/>
+          <a:ext cx="0" cy="0"/>
+          <a:chOff x="0" y="0"/>
+          <a:chExt cx="0" cy="0"/>
+        </a:xfrm>
+      </p:grpSpPr>
+      <p:sp>
+        <p:nvSpPr>
+          <p:cNvPr id="2" name="Title 1"/>
+          <p:cNvSpPr>
+            <a:spLocks noGrp="1"/>
+          </p:cNvSpPr>
+          <p:nvPr>
+            <p:ph type="title"/>
+          </p:nvPr>
+        </p:nvSpPr>
+        <p:spPr/>
+        <p:txBody>
+          <a:bodyPr>
+            <a:normAutofit/>
+          </a:bodyPr>
+          <a:lstStyle/>
+          <a:p>
+            <a:pPr lvl="0" indent="0" marL="0">
+              <a:buNone/>
+            </a:pPr>
+            <a:r>
+              <a:rPr/>
+              <a:t>Creating arrays</a:t>
+            </a:r>
+          </a:p>
+        </p:txBody>
+      </p:sp>
+      <p:sp>
+        <p:nvSpPr>
+          <p:cNvPr id="3" name="Content Placeholder 2"/>
+          <p:cNvSpPr>
+            <a:spLocks noGrp="1"/>
+          </p:cNvSpPr>
+          <p:nvPr>
+            <p:ph idx="1"/>
+          </p:nvPr>
+        </p:nvSpPr>
+        <p:spPr/>
+        <p:txBody>
+          <a:bodyPr>
+            <a:normAutofit/>
+          </a:bodyPr>
+          <a:lstStyle/>
+          <a:p>
+            <a:pPr lvl="0" indent="0">
+              <a:buNone/>
+            </a:pPr>
+            <a:r>
+              <a:rPr b="1">
+                <a:solidFill>
+                  <a:srgbClr val="008000"/>
+                </a:solidFill>
+                <a:latin typeface="Courier"/>
+              </a:rPr>
+              <a:t>import</a:t>
+            </a:r>
+            <a:r>
+              <a:rPr>
+                <a:latin typeface="Courier"/>
+              </a:rPr>
+              <a:t> numpy </a:t>
+            </a:r>
+            <a:r>
+              <a:rPr b="1">
+                <a:solidFill>
+                  <a:srgbClr val="008000"/>
+                </a:solidFill>
+                <a:latin typeface="Courier"/>
+              </a:rPr>
+              <a:t>as</a:t>
+            </a:r>
+            <a:r>
+              <a:rPr>
+                <a:latin typeface="Courier"/>
+              </a:rPr>
+              <a:t> np</a:t>
+            </a:r>
+            <a:br/>
+            <a:br/>
+            <a:r>
+              <a:rPr>
+                <a:latin typeface="Courier"/>
+              </a:rPr>
+              <a:t>np.array([</a:t>
+            </a:r>
+            <a:r>
+              <a:rPr>
+                <a:solidFill>
+                  <a:srgbClr val="40A070"/>
+                </a:solidFill>
+                <a:latin typeface="Courier"/>
+              </a:rPr>
+              <a:t>72</a:t>
+            </a:r>
+            <a:r>
+              <a:rPr>
+                <a:latin typeface="Courier"/>
+              </a:rPr>
+              <a:t>, </a:t>
+            </a:r>
+            <a:r>
+              <a:rPr>
+                <a:solidFill>
+                  <a:srgbClr val="40A070"/>
+                </a:solidFill>
+                <a:latin typeface="Courier"/>
+              </a:rPr>
+              <a:t>85</a:t>
+            </a:r>
+            <a:r>
+              <a:rPr>
+                <a:latin typeface="Courier"/>
+              </a:rPr>
+              <a:t>, </a:t>
+            </a:r>
+            <a:r>
+              <a:rPr>
+                <a:solidFill>
+                  <a:srgbClr val="40A070"/>
+                </a:solidFill>
+                <a:latin typeface="Courier"/>
+              </a:rPr>
+              <a:t>64</a:t>
+            </a:r>
+            <a:r>
+              <a:rPr>
+                <a:latin typeface="Courier"/>
+              </a:rPr>
+              <a:t>])</a:t>
+            </a:r>
+            <a:br/>
+            <a:r>
+              <a:rPr>
+                <a:latin typeface="Courier"/>
+              </a:rPr>
+              <a:t>np.arange(</a:t>
+            </a:r>
+            <a:r>
+              <a:rPr>
+                <a:solidFill>
+                  <a:srgbClr val="40A070"/>
+                </a:solidFill>
+                <a:latin typeface="Courier"/>
+              </a:rPr>
+              <a:t>12</a:t>
+            </a:r>
+            <a:r>
+              <a:rPr>
+                <a:latin typeface="Courier"/>
+              </a:rPr>
+              <a:t>).reshape(</a:t>
+            </a:r>
+            <a:r>
+              <a:rPr>
+                <a:solidFill>
+                  <a:srgbClr val="40A070"/>
+                </a:solidFill>
+                <a:latin typeface="Courier"/>
+              </a:rPr>
+              <a:t>3</a:t>
+            </a:r>
+            <a:r>
+              <a:rPr>
+                <a:latin typeface="Courier"/>
+              </a:rPr>
+              <a:t>, </a:t>
+            </a:r>
+            <a:r>
+              <a:rPr>
+                <a:solidFill>
+                  <a:srgbClr val="40A070"/>
+                </a:solidFill>
+                <a:latin typeface="Courier"/>
+              </a:rPr>
+              <a:t>4</a:t>
+            </a:r>
+            <a:r>
+              <a:rPr>
+                <a:latin typeface="Courier"/>
+              </a:rPr>
+              <a:t>)</a:t>
+            </a:r>
+            <a:br/>
+            <a:r>
+              <a:rPr>
+                <a:latin typeface="Courier"/>
+              </a:rPr>
+              <a:t>np.linspace(</a:t>
+            </a:r>
+            <a:r>
+              <a:rPr>
+                <a:solidFill>
+                  <a:srgbClr val="40A070"/>
+                </a:solidFill>
+                <a:latin typeface="Courier"/>
+              </a:rPr>
+              <a:t>0</a:t>
+            </a:r>
+            <a:r>
+              <a:rPr>
+                <a:latin typeface="Courier"/>
+              </a:rPr>
+              <a:t>, </a:t>
+            </a:r>
+            <a:r>
+              <a:rPr>
+                <a:solidFill>
+                  <a:srgbClr val="40A070"/>
+                </a:solidFill>
+                <a:latin typeface="Courier"/>
+              </a:rPr>
+              <a:t>1</a:t>
+            </a:r>
+            <a:r>
+              <a:rPr>
+                <a:latin typeface="Courier"/>
+              </a:rPr>
+              <a:t>, </a:t>
+            </a:r>
+            <a:r>
+              <a:rPr>
+                <a:solidFill>
+                  <a:srgbClr val="40A070"/>
+                </a:solidFill>
+                <a:latin typeface="Courier"/>
+              </a:rPr>
+              <a:t>5</a:t>
+            </a:r>
+            <a:r>
+              <a:rPr>
+                <a:latin typeface="Courier"/>
+              </a:rPr>
+              <a:t>)     </a:t>
+            </a:r>
+            <a:r>
+              <a:rPr i="1">
+                <a:solidFill>
+                  <a:srgbClr val="60A0B0"/>
+                </a:solidFill>
+                <a:latin typeface="Courier"/>
+              </a:rPr>
+              <a:t># 5 points</a:t>
+            </a:r>
+            <a:br/>
+            <a:r>
+              <a:rPr>
+                <a:latin typeface="Courier"/>
+              </a:rPr>
+              <a:t>np.zeros((</a:t>
+            </a:r>
+            <a:r>
+              <a:rPr>
+                <a:solidFill>
+                  <a:srgbClr val="40A070"/>
+                </a:solidFill>
+                <a:latin typeface="Courier"/>
+              </a:rPr>
+              <a:t>3</a:t>
+            </a:r>
+            <a:r>
+              <a:rPr>
+                <a:latin typeface="Courier"/>
+              </a:rPr>
+              <a:t>, </a:t>
+            </a:r>
+            <a:r>
+              <a:rPr>
+                <a:solidFill>
+                  <a:srgbClr val="40A070"/>
+                </a:solidFill>
+                <a:latin typeface="Courier"/>
+              </a:rPr>
+              <a:t>4</a:t>
+            </a:r>
+            <a:r>
+              <a:rPr>
+                <a:latin typeface="Courier"/>
+              </a:rPr>
+              <a:t>))</a:t>
+            </a:r>
+            <a:br/>
+            <a:r>
+              <a:rPr>
+                <a:latin typeface="Courier"/>
+              </a:rPr>
+              <a:t>np.eye(</a:t>
+            </a:r>
+            <a:r>
+              <a:rPr>
+                <a:solidFill>
+                  <a:srgbClr val="40A070"/>
+                </a:solidFill>
+                <a:latin typeface="Courier"/>
+              </a:rPr>
+              <a:t>4</a:t>
+            </a:r>
+            <a:r>
+              <a:rPr>
+                <a:latin typeface="Courier"/>
+              </a:rPr>
+              <a:t>)                </a:t>
+            </a:r>
+            <a:r>
+              <a:rPr i="1">
+                <a:solidFill>
+                  <a:srgbClr val="60A0B0"/>
+                </a:solidFill>
+                <a:latin typeface="Courier"/>
+              </a:rPr>
+              <a:t># identity</a:t>
+            </a:r>
+            <a:br/>
+            <a:br/>
+            <a:r>
+              <a:rPr>
+                <a:latin typeface="Courier"/>
+              </a:rPr>
+              <a:t>rng </a:t>
+            </a:r>
+            <a:r>
+              <a:rPr>
+                <a:solidFill>
+                  <a:srgbClr val="666666"/>
+                </a:solidFill>
+                <a:latin typeface="Courier"/>
+              </a:rPr>
+              <a:t>=</a:t>
+            </a:r>
+            <a:r>
+              <a:rPr>
+                <a:latin typeface="Courier"/>
+              </a:rPr>
+              <a:t> np.random.default_rng(</a:t>
+            </a:r>
+            <a:r>
+              <a:rPr>
+                <a:solidFill>
+                  <a:srgbClr val="40A070"/>
+                </a:solidFill>
+                <a:latin typeface="Courier"/>
+              </a:rPr>
+              <a:t>0</a:t>
+            </a:r>
+            <a:r>
+              <a:rPr>
+                <a:latin typeface="Courier"/>
+              </a:rPr>
+              <a:t>)</a:t>
+            </a:r>
+            <a:br/>
+            <a:r>
+              <a:rPr>
+                <a:latin typeface="Courier"/>
+              </a:rPr>
+              <a:t>rng.normal(</a:t>
+            </a:r>
+            <a:r>
+              <a:rPr>
+                <a:solidFill>
+                  <a:srgbClr val="40A070"/>
+                </a:solidFill>
+                <a:latin typeface="Courier"/>
+              </a:rPr>
+              <a:t>1.70</a:t>
+            </a:r>
+            <a:r>
+              <a:rPr>
+                <a:latin typeface="Courier"/>
+              </a:rPr>
+              <a:t>, </a:t>
+            </a:r>
+            <a:r>
+              <a:rPr>
+                <a:solidFill>
+                  <a:srgbClr val="40A070"/>
+                </a:solidFill>
+                <a:latin typeface="Courier"/>
+              </a:rPr>
+              <a:t>0.09</a:t>
+            </a:r>
+            <a:r>
+              <a:rPr>
+                <a:latin typeface="Courier"/>
+              </a:rPr>
+              <a:t>, </a:t>
+            </a:r>
+            <a:r>
+              <a:rPr>
+                <a:solidFill>
+                  <a:srgbClr val="40A070"/>
+                </a:solidFill>
+                <a:latin typeface="Courier"/>
+              </a:rPr>
+              <a:t>200</a:t>
+            </a:r>
+            <a:r>
+              <a:rPr>
+                <a:latin typeface="Courier"/>
+              </a:rPr>
+              <a:t>)</a:t>
+            </a:r>
+          </a:p>
+        </p:txBody>
+      </p:sp>
+    </p:spTree>
+  </p:cSld>
+</p:sld>
+</file>
+
+<file path=ppt/slides/slide33.xml><?xml version="1.0" encoding="utf-8"?>
+<p:sld xmlns:a="http://schemas.openxmlformats.org/drawingml/2006/main" xmlns:r="http://schemas.openxmlformats.org/officeDocument/2006/relationships" xmlns:p="http://schemas.openxmlformats.org/presentationml/2006/main">
+  <p:cSld>
+    <p:spTree>
+      <p:nvGrpSpPr>
+        <p:cNvPr id="1" name=""/>
+        <p:cNvGrpSpPr/>
+        <p:nvPr/>
+      </p:nvGrpSpPr>
+      <p:grpSpPr>
+        <a:xfrm>
+          <a:off x="0" y="0"/>
+          <a:ext cx="0" cy="0"/>
+          <a:chOff x="0" y="0"/>
+          <a:chExt cx="0" cy="0"/>
+        </a:xfrm>
+      </p:grpSpPr>
+      <p:sp>
+        <p:nvSpPr>
+          <p:cNvPr id="2" name="Title 1"/>
+          <p:cNvSpPr>
+            <a:spLocks noGrp="1"/>
+          </p:cNvSpPr>
+          <p:nvPr>
+            <p:ph type="title"/>
+          </p:nvPr>
+        </p:nvSpPr>
+        <p:spPr/>
+        <p:txBody>
+          <a:bodyPr>
+            <a:normAutofit/>
+          </a:bodyPr>
+          <a:lstStyle/>
+          <a:p>
+            <a:pPr lvl="0" indent="0" marL="0">
+              <a:buNone/>
+            </a:pPr>
+            <a:r>
+              <a:rPr/>
+              <a:t>Indexing in two dimensions</a:t>
+            </a:r>
+          </a:p>
+        </p:txBody>
+      </p:sp>
+      <p:pic>
+        <p:nvPicPr>
+          <p:cNvPr descr="img/array_index.png" id="0" name="Picture 1"/>
+          <p:cNvPicPr>
+            <a:picLocks noGrp="1" noChangeAspect="1"/>
+          </p:cNvPicPr>
+          <p:nvPr/>
+        </p:nvPicPr>
+        <p:blipFill>
+          <a:blip r:embed="rId3"/>
+          <a:stretch>
+            <a:fillRect/>
+          </a:stretch>
+        </p:blipFill>
+        <p:spPr bwMode="auto">
+          <a:xfrm>
+            <a:off x="457200" y="1193800"/>
+            <a:ext cx="8229600" cy="3390900"/>
+          </a:xfrm>
+          <a:prstGeom prst="rect">
+            <a:avLst/>
+          </a:prstGeom>
+          <a:noFill/>
+          <a:ln w="9525">
+            <a:noFill/>
+            <a:headEnd/>
+            <a:tailEnd/>
+          </a:ln>
+        </p:spPr>
+      </p:pic>
+    </p:spTree>
+  </p:cSld>
+</p:sld>
+</file>
+
+<file path=ppt/slides/slide34.xml><?xml version="1.0" encoding="utf-8"?>
+<p:sld xmlns:a="http://schemas.openxmlformats.org/drawingml/2006/main" xmlns:r="http://schemas.openxmlformats.org/officeDocument/2006/relationships" xmlns:p="http://schemas.openxmlformats.org/presentationml/2006/main">
+  <p:cSld>
+    <p:spTree>
+      <p:nvGrpSpPr>
+        <p:cNvPr id="1" name=""/>
+        <p:cNvGrpSpPr/>
+        <p:nvPr/>
+      </p:nvGrpSpPr>
+      <p:grpSpPr>
+        <a:xfrm>
+          <a:off x="0" y="0"/>
+          <a:ext cx="0" cy="0"/>
+          <a:chOff x="0" y="0"/>
+          <a:chExt cx="0" cy="0"/>
+        </a:xfrm>
+      </p:grpSpPr>
+      <p:sp>
+        <p:nvSpPr>
+          <p:cNvPr id="2" name="Title 1"/>
+          <p:cNvSpPr>
+            <a:spLocks noGrp="1"/>
+          </p:cNvSpPr>
+          <p:nvPr>
+            <p:ph type="title"/>
+          </p:nvPr>
+        </p:nvSpPr>
+        <p:spPr/>
+        <p:txBody>
+          <a:bodyPr>
+            <a:normAutofit/>
+          </a:bodyPr>
+          <a:lstStyle/>
+          <a:p>
+            <a:pPr lvl="0" indent="0" marL="0">
+              <a:buNone/>
+            </a:pPr>
+            <a:r>
+              <a:rPr/>
+              <a:t>Operations are element-wise</a:t>
+            </a:r>
+          </a:p>
+        </p:txBody>
+      </p:sp>
+      <p:sp>
+        <p:nvSpPr>
+          <p:cNvPr id="3" name="Content Placeholder 2"/>
+          <p:cNvSpPr>
+            <a:spLocks noGrp="1"/>
+          </p:cNvSpPr>
+          <p:nvPr>
+            <p:ph idx="1"/>
+          </p:nvPr>
+        </p:nvSpPr>
+        <p:spPr/>
+        <p:txBody>
+          <a:bodyPr>
+            <a:normAutofit/>
+          </a:bodyPr>
+          <a:lstStyle/>
+          <a:p>
+            <a:pPr lvl="0" indent="0">
+              <a:buNone/>
+            </a:pPr>
+            <a:r>
+              <a:rPr>
+                <a:latin typeface="Courier"/>
+              </a:rPr>
+              <a:t>x </a:t>
+            </a:r>
+            <a:r>
+              <a:rPr>
+                <a:solidFill>
+                  <a:srgbClr val="666666"/>
+                </a:solidFill>
+                <a:latin typeface="Courier"/>
+              </a:rPr>
+              <a:t>=</a:t>
+            </a:r>
+            <a:r>
+              <a:rPr>
+                <a:latin typeface="Courier"/>
+              </a:rPr>
+              <a:t> np.arange(</a:t>
+            </a:r>
+            <a:r>
+              <a:rPr>
+                <a:solidFill>
+                  <a:srgbClr val="40A070"/>
+                </a:solidFill>
+                <a:latin typeface="Courier"/>
+              </a:rPr>
+              <a:t>5</a:t>
+            </a:r>
+            <a:r>
+              <a:rPr>
+                <a:latin typeface="Courier"/>
+              </a:rPr>
+              <a:t>)   </a:t>
+            </a:r>
+            <a:r>
+              <a:rPr i="1">
+                <a:solidFill>
+                  <a:srgbClr val="60A0B0"/>
+                </a:solidFill>
+                <a:latin typeface="Courier"/>
+              </a:rPr>
+              <a:t># [0 1 2 3 4]</a:t>
+            </a:r>
+            <a:br/>
+            <a:br/>
+            <a:r>
+              <a:rPr>
+                <a:latin typeface="Courier"/>
+              </a:rPr>
+              <a:t>x </a:t>
+            </a:r>
+            <a:r>
+              <a:rPr>
+                <a:solidFill>
+                  <a:srgbClr val="666666"/>
+                </a:solidFill>
+                <a:latin typeface="Courier"/>
+              </a:rPr>
+              <a:t>**</a:t>
+            </a:r>
+            <a:r>
+              <a:rPr>
+                <a:latin typeface="Courier"/>
+              </a:rPr>
+              <a:t> </a:t>
+            </a:r>
+            <a:r>
+              <a:rPr>
+                <a:solidFill>
+                  <a:srgbClr val="40A070"/>
+                </a:solidFill>
+                <a:latin typeface="Courier"/>
+              </a:rPr>
+              <a:t>2</a:t>
+            </a:r>
+            <a:r>
+              <a:rPr>
+                <a:latin typeface="Courier"/>
+              </a:rPr>
+              <a:t>             </a:t>
+            </a:r>
+            <a:r>
+              <a:rPr i="1">
+                <a:solidFill>
+                  <a:srgbClr val="60A0B0"/>
+                </a:solidFill>
+                <a:latin typeface="Courier"/>
+              </a:rPr>
+              <a:t># [0 1 4 9 16]</a:t>
+            </a:r>
+            <a:br/>
+            <a:r>
+              <a:rPr>
+                <a:latin typeface="Courier"/>
+              </a:rPr>
+              <a:t>x </a:t>
+            </a:r>
+            <a:r>
+              <a:rPr>
+                <a:solidFill>
+                  <a:srgbClr val="666666"/>
+                </a:solidFill>
+                <a:latin typeface="Courier"/>
+              </a:rPr>
+              <a:t>+</a:t>
+            </a:r>
+            <a:r>
+              <a:rPr>
+                <a:latin typeface="Courier"/>
+              </a:rPr>
+              <a:t> </a:t>
+            </a:r>
+            <a:r>
+              <a:rPr>
+                <a:solidFill>
+                  <a:srgbClr val="40A070"/>
+                </a:solidFill>
+                <a:latin typeface="Courier"/>
+              </a:rPr>
+              <a:t>10</a:t>
+            </a:r>
+            <a:r>
+              <a:rPr>
+                <a:latin typeface="Courier"/>
+              </a:rPr>
+              <a:t>             </a:t>
+            </a:r>
+            <a:r>
+              <a:rPr i="1">
+                <a:solidFill>
+                  <a:srgbClr val="60A0B0"/>
+                </a:solidFill>
+                <a:latin typeface="Courier"/>
+              </a:rPr>
+              <a:t># [10 11 12 13 14]</a:t>
+            </a:r>
+            <a:br/>
+            <a:r>
+              <a:rPr>
+                <a:latin typeface="Courier"/>
+              </a:rPr>
+              <a:t>np.sqrt(x)         </a:t>
+            </a:r>
+            <a:r>
+              <a:rPr i="1">
+                <a:solidFill>
+                  <a:srgbClr val="60A0B0"/>
+                </a:solidFill>
+                <a:latin typeface="Courier"/>
+              </a:rPr>
+              <a:t># no loop</a:t>
+            </a:r>
+            <a:br/>
+            <a:br/>
+            <a:r>
+              <a:rPr>
+                <a:latin typeface="Courier"/>
+              </a:rPr>
+              <a:t>t </a:t>
+            </a:r>
+            <a:r>
+              <a:rPr>
+                <a:solidFill>
+                  <a:srgbClr val="666666"/>
+                </a:solidFill>
+                <a:latin typeface="Courier"/>
+              </a:rPr>
+              <a:t>*</a:t>
+            </a:r>
+            <a:r>
+              <a:rPr>
+                <a:latin typeface="Courier"/>
+              </a:rPr>
+              <a:t> t              </a:t>
+            </a:r>
+            <a:r>
+              <a:rPr i="1">
+                <a:solidFill>
+                  <a:srgbClr val="60A0B0"/>
+                </a:solidFill>
+                <a:latin typeface="Courier"/>
+              </a:rPr>
+              <a:t># element-wise</a:t>
+            </a:r>
+            <a:br/>
+            <a:r>
+              <a:rPr>
+                <a:latin typeface="Courier"/>
+              </a:rPr>
+              <a:t>t </a:t>
+            </a:r>
+            <a:r>
+              <a:rPr>
+                <a:solidFill>
+                  <a:srgbClr val="666666"/>
+                </a:solidFill>
+                <a:latin typeface="Courier"/>
+              </a:rPr>
+              <a:t>@</a:t>
+            </a:r>
+            <a:r>
+              <a:rPr>
+                <a:latin typeface="Courier"/>
+              </a:rPr>
+              <a:t> t.T            </a:t>
+            </a:r>
+            <a:r>
+              <a:rPr i="1">
+                <a:solidFill>
+                  <a:srgbClr val="60A0B0"/>
+                </a:solidFill>
+                <a:latin typeface="Courier"/>
+              </a:rPr>
+              <a:t># matrix product</a:t>
+            </a:r>
+          </a:p>
+        </p:txBody>
+      </p:sp>
+    </p:spTree>
+  </p:cSld>
+</p:sld>
+</file>
+
+<file path=ppt/slides/slide35.xml><?xml version="1.0" encoding="utf-8"?>
+<p:sld xmlns:a="http://schemas.openxmlformats.org/drawingml/2006/main" xmlns:r="http://schemas.openxmlformats.org/officeDocument/2006/relationships" xmlns:p="http://schemas.openxmlformats.org/presentationml/2006/main">
+  <p:cSld>
+    <p:spTree>
+      <p:nvGrpSpPr>
+        <p:cNvPr id="1" name=""/>
+        <p:cNvGrpSpPr/>
+        <p:nvPr/>
+      </p:nvGrpSpPr>
+      <p:grpSpPr>
+        <a:xfrm>
+          <a:off x="0" y="0"/>
+          <a:ext cx="0" cy="0"/>
+          <a:chOff x="0" y="0"/>
+          <a:chExt cx="0" cy="0"/>
+        </a:xfrm>
+      </p:grpSpPr>
+      <p:sp>
+        <p:nvSpPr>
+          <p:cNvPr id="2" name="Title 1"/>
+          <p:cNvSpPr>
+            <a:spLocks noGrp="1"/>
+          </p:cNvSpPr>
+          <p:nvPr>
+            <p:ph type="title"/>
+          </p:nvPr>
+        </p:nvSpPr>
+        <p:spPr/>
+        <p:txBody>
+          <a:bodyPr>
+            <a:normAutofit/>
+          </a:bodyPr>
+          <a:lstStyle/>
+          <a:p>
+            <a:pPr lvl="0" indent="0" marL="0">
+              <a:buNone/>
+            </a:pPr>
+            <a:r>
+              <a:rPr/>
+              <a:t>Broadcasting</a:t>
+            </a:r>
+          </a:p>
+        </p:txBody>
+      </p:sp>
+      <p:pic>
+        <p:nvPicPr>
+          <p:cNvPr descr="img/broadcasting.png" id="0" name="Picture 1"/>
+          <p:cNvPicPr>
+            <a:picLocks noGrp="1" noChangeAspect="1"/>
+          </p:cNvPicPr>
+          <p:nvPr/>
+        </p:nvPicPr>
+        <p:blipFill>
+          <a:blip r:embed="rId3"/>
+          <a:stretch>
+            <a:fillRect/>
+          </a:stretch>
+        </p:blipFill>
+        <p:spPr bwMode="auto">
+          <a:xfrm>
+            <a:off x="457200" y="1193800"/>
+            <a:ext cx="8229600" cy="3390900"/>
+          </a:xfrm>
+          <a:prstGeom prst="rect">
+            <a:avLst/>
+          </a:prstGeom>
+          <a:noFill/>
+          <a:ln w="9525">
+            <a:noFill/>
+            <a:headEnd/>
+            <a:tailEnd/>
+          </a:ln>
+        </p:spPr>
+      </p:pic>
+    </p:spTree>
+  </p:cSld>
+</p:sld>
+</file>
+
+<file path=ppt/slides/slide36.xml><?xml version="1.0" encoding="utf-8"?>
+<p:sld xmlns:a="http://schemas.openxmlformats.org/drawingml/2006/main" xmlns:r="http://schemas.openxmlformats.org/officeDocument/2006/relationships" xmlns:p="http://schemas.openxmlformats.org/presentationml/2006/main">
+  <p:cSld>
+    <p:spTree>
+      <p:nvGrpSpPr>
+        <p:cNvPr id="1" name=""/>
+        <p:cNvGrpSpPr/>
+        <p:nvPr/>
+      </p:nvGrpSpPr>
+      <p:grpSpPr>
+        <a:xfrm>
+          <a:off x="0" y="0"/>
+          <a:ext cx="0" cy="0"/>
+          <a:chOff x="0" y="0"/>
+          <a:chExt cx="0" cy="0"/>
+        </a:xfrm>
+      </p:grpSpPr>
+      <p:sp>
+        <p:nvSpPr>
+          <p:cNvPr id="2" name="Title 1"/>
+          <p:cNvSpPr>
+            <a:spLocks noGrp="1"/>
+          </p:cNvSpPr>
+          <p:nvPr>
+            <p:ph type="title"/>
+          </p:nvPr>
+        </p:nvSpPr>
+        <p:spPr/>
+        <p:txBody>
+          <a:bodyPr>
+            <a:normAutofit/>
+          </a:bodyPr>
+          <a:lstStyle/>
+          <a:p>
+            <a:pPr lvl="0" indent="0" marL="0">
+              <a:buNone/>
+            </a:pPr>
+            <a:r>
+              <a:rPr/>
               <a:t>Aggregating along an axis</a:t>
             </a:r>
           </a:p>
@@ -11264,7 +13363,7 @@
 </p:sld>
 </file>
 
-<file path=ppt/slides/slide32.xml><?xml version="1.0" encoding="utf-8"?>
+<file path=ppt/slides/slide37.xml><?xml version="1.0" encoding="utf-8"?>
 <p:sld xmlns:a="http://schemas.openxmlformats.org/drawingml/2006/main" xmlns:r="http://schemas.openxmlformats.org/officeDocument/2006/relationships" xmlns:p="http://schemas.openxmlformats.org/presentationml/2006/main">
   <p:cSld>
     <p:spTree>
@@ -11343,7 +13442,7 @@
 </p:sld>
 </file>
 
-<file path=ppt/slides/slide33.xml><?xml version="1.0" encoding="utf-8"?>
+<file path=ppt/slides/slide38.xml><?xml version="1.0" encoding="utf-8"?>
 <p:sld xmlns:a="http://schemas.openxmlformats.org/drawingml/2006/main" xmlns:r="http://schemas.openxmlformats.org/officeDocument/2006/relationships" xmlns:p="http://schemas.openxmlformats.org/presentationml/2006/main">
   <p:cSld>
     <p:spTree>
@@ -11658,7 +13757,7 @@
 </p:sld>
 </file>
 
-<file path=ppt/slides/slide34.xml><?xml version="1.0" encoding="utf-8"?>
+<file path=ppt/slides/slide39.xml><?xml version="1.0" encoding="utf-8"?>
 <p:sld xmlns:a="http://schemas.openxmlformats.org/drawingml/2006/main" xmlns:r="http://schemas.openxmlformats.org/officeDocument/2006/relationships" xmlns:p="http://schemas.openxmlformats.org/presentationml/2006/main">
   <p:cSld>
     <p:spTree>

</xml_diff>